<commit_message>
Finalize presentation-ready MarketPilot release
</commit_message>
<xml_diff>
--- a/docs/presentation/output/MarketPilot-Final-Presentation.pptx
+++ b/docs/presentation/output/MarketPilot-Final-Presentation.pptx
@@ -2,24 +2,24 @@
 <file path=ppt/presentation.xml><?xml version="1.0" encoding="utf-8"?>
 <p:presentation xmlns:p="http://schemas.openxmlformats.org/presentationml/2006/main">
   <p:sldMasterIdLst>
-    <p:sldMasterId xmlns:r="http://schemas.openxmlformats.org/officeDocument/2006/relationships" id="2147483648" r:id="R32cbeb1b3a8e4a56"/>
+    <p:sldMasterId xmlns:r="http://schemas.openxmlformats.org/officeDocument/2006/relationships" id="2147483648" r:id="R58745ad16d224847"/>
   </p:sldMasterIdLst>
   <p:notesMasterIdLst>
-    <p:notesMasterId xmlns:r="http://schemas.openxmlformats.org/officeDocument/2006/relationships" r:id="R49e36cb876c641cc"/>
+    <p:notesMasterId xmlns:r="http://schemas.openxmlformats.org/officeDocument/2006/relationships" r:id="Rce7451200ee545c7"/>
   </p:notesMasterIdLst>
   <p:sldIdLst>
-    <p:sldId xmlns:r="http://schemas.openxmlformats.org/officeDocument/2006/relationships" id="256" r:id="R74322b50d87248a3"/>
-    <p:sldId xmlns:r="http://schemas.openxmlformats.org/officeDocument/2006/relationships" id="257" r:id="Ra5bf75a3d2894b28"/>
-    <p:sldId xmlns:r="http://schemas.openxmlformats.org/officeDocument/2006/relationships" id="258" r:id="Re6f7bf7699014bda"/>
-    <p:sldId xmlns:r="http://schemas.openxmlformats.org/officeDocument/2006/relationships" id="259" r:id="Rcffca07e28de4b6d"/>
-    <p:sldId xmlns:r="http://schemas.openxmlformats.org/officeDocument/2006/relationships" id="260" r:id="R896e66ef92cb4c66"/>
-    <p:sldId xmlns:r="http://schemas.openxmlformats.org/officeDocument/2006/relationships" id="261" r:id="R0e690e7f3f1948ae"/>
-    <p:sldId xmlns:r="http://schemas.openxmlformats.org/officeDocument/2006/relationships" id="262" r:id="R8c896fff0bbe4af6"/>
-    <p:sldId xmlns:r="http://schemas.openxmlformats.org/officeDocument/2006/relationships" id="263" r:id="R25106fb8d9014b31"/>
-    <p:sldId xmlns:r="http://schemas.openxmlformats.org/officeDocument/2006/relationships" id="264" r:id="R4c8550f7b53547f1"/>
-    <p:sldId xmlns:r="http://schemas.openxmlformats.org/officeDocument/2006/relationships" id="265" r:id="Rc2a0c63c153340d0"/>
-    <p:sldId xmlns:r="http://schemas.openxmlformats.org/officeDocument/2006/relationships" id="266" r:id="Rdcdf351b4a004602"/>
-    <p:sldId xmlns:r="http://schemas.openxmlformats.org/officeDocument/2006/relationships" id="267" r:id="Rb806d7657c76484b"/>
+    <p:sldId xmlns:r="http://schemas.openxmlformats.org/officeDocument/2006/relationships" id="256" r:id="Re91c90276f3e4de8"/>
+    <p:sldId xmlns:r="http://schemas.openxmlformats.org/officeDocument/2006/relationships" id="257" r:id="R7e67d3afed0346fa"/>
+    <p:sldId xmlns:r="http://schemas.openxmlformats.org/officeDocument/2006/relationships" id="258" r:id="R2bda899deb824076"/>
+    <p:sldId xmlns:r="http://schemas.openxmlformats.org/officeDocument/2006/relationships" id="259" r:id="Re1ee10bf4f3542ff"/>
+    <p:sldId xmlns:r="http://schemas.openxmlformats.org/officeDocument/2006/relationships" id="260" r:id="Rab9235e560354f45"/>
+    <p:sldId xmlns:r="http://schemas.openxmlformats.org/officeDocument/2006/relationships" id="261" r:id="Rfbcfd43af2dd445d"/>
+    <p:sldId xmlns:r="http://schemas.openxmlformats.org/officeDocument/2006/relationships" id="262" r:id="R9e4e58a5e95f4d2f"/>
+    <p:sldId xmlns:r="http://schemas.openxmlformats.org/officeDocument/2006/relationships" id="263" r:id="R4ba006f0d6f645aa"/>
+    <p:sldId xmlns:r="http://schemas.openxmlformats.org/officeDocument/2006/relationships" id="264" r:id="R7a5b81a0e2634213"/>
+    <p:sldId xmlns:r="http://schemas.openxmlformats.org/officeDocument/2006/relationships" id="265" r:id="Rf64f5ed48e4b4af9"/>
+    <p:sldId xmlns:r="http://schemas.openxmlformats.org/officeDocument/2006/relationships" id="266" r:id="R130fb550f138468a"/>
+    <p:sldId xmlns:r="http://schemas.openxmlformats.org/officeDocument/2006/relationships" id="267" r:id="R3559e71f61f7408e"/>
   </p:sldIdLst>
   <p:sldSz cx="12192000" cy="6858000"/>
   <p:notesSz cx="6858000" cy="9144000"/>
@@ -651,7 +651,7 @@
           <a:p xmlns:a="http://schemas.openxmlformats.org/drawingml/2006/main">
             <a:pPr algn="r" rtl="1"/>
             <a:r>
-              <a:t>הפרד בבירור בין קיים לעתידי. היום יש פלטפורמה מקומית מלאה, מסלולי Live ו-Certified, היסטוריה מאושרת ומוצר Web. לפני שהמלצה תהפוך ל-Decision Support פעיל נדרשים 20 ימי Shadow Mode, בדיקת Calibration ואישור אנושי מתועד. בהמשך אפשר להוסיף SIP, מעבר ל-S3, Observability ואבטחת Production. אל תציג אותם כאילו כבר מומשו.</a:t>
+              <a:t>הפרד בבירור בין קיים לעתידי. היום יש פלטפורמה מקומית מלאה, 53 ימי היסטוריה מאושרים, v1 Rules ו-Shadow Mode של 2/20. תשתית v2 קיימת אך נמצאת ב-FALLBACK כי אין עדיין 24 חודשי נתונים ומדגם של 300 כניסות. לאחר אימון נדרש Walk-Forward, כיול, 20 ימי Shadow חדשים ואישור אנושי. רק אחר כך יש מקום ל-SIP, S3 ואבטחת Production.</a:t>
             </a:r>
           </a:p>
           <a:p xmlns:a="http://schemas.openxmlformats.org/drawingml/2006/main">
@@ -662,7 +662,7 @@
           <a:p xmlns:a="http://schemas.openxmlformats.org/drawingml/2006/main">
             <a:pPr algn="r" rtl="1"/>
             <a:r>
-              <a:t>מקור ואימות: docs/implementation-plan.md; docs/phase14-verification.md</a:t>
+              <a:t>מקור ואימות: docs/implementation-plan.md; docs/decisions/ADR-009-hybrid-decision-intelligence.md</a:t>
             </a:r>
           </a:p>
         </p:txBody>
@@ -755,7 +755,7 @@
           <a:p xmlns:a="http://schemas.openxmlformats.org/drawingml/2006/main">
             <a:pPr algn="r" rtl="1"/>
             <a:r>
-              <a:t>מקור ואימות: docs/presentation/live-demo-script-he.md; scripts/demo-preflight.ps1</a:t>
+              <a:t>מקור ואימות: docs/presentation/demo-day-step-by-step-he.md; scripts/demo-preflight.ps1</a:t>
             </a:r>
           </a:p>
         </p:txBody>
@@ -1023,7 +1023,7 @@
           <a:p xmlns:a="http://schemas.openxmlformats.org/drawingml/2006/main">
             <a:pPr algn="r" rtl="1"/>
             <a:r>
-              <a:t>פתח במשפט: זהו אותו נתון בשלוש רמות של אמון. עקוב אחר השורה העליונה מימין לשמאל: Alpaca ו-SEC הם המקורות, Python מאחד אותם לחוזים ברורים, Kafka מפריד בין היצרן לצרכנים, Spark מעבד, ו-MariaDB Gold מגיש את התוצאה ל-API ול-Web. אחר כך עבור למסלול התחתון: Kafka נשמר גם ב-Bronze, Spark Batch מנקה ל-Silver, ורק אחרי בדיקות מפרסם Gold מאושר. Airflow מתזמן את העבודות התחומות במסלול הזה. הוא אינו מפעיל את שירות ה-Streaming. סיים בגבול האבטחה: הדפדפן מתקשר רק עם ה-API.</a:t>
+              <a:t>פתח במשפט: כל מסלול עונה על צורך אחר. עקוב אחר השורה העליונה מימין לשמאל: Alpaca הוא מקור השוק, Python מאחד את הנתונים לחוזה, Kafka מפריד בין היצרן לצרכנים, Spark מעבד, ו-MariaDB Gold מגיש את התוצאה ל-API ול-Web. במקביל Kafka נשמר ב-Bronze, Spark Batch מנקה ל-Silver, ורק אחרי בדיקות מפרסם Gold מאושר. SEC ו-Corporate Actions נכנסים בעבודות תחומות ומוסיפים הקשר פונדמנטלי. מעל Gold יושבים כללי v1 ושכבת v2 המוגנת. Airflow מתזמן עבודות תחומות בלבד; הדפדפן מתקשר רק עם ה-API.</a:t>
             </a:r>
           </a:p>
           <a:p xmlns:a="http://schemas.openxmlformats.org/drawingml/2006/main">
@@ -1395,7 +1395,7 @@
           <a:p xmlns:a="http://schemas.openxmlformats.org/drawingml/2006/main">
             <a:pPr algn="r" rtl="1"/>
             <a:r>
-              <a:t>פתח כך: המלצה בלי נקודת ביטול ובלי גודל פוזיציה היא רק דעה. MarketPilot מציגה תרחיש שלם: Buy Zone, Stop, שני יעדים, יחס Risk/Reward וגודל פוזיציה שמכבד את מגבלות התיק. אחר כך הסבר את הגבול: Shadow Mode עדיין אוסף ראיות חיות ולכן הפלט אינו Actionable. ההיסטוריה משמשת למחקר ולבדיקה, אך אינה מזייפת זמן אמיתי.</a:t>
+              <a:t>פתח כך: המלצה בלי נקודת ביטול ובלי גודל פוזיציה היא רק דעה. המסך מפריד בין Rule Score, שמסכם ראיות לפי כללים שקופים; Data Confidence, שמודד איכות וטריות; ו-Model Probability, שתופיע רק לאחר אימון וכיול. כרגע v1 מחשב Buy Zone, Stop, Targets ו-Risk/Reward. Shadow Mode עומד על 2/20 ו-v2 נמצא ב-FALLBACK, ולכן המערכת אינה מציגה הסתברות לא מוכחת. זהו מנגנון בטיחות, לא חוסר שמסתירים.</a:t>
             </a:r>
           </a:p>
           <a:p xmlns:a="http://schemas.openxmlformats.org/drawingml/2006/main">
@@ -1406,7 +1406,7 @@
           <a:p xmlns:a="http://schemas.openxmlformats.org/drawingml/2006/main">
             <a:pPr algn="r" rtl="1"/>
             <a:r>
-              <a:t>מקור ואימות: docs/phase14-verification.md; docs/decisions/ADR-008-decision-intelligence.md</a:t>
+              <a:t>מקור ואימות: docs/decisions/ADR-008-decision-intelligence.md; docs/decisions/ADR-009-hybrid-decision-intelligence.md</a:t>
             </a:r>
           </a:p>
         </p:txBody>
@@ -1499,7 +1499,7 @@
           <a:p xmlns:a="http://schemas.openxmlformats.org/drawingml/2006/main">
             <a:pPr algn="r" rtl="1"/>
             <a:r>
-              <a:t>מקור ואימות: docs/phase14-historical-evidence-verification.md; docs/decisions/ADR-005-historical-backtesting.md</a:t>
+              <a:t>מקור ואימות: docs/architecture/architecture.md; docs/decisions/ADR-005-historical-backtesting.md</a:t>
             </a:r>
           </a:p>
         </p:txBody>
@@ -1567,7 +1567,7 @@
   </p:cSld>
   <p:clrMap bg1="lt1" tx1="dk1" bg2="lt2" tx2="dk2" accent1="accent1" accent2="accent2" accent3="accent3" accent4="accent4" accent5="accent5" accent6="accent6" hlink="hlink" folHlink="folHlink"/>
   <p:sldLayoutIdLst>
-    <p:sldLayoutId xmlns:r="http://schemas.openxmlformats.org/officeDocument/2006/relationships" id="2147483649" r:id="Rbffd8c17930c4f3c"/>
+    <p:sldLayoutId xmlns:r="http://schemas.openxmlformats.org/officeDocument/2006/relationships" id="2147483649" r:id="R3c694d5991924dca"/>
   </p:sldLayoutIdLst>
   <p:txStyles>
     <p:titleStyle>
@@ -2118,7 +2118,7 @@
           <p:cNvPr id="17" name="">
             <a:extLst xmlns:a="http://schemas.openxmlformats.org/drawingml/2006/main">
               <a:ext uri="{FF2B5EF4-FFF2-40B4-BE49-F238E27FC236}">
-                <a16:creationId xmlns:a16="http://schemas.microsoft.com/office/drawing/2014/main" id="{92B43036-F20D-43C5-82EA-61048032585C}"/>
+                <a16:creationId xmlns:a16="http://schemas.microsoft.com/office/drawing/2014/main" id="{DB055C5A-FF5B-4D5A-9423-36EB8B37F392}"/>
               </a:ext>
             </a:extLst>
           </p:cNvPr>
@@ -2148,7 +2148,7 @@
           <p:cNvPr id="2" name="">
             <a:extLst xmlns:a="http://schemas.openxmlformats.org/drawingml/2006/main">
               <a:ext uri="{FF2B5EF4-FFF2-40B4-BE49-F238E27FC236}">
-                <a16:creationId xmlns:a16="http://schemas.microsoft.com/office/drawing/2014/main" id="{206063D9-618D-4016-BFE2-DE4E6F6053CC}"/>
+                <a16:creationId xmlns:a16="http://schemas.microsoft.com/office/drawing/2014/main" id="{01197D7E-A5CE-453C-831A-D769F06AEC99}"/>
               </a:ext>
             </a:extLst>
           </p:cNvPr>
@@ -2209,7 +2209,7 @@
           <p:cNvPr id="3" name="">
             <a:extLst xmlns:a="http://schemas.openxmlformats.org/drawingml/2006/main">
               <a:ext uri="{FF2B5EF4-FFF2-40B4-BE49-F238E27FC236}">
-                <a16:creationId xmlns:a16="http://schemas.microsoft.com/office/drawing/2014/main" id="{FB7312EB-653B-4FF9-A658-340A37DA92D7}"/>
+                <a16:creationId xmlns:a16="http://schemas.microsoft.com/office/drawing/2014/main" id="{4A8F7B66-34A1-4BF0-BBD3-BF3148887476}"/>
               </a:ext>
             </a:extLst>
           </p:cNvPr>
@@ -2324,7 +2324,7 @@
           <p:cNvPr id="4" name="">
             <a:extLst xmlns:a="http://schemas.openxmlformats.org/drawingml/2006/main">
               <a:ext uri="{FF2B5EF4-FFF2-40B4-BE49-F238E27FC236}">
-                <a16:creationId xmlns:a16="http://schemas.microsoft.com/office/drawing/2014/main" id="{88048776-0BDA-4755-B7ED-2D53C35B9ADC}"/>
+                <a16:creationId xmlns:a16="http://schemas.microsoft.com/office/drawing/2014/main" id="{2C5E4415-0CC0-45A4-8E34-D122A23DE2AB}"/>
               </a:ext>
             </a:extLst>
           </p:cNvPr>
@@ -2439,7 +2439,7 @@
           <p:cNvPr id="5" name="">
             <a:extLst xmlns:a="http://schemas.openxmlformats.org/drawingml/2006/main">
               <a:ext uri="{FF2B5EF4-FFF2-40B4-BE49-F238E27FC236}">
-                <a16:creationId xmlns:a16="http://schemas.microsoft.com/office/drawing/2014/main" id="{818EE91A-60CC-4809-82B6-1F312731420B}"/>
+                <a16:creationId xmlns:a16="http://schemas.microsoft.com/office/drawing/2014/main" id="{7D18F918-5EB2-47BE-AC80-E37626533D6B}"/>
               </a:ext>
             </a:extLst>
           </p:cNvPr>
@@ -2500,7 +2500,7 @@
           <p:cNvPr id="6" name="">
             <a:extLst xmlns:a="http://schemas.openxmlformats.org/drawingml/2006/main">
               <a:ext uri="{FF2B5EF4-FFF2-40B4-BE49-F238E27FC236}">
-                <a16:creationId xmlns:a16="http://schemas.microsoft.com/office/drawing/2014/main" id="{7F1A8791-85AD-440F-8CC0-7D5B70647DF4}"/>
+                <a16:creationId xmlns:a16="http://schemas.microsoft.com/office/drawing/2014/main" id="{6BCFBD24-23FB-4376-84E9-E7CFFC8A0825}"/>
               </a:ext>
             </a:extLst>
           </p:cNvPr>
@@ -2561,7 +2561,7 @@
           <p:cNvPr id="7" name="">
             <a:extLst xmlns:a="http://schemas.openxmlformats.org/drawingml/2006/main">
               <a:ext uri="{FF2B5EF4-FFF2-40B4-BE49-F238E27FC236}">
-                <a16:creationId xmlns:a16="http://schemas.microsoft.com/office/drawing/2014/main" id="{DB3FD99F-C271-4ED8-A7AC-80965D9735AE}"/>
+                <a16:creationId xmlns:a16="http://schemas.microsoft.com/office/drawing/2014/main" id="{FDE02050-0C3B-47A7-BCC7-4F5B938CA2AB}"/>
               </a:ext>
             </a:extLst>
           </p:cNvPr>
@@ -2622,7 +2622,7 @@
           <p:cNvPr id="8" name="">
             <a:extLst xmlns:a="http://schemas.openxmlformats.org/drawingml/2006/main">
               <a:ext uri="{FF2B5EF4-FFF2-40B4-BE49-F238E27FC236}">
-                <a16:creationId xmlns:a16="http://schemas.microsoft.com/office/drawing/2014/main" id="{BA469849-2025-4505-A609-00E120B03B1F}"/>
+                <a16:creationId xmlns:a16="http://schemas.microsoft.com/office/drawing/2014/main" id="{66254A54-ACA6-4E2B-84E9-D07B519A0600}"/>
               </a:ext>
             </a:extLst>
           </p:cNvPr>
@@ -2653,7 +2653,7 @@
           <p:cNvPr id="9" name="">
             <a:extLst xmlns:a="http://schemas.openxmlformats.org/drawingml/2006/main">
               <a:ext uri="{FF2B5EF4-FFF2-40B4-BE49-F238E27FC236}">
-                <a16:creationId xmlns:a16="http://schemas.microsoft.com/office/drawing/2014/main" id="{A053266F-7969-4992-9F8A-A1ADCE96DD34}"/>
+                <a16:creationId xmlns:a16="http://schemas.microsoft.com/office/drawing/2014/main" id="{06B20F59-1D0A-4BB5-ABCF-5AC4ED500E9F}"/>
               </a:ext>
             </a:extLst>
           </p:cNvPr>
@@ -2714,7 +2714,7 @@
           <p:cNvPr id="10" name="">
             <a:extLst xmlns:a="http://schemas.openxmlformats.org/drawingml/2006/main">
               <a:ext uri="{FF2B5EF4-FFF2-40B4-BE49-F238E27FC236}">
-                <a16:creationId xmlns:a16="http://schemas.microsoft.com/office/drawing/2014/main" id="{9F7152AB-DBF0-4D9A-90EF-9EFF64867112}"/>
+                <a16:creationId xmlns:a16="http://schemas.microsoft.com/office/drawing/2014/main" id="{8F5C1467-1DC2-43AC-98E4-C093E6D99601}"/>
               </a:ext>
             </a:extLst>
           </p:cNvPr>
@@ -2775,7 +2775,7 @@
           <p:cNvPr id="11" name="">
             <a:extLst xmlns:a="http://schemas.openxmlformats.org/drawingml/2006/main">
               <a:ext uri="{FF2B5EF4-FFF2-40B4-BE49-F238E27FC236}">
-                <a16:creationId xmlns:a16="http://schemas.microsoft.com/office/drawing/2014/main" id="{B5E150DE-7691-44A0-9B95-FB77045C9215}"/>
+                <a16:creationId xmlns:a16="http://schemas.microsoft.com/office/drawing/2014/main" id="{0C52351E-6728-421F-930B-79E98B086A45}"/>
               </a:ext>
             </a:extLst>
           </p:cNvPr>
@@ -2836,7 +2836,7 @@
           <p:cNvPr id="12" name="">
             <a:extLst xmlns:a="http://schemas.openxmlformats.org/drawingml/2006/main">
               <a:ext uri="{FF2B5EF4-FFF2-40B4-BE49-F238E27FC236}">
-                <a16:creationId xmlns:a16="http://schemas.microsoft.com/office/drawing/2014/main" id="{F98C9B21-60CD-4F69-9531-2567E1396E0A}"/>
+                <a16:creationId xmlns:a16="http://schemas.microsoft.com/office/drawing/2014/main" id="{4889C63A-231F-48E8-9C66-DF51E0158265}"/>
               </a:ext>
             </a:extLst>
           </p:cNvPr>
@@ -2867,7 +2867,7 @@
           <p:cNvPr id="13" name="">
             <a:extLst xmlns:a="http://schemas.openxmlformats.org/drawingml/2006/main">
               <a:ext uri="{FF2B5EF4-FFF2-40B4-BE49-F238E27FC236}">
-                <a16:creationId xmlns:a16="http://schemas.microsoft.com/office/drawing/2014/main" id="{A327B804-1C99-4272-8CAE-1E9D0A786DD8}"/>
+                <a16:creationId xmlns:a16="http://schemas.microsoft.com/office/drawing/2014/main" id="{64B1EF7C-223F-43D1-B51D-B313AB856391}"/>
               </a:ext>
             </a:extLst>
           </p:cNvPr>
@@ -2928,7 +2928,7 @@
           <p:cNvPr id="14" name="">
             <a:extLst xmlns:a="http://schemas.openxmlformats.org/drawingml/2006/main">
               <a:ext uri="{FF2B5EF4-FFF2-40B4-BE49-F238E27FC236}">
-                <a16:creationId xmlns:a16="http://schemas.microsoft.com/office/drawing/2014/main" id="{B1B90BCD-6FC6-42EA-A78D-30C9289E67FD}"/>
+                <a16:creationId xmlns:a16="http://schemas.microsoft.com/office/drawing/2014/main" id="{AA134EEA-3F1F-48CA-AF00-675BE9314462}"/>
               </a:ext>
             </a:extLst>
           </p:cNvPr>
@@ -2989,7 +2989,7 @@
           <p:cNvPr id="15" name="">
             <a:extLst xmlns:a="http://schemas.openxmlformats.org/drawingml/2006/main">
               <a:ext uri="{FF2B5EF4-FFF2-40B4-BE49-F238E27FC236}">
-                <a16:creationId xmlns:a16="http://schemas.microsoft.com/office/drawing/2014/main" id="{0A2B282C-0501-44BD-8885-5166683AE4B2}"/>
+                <a16:creationId xmlns:a16="http://schemas.microsoft.com/office/drawing/2014/main" id="{E4152517-98BB-4794-B56B-948C91221054}"/>
               </a:ext>
             </a:extLst>
           </p:cNvPr>
@@ -3050,7 +3050,7 @@
           <p:cNvPr id="16" name="">
             <a:extLst xmlns:a="http://schemas.openxmlformats.org/drawingml/2006/main">
               <a:ext uri="{FF2B5EF4-FFF2-40B4-BE49-F238E27FC236}">
-                <a16:creationId xmlns:a16="http://schemas.microsoft.com/office/drawing/2014/main" id="{5F69BCD1-D6C9-481F-8ACB-238129195BB1}"/>
+                <a16:creationId xmlns:a16="http://schemas.microsoft.com/office/drawing/2014/main" id="{1874E966-DB6B-4FBA-8027-57C2135F5056}"/>
               </a:ext>
             </a:extLst>
           </p:cNvPr>
@@ -3109,7 +3109,7 @@
     </p:spTree>
     <p:extLst>
       <p:ext uri="{BB962C8B-B14F-4D97-AF65-F5344CB8AC3E}">
-        <p14:creationId xmlns:p14="http://schemas.microsoft.com/office/powerpoint/2010/main" val="938227918"/>
+        <p14:creationId xmlns:p14="http://schemas.microsoft.com/office/powerpoint/2010/main" val="1068682869"/>
       </p:ext>
     </p:extLst>
   </p:cSld>
@@ -3140,7 +3140,7 @@
           <p:cNvPr id="28" name="">
             <a:extLst xmlns:a="http://schemas.openxmlformats.org/drawingml/2006/main">
               <a:ext uri="{FF2B5EF4-FFF2-40B4-BE49-F238E27FC236}">
-                <a16:creationId xmlns:a16="http://schemas.microsoft.com/office/drawing/2014/main" id="{10CFF452-7C8E-46F6-A567-35A419DCFC39}"/>
+                <a16:creationId xmlns:a16="http://schemas.microsoft.com/office/drawing/2014/main" id="{24099B59-C743-4E1A-846B-27586EB479FB}"/>
               </a:ext>
             </a:extLst>
           </p:cNvPr>
@@ -3170,7 +3170,7 @@
           <p:cNvPr id="2" name="">
             <a:extLst xmlns:a="http://schemas.openxmlformats.org/drawingml/2006/main">
               <a:ext uri="{FF2B5EF4-FFF2-40B4-BE49-F238E27FC236}">
-                <a16:creationId xmlns:a16="http://schemas.microsoft.com/office/drawing/2014/main" id="{32D5C83E-2859-4115-91B9-6AA6D2606AE6}"/>
+                <a16:creationId xmlns:a16="http://schemas.microsoft.com/office/drawing/2014/main" id="{704EEFB3-F661-4FEC-A00D-540B797C8D9C}"/>
               </a:ext>
             </a:extLst>
           </p:cNvPr>
@@ -3231,7 +3231,7 @@
           <p:cNvPr id="3" name="">
             <a:extLst xmlns:a="http://schemas.openxmlformats.org/drawingml/2006/main">
               <a:ext uri="{FF2B5EF4-FFF2-40B4-BE49-F238E27FC236}">
-                <a16:creationId xmlns:a16="http://schemas.microsoft.com/office/drawing/2014/main" id="{5EB832DE-0F0C-491D-BE43-B4F3E50C2589}"/>
+                <a16:creationId xmlns:a16="http://schemas.microsoft.com/office/drawing/2014/main" id="{96D88EA8-8049-4397-860E-07ABB10065A6}"/>
               </a:ext>
             </a:extLst>
           </p:cNvPr>
@@ -3292,7 +3292,7 @@
           <p:cNvPr id="4" name="">
             <a:extLst xmlns:a="http://schemas.openxmlformats.org/drawingml/2006/main">
               <a:ext uri="{FF2B5EF4-FFF2-40B4-BE49-F238E27FC236}">
-                <a16:creationId xmlns:a16="http://schemas.microsoft.com/office/drawing/2014/main" id="{C16222CB-26AD-473E-80FC-C6766B5E3887}"/>
+                <a16:creationId xmlns:a16="http://schemas.microsoft.com/office/drawing/2014/main" id="{1419F467-65CC-403D-BD5A-AA8AAAA3512F}"/>
               </a:ext>
             </a:extLst>
           </p:cNvPr>
@@ -3353,7 +3353,7 @@
           <p:cNvPr id="5" name="">
             <a:extLst xmlns:a="http://schemas.openxmlformats.org/drawingml/2006/main">
               <a:ext uri="{FF2B5EF4-FFF2-40B4-BE49-F238E27FC236}">
-                <a16:creationId xmlns:a16="http://schemas.microsoft.com/office/drawing/2014/main" id="{05556FC2-369E-475D-8AA1-BB0C984FB016}"/>
+                <a16:creationId xmlns:a16="http://schemas.microsoft.com/office/drawing/2014/main" id="{9EF9ED4B-FE5C-4CE6-B501-C7A3F6518521}"/>
               </a:ext>
             </a:extLst>
           </p:cNvPr>
@@ -3384,7 +3384,7 @@
           <p:cNvPr id="6" name="">
             <a:extLst xmlns:a="http://schemas.openxmlformats.org/drawingml/2006/main">
               <a:ext uri="{FF2B5EF4-FFF2-40B4-BE49-F238E27FC236}">
-                <a16:creationId xmlns:a16="http://schemas.microsoft.com/office/drawing/2014/main" id="{1FF578FD-E1FE-4954-BDEC-C6EAAF4AC727}"/>
+                <a16:creationId xmlns:a16="http://schemas.microsoft.com/office/drawing/2014/main" id="{750238A9-FC5B-4522-A6B2-4ECFF73B48B7}"/>
               </a:ext>
             </a:extLst>
           </p:cNvPr>
@@ -3445,7 +3445,7 @@
           <p:cNvPr id="7" name="">
             <a:extLst xmlns:a="http://schemas.openxmlformats.org/drawingml/2006/main">
               <a:ext uri="{FF2B5EF4-FFF2-40B4-BE49-F238E27FC236}">
-                <a16:creationId xmlns:a16="http://schemas.microsoft.com/office/drawing/2014/main" id="{EAAA1220-3F02-4BA8-9E99-FAB9597F1E97}"/>
+                <a16:creationId xmlns:a16="http://schemas.microsoft.com/office/drawing/2014/main" id="{D6BFBF3B-AF3C-415A-846D-924F89BCD510}"/>
               </a:ext>
             </a:extLst>
           </p:cNvPr>
@@ -3506,7 +3506,7 @@
           <p:cNvPr id="8" name="">
             <a:extLst xmlns:a="http://schemas.openxmlformats.org/drawingml/2006/main">
               <a:ext uri="{FF2B5EF4-FFF2-40B4-BE49-F238E27FC236}">
-                <a16:creationId xmlns:a16="http://schemas.microsoft.com/office/drawing/2014/main" id="{EA8D722A-8601-40A2-8B39-6E431672745B}"/>
+                <a16:creationId xmlns:a16="http://schemas.microsoft.com/office/drawing/2014/main" id="{9F98B46E-1903-486A-8A6A-B6114BB8E4BB}"/>
               </a:ext>
             </a:extLst>
           </p:cNvPr>
@@ -3537,7 +3537,7 @@
           <p:cNvPr id="9" name="">
             <a:extLst xmlns:a="http://schemas.openxmlformats.org/drawingml/2006/main">
               <a:ext uri="{FF2B5EF4-FFF2-40B4-BE49-F238E27FC236}">
-                <a16:creationId xmlns:a16="http://schemas.microsoft.com/office/drawing/2014/main" id="{929BE6A5-35FE-4007-9032-26B2C8C13C45}"/>
+                <a16:creationId xmlns:a16="http://schemas.microsoft.com/office/drawing/2014/main" id="{5ED94049-F882-44D1-AECE-8F54D409D46D}"/>
               </a:ext>
             </a:extLst>
           </p:cNvPr>
@@ -3598,7 +3598,7 @@
           <p:cNvPr id="10" name="">
             <a:extLst xmlns:a="http://schemas.openxmlformats.org/drawingml/2006/main">
               <a:ext uri="{FF2B5EF4-FFF2-40B4-BE49-F238E27FC236}">
-                <a16:creationId xmlns:a16="http://schemas.microsoft.com/office/drawing/2014/main" id="{2F19D2C3-5A37-4C5E-BC83-FA5E422AF1CC}"/>
+                <a16:creationId xmlns:a16="http://schemas.microsoft.com/office/drawing/2014/main" id="{C393061D-1D9E-44E9-9AF3-647961E8472A}"/>
               </a:ext>
             </a:extLst>
           </p:cNvPr>
@@ -3628,7 +3628,7 @@
           <p:cNvPr id="11" name="">
             <a:extLst xmlns:a="http://schemas.openxmlformats.org/drawingml/2006/main">
               <a:ext uri="{FF2B5EF4-FFF2-40B4-BE49-F238E27FC236}">
-                <a16:creationId xmlns:a16="http://schemas.microsoft.com/office/drawing/2014/main" id="{5CDF897A-183A-4993-8F52-F56C3BA641CF}"/>
+                <a16:creationId xmlns:a16="http://schemas.microsoft.com/office/drawing/2014/main" id="{FD3ADFDE-5629-4412-BF00-EF7C47541BCA}"/>
               </a:ext>
             </a:extLst>
           </p:cNvPr>
@@ -3689,7 +3689,7 @@
           <p:cNvPr id="12" name="">
             <a:extLst xmlns:a="http://schemas.openxmlformats.org/drawingml/2006/main">
               <a:ext uri="{FF2B5EF4-FFF2-40B4-BE49-F238E27FC236}">
-                <a16:creationId xmlns:a16="http://schemas.microsoft.com/office/drawing/2014/main" id="{A8FB7834-5E3B-4D29-9D39-B7FF317EC18D}"/>
+                <a16:creationId xmlns:a16="http://schemas.microsoft.com/office/drawing/2014/main" id="{756484A6-4381-4832-B80D-86E76D794E86}"/>
               </a:ext>
             </a:extLst>
           </p:cNvPr>
@@ -3750,7 +3750,7 @@
           <p:cNvPr id="13" name="">
             <a:extLst xmlns:a="http://schemas.openxmlformats.org/drawingml/2006/main">
               <a:ext uri="{FF2B5EF4-FFF2-40B4-BE49-F238E27FC236}">
-                <a16:creationId xmlns:a16="http://schemas.microsoft.com/office/drawing/2014/main" id="{9F441668-E3C9-4D59-B15D-0BDBE8AA6580}"/>
+                <a16:creationId xmlns:a16="http://schemas.microsoft.com/office/drawing/2014/main" id="{FA30FF6E-6DD4-4EA8-B646-5948BE991738}"/>
               </a:ext>
             </a:extLst>
           </p:cNvPr>
@@ -3781,7 +3781,7 @@
           <p:cNvPr id="14" name="">
             <a:extLst xmlns:a="http://schemas.openxmlformats.org/drawingml/2006/main">
               <a:ext uri="{FF2B5EF4-FFF2-40B4-BE49-F238E27FC236}">
-                <a16:creationId xmlns:a16="http://schemas.microsoft.com/office/drawing/2014/main" id="{0B109BC7-5B2D-4B15-8426-A23B42C40688}"/>
+                <a16:creationId xmlns:a16="http://schemas.microsoft.com/office/drawing/2014/main" id="{CE562733-CFBB-4EE4-9371-6787D4699123}"/>
               </a:ext>
             </a:extLst>
           </p:cNvPr>
@@ -3842,7 +3842,7 @@
           <p:cNvPr id="15" name="">
             <a:extLst xmlns:a="http://schemas.openxmlformats.org/drawingml/2006/main">
               <a:ext uri="{FF2B5EF4-FFF2-40B4-BE49-F238E27FC236}">
-                <a16:creationId xmlns:a16="http://schemas.microsoft.com/office/drawing/2014/main" id="{D2BF45DF-BF09-4521-A7C2-AA672EA464A6}"/>
+                <a16:creationId xmlns:a16="http://schemas.microsoft.com/office/drawing/2014/main" id="{A8544521-7F6B-4AB5-94A4-98A0FAB05C17}"/>
               </a:ext>
             </a:extLst>
           </p:cNvPr>
@@ -3872,7 +3872,7 @@
           <p:cNvPr id="16" name="">
             <a:extLst xmlns:a="http://schemas.openxmlformats.org/drawingml/2006/main">
               <a:ext uri="{FF2B5EF4-FFF2-40B4-BE49-F238E27FC236}">
-                <a16:creationId xmlns:a16="http://schemas.microsoft.com/office/drawing/2014/main" id="{52DA3037-37D3-4A21-9A67-76136903BA86}"/>
+                <a16:creationId xmlns:a16="http://schemas.microsoft.com/office/drawing/2014/main" id="{5B202C08-B6BD-4B9F-926E-06980839BAFF}"/>
               </a:ext>
             </a:extLst>
           </p:cNvPr>
@@ -3933,7 +3933,7 @@
           <p:cNvPr id="17" name="">
             <a:extLst xmlns:a="http://schemas.openxmlformats.org/drawingml/2006/main">
               <a:ext uri="{FF2B5EF4-FFF2-40B4-BE49-F238E27FC236}">
-                <a16:creationId xmlns:a16="http://schemas.microsoft.com/office/drawing/2014/main" id="{0FFC76E3-5B65-4622-B87B-75DFEC3003F3}"/>
+                <a16:creationId xmlns:a16="http://schemas.microsoft.com/office/drawing/2014/main" id="{81308C20-C53C-4066-8A15-73A704DF855D}"/>
               </a:ext>
             </a:extLst>
           </p:cNvPr>
@@ -3994,7 +3994,7 @@
           <p:cNvPr id="18" name="">
             <a:extLst xmlns:a="http://schemas.openxmlformats.org/drawingml/2006/main">
               <a:ext uri="{FF2B5EF4-FFF2-40B4-BE49-F238E27FC236}">
-                <a16:creationId xmlns:a16="http://schemas.microsoft.com/office/drawing/2014/main" id="{0FCE4E39-F1ED-4668-A4AA-6EEF75FC7287}"/>
+                <a16:creationId xmlns:a16="http://schemas.microsoft.com/office/drawing/2014/main" id="{FF9B5797-59FB-46FF-824D-3AB353FEF92F}"/>
               </a:ext>
             </a:extLst>
           </p:cNvPr>
@@ -4025,7 +4025,7 @@
           <p:cNvPr id="19" name="">
             <a:extLst xmlns:a="http://schemas.openxmlformats.org/drawingml/2006/main">
               <a:ext uri="{FF2B5EF4-FFF2-40B4-BE49-F238E27FC236}">
-                <a16:creationId xmlns:a16="http://schemas.microsoft.com/office/drawing/2014/main" id="{54E230A2-1208-42BA-BDFF-5EB34D67ABE5}"/>
+                <a16:creationId xmlns:a16="http://schemas.microsoft.com/office/drawing/2014/main" id="{E83DB61D-3774-40B9-BB49-E2257F9B9CDC}"/>
               </a:ext>
             </a:extLst>
           </p:cNvPr>
@@ -4086,7 +4086,7 @@
           <p:cNvPr id="20" name="">
             <a:extLst xmlns:a="http://schemas.openxmlformats.org/drawingml/2006/main">
               <a:ext uri="{FF2B5EF4-FFF2-40B4-BE49-F238E27FC236}">
-                <a16:creationId xmlns:a16="http://schemas.microsoft.com/office/drawing/2014/main" id="{D258CDD6-D133-42C6-AF7C-CBF15A1A5B8C}"/>
+                <a16:creationId xmlns:a16="http://schemas.microsoft.com/office/drawing/2014/main" id="{A45A393F-D24C-44CD-84A9-0E0D0630FF9C}"/>
               </a:ext>
             </a:extLst>
           </p:cNvPr>
@@ -4116,7 +4116,7 @@
           <p:cNvPr id="21" name="">
             <a:extLst xmlns:a="http://schemas.openxmlformats.org/drawingml/2006/main">
               <a:ext uri="{FF2B5EF4-FFF2-40B4-BE49-F238E27FC236}">
-                <a16:creationId xmlns:a16="http://schemas.microsoft.com/office/drawing/2014/main" id="{E3FB3954-14B3-4CF8-BAEB-71259CB8C251}"/>
+                <a16:creationId xmlns:a16="http://schemas.microsoft.com/office/drawing/2014/main" id="{882C6542-5E1A-42A4-AE5E-B819468B2736}"/>
               </a:ext>
             </a:extLst>
           </p:cNvPr>
@@ -4177,7 +4177,7 @@
           <p:cNvPr id="22" name="">
             <a:extLst xmlns:a="http://schemas.openxmlformats.org/drawingml/2006/main">
               <a:ext uri="{FF2B5EF4-FFF2-40B4-BE49-F238E27FC236}">
-                <a16:creationId xmlns:a16="http://schemas.microsoft.com/office/drawing/2014/main" id="{45BB2D09-4EE6-450C-BDCB-406DC3F0287C}"/>
+                <a16:creationId xmlns:a16="http://schemas.microsoft.com/office/drawing/2014/main" id="{580391AC-E115-4F09-ADDD-844B64A33788}"/>
               </a:ext>
             </a:extLst>
           </p:cNvPr>
@@ -4238,7 +4238,7 @@
           <p:cNvPr id="23" name="">
             <a:extLst xmlns:a="http://schemas.openxmlformats.org/drawingml/2006/main">
               <a:ext uri="{FF2B5EF4-FFF2-40B4-BE49-F238E27FC236}">
-                <a16:creationId xmlns:a16="http://schemas.microsoft.com/office/drawing/2014/main" id="{94429722-0F18-474D-9176-635BD5C639FC}"/>
+                <a16:creationId xmlns:a16="http://schemas.microsoft.com/office/drawing/2014/main" id="{20A1E970-B40D-4937-8FDD-C39C6C09FA0C}"/>
               </a:ext>
             </a:extLst>
           </p:cNvPr>
@@ -4269,7 +4269,7 @@
           <p:cNvPr id="24" name="">
             <a:extLst xmlns:a="http://schemas.openxmlformats.org/drawingml/2006/main">
               <a:ext uri="{FF2B5EF4-FFF2-40B4-BE49-F238E27FC236}">
-                <a16:creationId xmlns:a16="http://schemas.microsoft.com/office/drawing/2014/main" id="{5758F8BD-584A-42E6-B299-77C227214CA2}"/>
+                <a16:creationId xmlns:a16="http://schemas.microsoft.com/office/drawing/2014/main" id="{1AFBD9D6-41AF-447C-AD0F-64286E804742}"/>
               </a:ext>
             </a:extLst>
           </p:cNvPr>
@@ -4330,7 +4330,7 @@
           <p:cNvPr id="25" name="">
             <a:extLst xmlns:a="http://schemas.openxmlformats.org/drawingml/2006/main">
               <a:ext uri="{FF2B5EF4-FFF2-40B4-BE49-F238E27FC236}">
-                <a16:creationId xmlns:a16="http://schemas.microsoft.com/office/drawing/2014/main" id="{01BFC6A5-C150-4A3E-89C1-5DBF937CF04F}"/>
+                <a16:creationId xmlns:a16="http://schemas.microsoft.com/office/drawing/2014/main" id="{E14F9BE9-2753-4976-8021-366D52549882}"/>
               </a:ext>
             </a:extLst>
           </p:cNvPr>
@@ -4360,7 +4360,7 @@
           <p:cNvPr id="26" name="">
             <a:extLst xmlns:a="http://schemas.openxmlformats.org/drawingml/2006/main">
               <a:ext uri="{FF2B5EF4-FFF2-40B4-BE49-F238E27FC236}">
-                <a16:creationId xmlns:a16="http://schemas.microsoft.com/office/drawing/2014/main" id="{FA1EA846-A457-47E6-B281-0B34B7783EED}"/>
+                <a16:creationId xmlns:a16="http://schemas.microsoft.com/office/drawing/2014/main" id="{9A9F894E-3CEC-4E23-9BF5-4A51E4E9B46C}"/>
               </a:ext>
             </a:extLst>
           </p:cNvPr>
@@ -4421,7 +4421,7 @@
           <p:cNvPr id="27" name="">
             <a:extLst xmlns:a="http://schemas.openxmlformats.org/drawingml/2006/main">
               <a:ext uri="{FF2B5EF4-FFF2-40B4-BE49-F238E27FC236}">
-                <a16:creationId xmlns:a16="http://schemas.microsoft.com/office/drawing/2014/main" id="{B42C9CCA-E9EE-4459-8CAC-DF1D657C0D0C}"/>
+                <a16:creationId xmlns:a16="http://schemas.microsoft.com/office/drawing/2014/main" id="{9C30C9BC-5115-4205-8C22-40240F69ED90}"/>
               </a:ext>
             </a:extLst>
           </p:cNvPr>
@@ -4480,7 +4480,7 @@
     </p:spTree>
     <p:extLst>
       <p:ext uri="{BB962C8B-B14F-4D97-AF65-F5344CB8AC3E}">
-        <p14:creationId xmlns:p14="http://schemas.microsoft.com/office/powerpoint/2010/main" val="1261294273"/>
+        <p14:creationId xmlns:p14="http://schemas.microsoft.com/office/powerpoint/2010/main" val="2033444948"/>
       </p:ext>
     </p:extLst>
   </p:cSld>
@@ -4511,7 +4511,7 @@
           <p:cNvPr id="21" name="">
             <a:extLst xmlns:a="http://schemas.openxmlformats.org/drawingml/2006/main">
               <a:ext uri="{FF2B5EF4-FFF2-40B4-BE49-F238E27FC236}">
-                <a16:creationId xmlns:a16="http://schemas.microsoft.com/office/drawing/2014/main" id="{2782FAFD-C21D-47B9-B7C7-E86DA38A88ED}"/>
+                <a16:creationId xmlns:a16="http://schemas.microsoft.com/office/drawing/2014/main" id="{8537BD9A-3222-4CAB-AE47-35A8BAD94982}"/>
               </a:ext>
             </a:extLst>
           </p:cNvPr>
@@ -4541,7 +4541,7 @@
           <p:cNvPr id="2" name="">
             <a:extLst xmlns:a="http://schemas.openxmlformats.org/drawingml/2006/main">
               <a:ext uri="{FF2B5EF4-FFF2-40B4-BE49-F238E27FC236}">
-                <a16:creationId xmlns:a16="http://schemas.microsoft.com/office/drawing/2014/main" id="{29D7BA2D-F78A-4A11-8AE7-7BFD09792434}"/>
+                <a16:creationId xmlns:a16="http://schemas.microsoft.com/office/drawing/2014/main" id="{79EB5995-6D07-4A36-BF3C-FC1EDB78325F}"/>
               </a:ext>
             </a:extLst>
           </p:cNvPr>
@@ -4602,7 +4602,7 @@
           <p:cNvPr id="3" name="">
             <a:extLst xmlns:a="http://schemas.openxmlformats.org/drawingml/2006/main">
               <a:ext uri="{FF2B5EF4-FFF2-40B4-BE49-F238E27FC236}">
-                <a16:creationId xmlns:a16="http://schemas.microsoft.com/office/drawing/2014/main" id="{97BBF765-82E4-4ACC-8795-4AC77D7CEEA5}"/>
+                <a16:creationId xmlns:a16="http://schemas.microsoft.com/office/drawing/2014/main" id="{6982718A-F3F1-4AC6-887F-4EDADCE88B5D}"/>
               </a:ext>
             </a:extLst>
           </p:cNvPr>
@@ -4663,7 +4663,7 @@
           <p:cNvPr id="4" name="">
             <a:extLst xmlns:a="http://schemas.openxmlformats.org/drawingml/2006/main">
               <a:ext uri="{FF2B5EF4-FFF2-40B4-BE49-F238E27FC236}">
-                <a16:creationId xmlns:a16="http://schemas.microsoft.com/office/drawing/2014/main" id="{CC7593F6-0122-4943-AE9D-98FAC35AB92B}"/>
+                <a16:creationId xmlns:a16="http://schemas.microsoft.com/office/drawing/2014/main" id="{34F1D326-F0E0-494B-A664-7F5F8CEE5A19}"/>
               </a:ext>
             </a:extLst>
           </p:cNvPr>
@@ -4724,7 +4724,7 @@
           <p:cNvPr id="5" name="">
             <a:extLst xmlns:a="http://schemas.openxmlformats.org/drawingml/2006/main">
               <a:ext uri="{FF2B5EF4-FFF2-40B4-BE49-F238E27FC236}">
-                <a16:creationId xmlns:a16="http://schemas.microsoft.com/office/drawing/2014/main" id="{E1C151E4-31A0-4E7D-8669-828C1F368A81}"/>
+                <a16:creationId xmlns:a16="http://schemas.microsoft.com/office/drawing/2014/main" id="{27BF070D-A64A-4023-AD20-358F8796CBE3}"/>
               </a:ext>
             </a:extLst>
           </p:cNvPr>
@@ -4755,7 +4755,7 @@
           <p:cNvPr id="6" name="">
             <a:extLst xmlns:a="http://schemas.openxmlformats.org/drawingml/2006/main">
               <a:ext uri="{FF2B5EF4-FFF2-40B4-BE49-F238E27FC236}">
-                <a16:creationId xmlns:a16="http://schemas.microsoft.com/office/drawing/2014/main" id="{9BA08ED4-A543-49CC-B7A3-2D2680265AA7}"/>
+                <a16:creationId xmlns:a16="http://schemas.microsoft.com/office/drawing/2014/main" id="{153158B8-5607-43D9-B198-C30EF2D00E9E}"/>
               </a:ext>
             </a:extLst>
           </p:cNvPr>
@@ -4816,7 +4816,7 @@
           <p:cNvPr id="7" name="">
             <a:extLst xmlns:a="http://schemas.openxmlformats.org/drawingml/2006/main">
               <a:ext uri="{FF2B5EF4-FFF2-40B4-BE49-F238E27FC236}">
-                <a16:creationId xmlns:a16="http://schemas.microsoft.com/office/drawing/2014/main" id="{AEE6162B-3132-4FE5-9F83-7FB6EC5A0B86}"/>
+                <a16:creationId xmlns:a16="http://schemas.microsoft.com/office/drawing/2014/main" id="{BD3042B7-8F08-43A5-B1B5-31E1CD6F5521}"/>
               </a:ext>
             </a:extLst>
           </p:cNvPr>
@@ -4847,7 +4847,7 @@
           <p:cNvPr id="8" name="">
             <a:extLst xmlns:a="http://schemas.openxmlformats.org/drawingml/2006/main">
               <a:ext uri="{FF2B5EF4-FFF2-40B4-BE49-F238E27FC236}">
-                <a16:creationId xmlns:a16="http://schemas.microsoft.com/office/drawing/2014/main" id="{881A2E2B-17AE-4211-B44F-9E20D87B8940}"/>
+                <a16:creationId xmlns:a16="http://schemas.microsoft.com/office/drawing/2014/main" id="{45CD1255-0D79-4F19-9B9B-417AA8CD587E}"/>
               </a:ext>
             </a:extLst>
           </p:cNvPr>
@@ -4879,7 +4879,7 @@
           <p:cNvPr id="9" name="">
             <a:extLst xmlns:a="http://schemas.openxmlformats.org/drawingml/2006/main">
               <a:ext uri="{FF2B5EF4-FFF2-40B4-BE49-F238E27FC236}">
-                <a16:creationId xmlns:a16="http://schemas.microsoft.com/office/drawing/2014/main" id="{4CC5C335-3D43-4676-99D0-8AAF8EC397E0}"/>
+                <a16:creationId xmlns:a16="http://schemas.microsoft.com/office/drawing/2014/main" id="{3466D609-EDD0-421D-A040-9320824C30E2}"/>
               </a:ext>
             </a:extLst>
           </p:cNvPr>
@@ -4940,7 +4940,7 @@
           <p:cNvPr id="10" name="">
             <a:extLst xmlns:a="http://schemas.openxmlformats.org/drawingml/2006/main">
               <a:ext uri="{FF2B5EF4-FFF2-40B4-BE49-F238E27FC236}">
-                <a16:creationId xmlns:a16="http://schemas.microsoft.com/office/drawing/2014/main" id="{21D213A8-970D-4D15-9B35-402CB27AAF2E}"/>
+                <a16:creationId xmlns:a16="http://schemas.microsoft.com/office/drawing/2014/main" id="{BAB3EE2F-80F7-4E8F-B97C-AE46F74E029C}"/>
               </a:ext>
             </a:extLst>
           </p:cNvPr>
@@ -5001,7 +5001,7 @@
           <p:cNvPr id="11" name="">
             <a:extLst xmlns:a="http://schemas.openxmlformats.org/drawingml/2006/main">
               <a:ext uri="{FF2B5EF4-FFF2-40B4-BE49-F238E27FC236}">
-                <a16:creationId xmlns:a16="http://schemas.microsoft.com/office/drawing/2014/main" id="{5F44CBA4-0D32-4CD5-B796-D402313B8150}"/>
+                <a16:creationId xmlns:a16="http://schemas.microsoft.com/office/drawing/2014/main" id="{159CD81E-C69F-40A7-9609-5F32775BA4D7}"/>
               </a:ext>
             </a:extLst>
           </p:cNvPr>
@@ -5052,16 +5052,16 @@
                 <a:ea typeface="Arial"/>
                 <a:cs typeface="Arial"/>
               </a:rPr>
-              <a:t>סביבה מקומית עובדת</a:t>
-            </a:r>
-          </a:p>
-          <a:p xmlns:a="http://schemas.openxmlformats.org/drawingml/2006/main">
-            <a:pPr algn="r" rtl="1">
+              <a:t>53 ימים מאושרים</a:t>
+            </a:r>
+          </a:p>
+          <a:p xmlns:a="http://schemas.openxmlformats.org/drawingml/2006/main">
+            <a:pPr algn="r">
               <a:lnSpc>
                 <a:spcPct val="105000"/>
               </a:lnSpc>
               <a:buNone/>
-              <a:defRPr sz="1575" b="0" lang="he-IL">
+              <a:defRPr sz="1575" b="0">
                 <a:solidFill>
                   <a:srgbClr val="9AB1C5"/>
                 </a:solidFill>
@@ -5071,7 +5071,7 @@
               </a:defRPr>
             </a:pPr>
             <a:r>
-              <a:rPr sz="1575" b="0" lang="he-IL">
+              <a:rPr sz="1575" b="0">
                 <a:solidFill>
                   <a:srgbClr val="9AB1C5"/>
                 </a:solidFill>
@@ -5079,7 +5079,7 @@
                 <a:ea typeface="Arial"/>
                 <a:cs typeface="Arial"/>
               </a:rPr>
-              <a:t>41 ימים מאושרים</a:t>
+              <a:t>v1 Shadow 2/20</a:t>
             </a:r>
           </a:p>
           <a:p xmlns:a="http://schemas.openxmlformats.org/drawingml/2006/main">
@@ -5106,7 +5106,7 @@
                 <a:ea typeface="Arial"/>
                 <a:cs typeface="Arial"/>
               </a:rPr>
-              <a:t>Shadow Mode 1/20</a:t>
+              <a:t>v2 FALLBACK</a:t>
             </a:r>
           </a:p>
         </p:txBody>
@@ -5116,7 +5116,7 @@
           <p:cNvPr id="12" name="">
             <a:extLst xmlns:a="http://schemas.openxmlformats.org/drawingml/2006/main">
               <a:ext uri="{FF2B5EF4-FFF2-40B4-BE49-F238E27FC236}">
-                <a16:creationId xmlns:a16="http://schemas.microsoft.com/office/drawing/2014/main" id="{0BBA2248-1003-4FDE-A662-E006E7B3C4F7}"/>
+                <a16:creationId xmlns:a16="http://schemas.microsoft.com/office/drawing/2014/main" id="{A61FD1E2-82CC-47EC-995F-5959CB58E338}"/>
               </a:ext>
             </a:extLst>
           </p:cNvPr>
@@ -5148,7 +5148,7 @@
           <p:cNvPr id="13" name="">
             <a:extLst xmlns:a="http://schemas.openxmlformats.org/drawingml/2006/main">
               <a:ext uri="{FF2B5EF4-FFF2-40B4-BE49-F238E27FC236}">
-                <a16:creationId xmlns:a16="http://schemas.microsoft.com/office/drawing/2014/main" id="{BB8E72A1-D85E-4234-AD24-74A54FC90EA1}"/>
+                <a16:creationId xmlns:a16="http://schemas.microsoft.com/office/drawing/2014/main" id="{3325B80A-CFBB-450C-B5A4-63CEDBFB6F04}"/>
               </a:ext>
             </a:extLst>
           </p:cNvPr>
@@ -5209,7 +5209,7 @@
           <p:cNvPr id="14" name="">
             <a:extLst xmlns:a="http://schemas.openxmlformats.org/drawingml/2006/main">
               <a:ext uri="{FF2B5EF4-FFF2-40B4-BE49-F238E27FC236}">
-                <a16:creationId xmlns:a16="http://schemas.microsoft.com/office/drawing/2014/main" id="{E5D29DED-6DA0-4227-9F88-8478207BF4CF}"/>
+                <a16:creationId xmlns:a16="http://schemas.microsoft.com/office/drawing/2014/main" id="{4D8996D5-3221-4EFE-84CD-07DF2222B0E5}"/>
               </a:ext>
             </a:extLst>
           </p:cNvPr>
@@ -5260,7 +5260,7 @@
                 <a:ea typeface="Arial"/>
                 <a:cs typeface="Arial"/>
               </a:rPr>
-              <a:t>לאחר 20 ימים חיים</a:t>
+              <a:t>שער הראיות</a:t>
             </a:r>
           </a:p>
         </p:txBody>
@@ -5270,7 +5270,7 @@
           <p:cNvPr id="15" name="">
             <a:extLst xmlns:a="http://schemas.openxmlformats.org/drawingml/2006/main">
               <a:ext uri="{FF2B5EF4-FFF2-40B4-BE49-F238E27FC236}">
-                <a16:creationId xmlns:a16="http://schemas.microsoft.com/office/drawing/2014/main" id="{1DFC3396-AB3A-46E0-A740-674F02F69DBA}"/>
+                <a16:creationId xmlns:a16="http://schemas.microsoft.com/office/drawing/2014/main" id="{ADF559A4-3FAD-46AF-A685-2A19FD81F3FC}"/>
               </a:ext>
             </a:extLst>
           </p:cNvPr>
@@ -5321,7 +5321,7 @@
                 <a:ea typeface="Arial"/>
                 <a:cs typeface="Arial"/>
               </a:rPr>
-              <a:t>בדיקת Calibration</a:t>
+              <a:t>24 חודשי נתונים</a:t>
             </a:r>
           </a:p>
           <a:p xmlns:a="http://schemas.openxmlformats.org/drawingml/2006/main">
@@ -5348,16 +5348,16 @@
                 <a:ea typeface="Arial"/>
                 <a:cs typeface="Arial"/>
               </a:rPr>
-              <a:t>אישור אנושי נפרד</a:t>
-            </a:r>
-          </a:p>
-          <a:p xmlns:a="http://schemas.openxmlformats.org/drawingml/2006/main">
-            <a:pPr algn="r" rtl="1">
+              <a:t>300 כניסות תקפות</a:t>
+            </a:r>
+          </a:p>
+          <a:p xmlns:a="http://schemas.openxmlformats.org/drawingml/2006/main">
+            <a:pPr algn="r">
               <a:lnSpc>
                 <a:spcPct val="105000"/>
               </a:lnSpc>
               <a:buNone/>
-              <a:defRPr sz="1575" b="0" lang="he-IL">
+              <a:defRPr sz="1575" b="0">
                 <a:solidFill>
                   <a:srgbClr val="9AB1C5"/>
                 </a:solidFill>
@@ -5367,7 +5367,7 @@
               </a:defRPr>
             </a:pPr>
             <a:r>
-              <a:rPr sz="1575" b="0" lang="he-IL">
+              <a:rPr sz="1575" b="0">
                 <a:solidFill>
                   <a:srgbClr val="9AB1C5"/>
                 </a:solidFill>
@@ -5375,7 +5375,7 @@
                 <a:ea typeface="Arial"/>
                 <a:cs typeface="Arial"/>
               </a:rPr>
-              <a:t>פתיחת Decision Support</a:t>
+              <a:t>Walk-Forward gates</a:t>
             </a:r>
           </a:p>
         </p:txBody>
@@ -5385,7 +5385,7 @@
           <p:cNvPr id="16" name="">
             <a:extLst xmlns:a="http://schemas.openxmlformats.org/drawingml/2006/main">
               <a:ext uri="{FF2B5EF4-FFF2-40B4-BE49-F238E27FC236}">
-                <a16:creationId xmlns:a16="http://schemas.microsoft.com/office/drawing/2014/main" id="{42BE1A9D-8D9B-40A5-8F0E-656769516C70}"/>
+                <a16:creationId xmlns:a16="http://schemas.microsoft.com/office/drawing/2014/main" id="{AB67C1F8-A5D0-4089-86CC-895C90560E58}"/>
               </a:ext>
             </a:extLst>
           </p:cNvPr>
@@ -5417,7 +5417,7 @@
           <p:cNvPr id="17" name="">
             <a:extLst xmlns:a="http://schemas.openxmlformats.org/drawingml/2006/main">
               <a:ext uri="{FF2B5EF4-FFF2-40B4-BE49-F238E27FC236}">
-                <a16:creationId xmlns:a16="http://schemas.microsoft.com/office/drawing/2014/main" id="{891FC518-CCF6-41A0-B6A6-C840CDEA0BF7}"/>
+                <a16:creationId xmlns:a16="http://schemas.microsoft.com/office/drawing/2014/main" id="{B5AAEFD9-D56D-4907-82D9-6F467E4051BA}"/>
               </a:ext>
             </a:extLst>
           </p:cNvPr>
@@ -5478,7 +5478,7 @@
           <p:cNvPr id="18" name="">
             <a:extLst xmlns:a="http://schemas.openxmlformats.org/drawingml/2006/main">
               <a:ext uri="{FF2B5EF4-FFF2-40B4-BE49-F238E27FC236}">
-                <a16:creationId xmlns:a16="http://schemas.microsoft.com/office/drawing/2014/main" id="{AE61C49A-F956-427F-9152-65FB3CFDBDB8}"/>
+                <a16:creationId xmlns:a16="http://schemas.microsoft.com/office/drawing/2014/main" id="{29BBE666-8C8D-41B6-AEB9-8EF6364C9BAC}"/>
               </a:ext>
             </a:extLst>
           </p:cNvPr>
@@ -5529,7 +5529,7 @@
                 <a:ea typeface="Arial"/>
                 <a:cs typeface="Arial"/>
               </a:rPr>
-              <a:t>הרחבה עתידית</a:t>
+              <a:t>לפני הפעלה</a:t>
             </a:r>
           </a:p>
         </p:txBody>
@@ -5539,7 +5539,7 @@
           <p:cNvPr id="19" name="">
             <a:extLst xmlns:a="http://schemas.openxmlformats.org/drawingml/2006/main">
               <a:ext uri="{FF2B5EF4-FFF2-40B4-BE49-F238E27FC236}">
-                <a16:creationId xmlns:a16="http://schemas.microsoft.com/office/drawing/2014/main" id="{CD101AC6-63E6-4DFB-9767-4868F0AD763B}"/>
+                <a16:creationId xmlns:a16="http://schemas.microsoft.com/office/drawing/2014/main" id="{038CB654-2783-42AC-BA82-7593B33E6B41}"/>
               </a:ext>
             </a:extLst>
           </p:cNvPr>
@@ -5590,16 +5590,16 @@
                 <a:ea typeface="Arial"/>
                 <a:cs typeface="Arial"/>
               </a:rPr>
-              <a:t>SIP / S3 / Elastic</a:t>
-            </a:r>
-          </a:p>
-          <a:p xmlns:a="http://schemas.openxmlformats.org/drawingml/2006/main">
-            <a:pPr algn="r">
+              <a:t>v2 Shadow 20 days</a:t>
+            </a:r>
+          </a:p>
+          <a:p xmlns:a="http://schemas.openxmlformats.org/drawingml/2006/main">
+            <a:pPr algn="r" rtl="1">
               <a:lnSpc>
                 <a:spcPct val="105000"/>
               </a:lnSpc>
               <a:buNone/>
-              <a:defRPr sz="1575" b="0">
+              <a:defRPr sz="1575" b="0" lang="he-IL">
                 <a:solidFill>
                   <a:srgbClr val="9AB1C5"/>
                 </a:solidFill>
@@ -5609,7 +5609,7 @@
               </a:defRPr>
             </a:pPr>
             <a:r>
-              <a:rPr sz="1575" b="0">
+              <a:rPr sz="1575" b="0" lang="he-IL">
                 <a:solidFill>
                   <a:srgbClr val="9AB1C5"/>
                 </a:solidFill>
@@ -5617,7 +5617,7 @@
                 <a:ea typeface="Arial"/>
                 <a:cs typeface="Arial"/>
               </a:rPr>
-              <a:t>Authentication + TLS</a:t>
+              <a:t>בדיקת Calibration</a:t>
             </a:r>
           </a:p>
           <a:p xmlns:a="http://schemas.openxmlformats.org/drawingml/2006/main">
@@ -5644,7 +5644,7 @@
                 <a:ea typeface="Arial"/>
                 <a:cs typeface="Arial"/>
               </a:rPr>
-              <a:t>פריסה משותפת</a:t>
+              <a:t>אישור אנושי</a:t>
             </a:r>
           </a:p>
         </p:txBody>
@@ -5654,19 +5654,19 @@
           <p:cNvPr id="20" name="">
             <a:extLst xmlns:a="http://schemas.openxmlformats.org/drawingml/2006/main">
               <a:ext uri="{FF2B5EF4-FFF2-40B4-BE49-F238E27FC236}">
-                <a16:creationId xmlns:a16="http://schemas.microsoft.com/office/drawing/2014/main" id="{950EF426-F258-4D02-A91C-0AA5B2E2B3B8}"/>
-              </a:ext>
-            </a:extLst>
-          </p:cNvPr>
-          <p:cNvSpPr>
-            <a:spLocks xmlns:a="http://schemas.openxmlformats.org/drawingml/2006/main" noGrp="1"/>
-          </p:cNvSpPr>
-          <p:nvPr/>
-        </p:nvSpPr>
-        <p:spPr>
-          <a:xfrm xmlns:a="http://schemas.openxmlformats.org/drawingml/2006/main">
-            <a:off x="4419600" y="5295900"/>
-            <a:ext cx="7143750" cy="438150"/>
+                <a16:creationId xmlns:a16="http://schemas.microsoft.com/office/drawing/2014/main" id="{FE06F5CC-D059-4791-BBE1-398ED75E7EF0}"/>
+              </a:ext>
+            </a:extLst>
+          </p:cNvPr>
+          <p:cNvSpPr>
+            <a:spLocks xmlns:a="http://schemas.openxmlformats.org/drawingml/2006/main" noGrp="1"/>
+          </p:cNvSpPr>
+          <p:nvPr/>
+        </p:nvSpPr>
+        <p:spPr>
+          <a:xfrm xmlns:a="http://schemas.openxmlformats.org/drawingml/2006/main">
+            <a:off x="3810000" y="5295900"/>
+            <a:ext cx="7753350" cy="438150"/>
           </a:xfrm>
           <a:prstGeom xmlns:a="http://schemas.openxmlformats.org/drawingml/2006/main" prst="rect">
             <a:avLst/>
@@ -5678,7 +5678,7 @@
         </p:spPr>
         <p:txBody>
           <a:bodyPr xmlns:a="http://schemas.openxmlformats.org/drawingml/2006/main" wrap="square" lIns="0" tIns="0" rIns="0" bIns="0" anchor="t">
-            <a:normAutofit fontScale="95279"/>
+            <a:normAutofit fontScale="100000"/>
           </a:bodyPr>
           <a:lstStyle xmlns:a="http://schemas.openxmlformats.org/drawingml/2006/main"/>
           <a:p xmlns:a="http://schemas.openxmlformats.org/drawingml/2006/main">
@@ -5705,7 +5705,7 @@
                 <a:ea typeface="Arial"/>
                 <a:cs typeface="Arial"/>
               </a:rPr>
-              <a:t>הקידום יתאפשר רק לאחר ראיות חיות ובדיקה אנושית. תוצאות היסטוריות לבדן אינן מספיקות.</a:t>
+              <a:t>רק אחרי שערי האמון נשקול הזנת שוק מלאה, ענן, אבטחה וניטור תפעולי.</a:t>
             </a:r>
           </a:p>
         </p:txBody>
@@ -5713,7 +5713,7 @@
     </p:spTree>
     <p:extLst>
       <p:ext uri="{BB962C8B-B14F-4D97-AF65-F5344CB8AC3E}">
-        <p14:creationId xmlns:p14="http://schemas.microsoft.com/office/powerpoint/2010/main" val="2081791215"/>
+        <p14:creationId xmlns:p14="http://schemas.microsoft.com/office/powerpoint/2010/main" val="1049230087"/>
       </p:ext>
     </p:extLst>
   </p:cSld>
@@ -5744,7 +5744,7 @@
           <p:cNvPr id="34" name="">
             <a:extLst xmlns:a="http://schemas.openxmlformats.org/drawingml/2006/main">
               <a:ext uri="{FF2B5EF4-FFF2-40B4-BE49-F238E27FC236}">
-                <a16:creationId xmlns:a16="http://schemas.microsoft.com/office/drawing/2014/main" id="{D4151BD6-81A0-4AA9-A335-839CC4BA417C}"/>
+                <a16:creationId xmlns:a16="http://schemas.microsoft.com/office/drawing/2014/main" id="{5CF54FDF-F376-48E3-A924-2B8DF0CDF57C}"/>
               </a:ext>
             </a:extLst>
           </p:cNvPr>
@@ -5774,7 +5774,7 @@
           <p:cNvPr id="2" name="">
             <a:extLst xmlns:a="http://schemas.openxmlformats.org/drawingml/2006/main">
               <a:ext uri="{FF2B5EF4-FFF2-40B4-BE49-F238E27FC236}">
-                <a16:creationId xmlns:a16="http://schemas.microsoft.com/office/drawing/2014/main" id="{E2371AEB-C406-4A21-BAF5-0EA80E88D0DA}"/>
+                <a16:creationId xmlns:a16="http://schemas.microsoft.com/office/drawing/2014/main" id="{72573BF8-79FC-4017-ACE5-BCEC707079DD}"/>
               </a:ext>
             </a:extLst>
           </p:cNvPr>
@@ -5825,7 +5825,7 @@
                 <a:ea typeface="Cascadia Mono"/>
                 <a:cs typeface="Cascadia Mono"/>
               </a:rPr>
-              <a:t>LIVE DEMO · 06:00</a:t>
+              <a:t>LIVE DEMO · 05:50</a:t>
             </a:r>
           </a:p>
         </p:txBody>
@@ -5835,7 +5835,7 @@
           <p:cNvPr id="3" name="">
             <a:extLst xmlns:a="http://schemas.openxmlformats.org/drawingml/2006/main">
               <a:ext uri="{FF2B5EF4-FFF2-40B4-BE49-F238E27FC236}">
-                <a16:creationId xmlns:a16="http://schemas.microsoft.com/office/drawing/2014/main" id="{1D2EA5D3-9FD2-42ED-922E-8BF26883F731}"/>
+                <a16:creationId xmlns:a16="http://schemas.microsoft.com/office/drawing/2014/main" id="{43BA97E8-60C6-403F-B5D1-66995E3A3170}"/>
               </a:ext>
             </a:extLst>
           </p:cNvPr>
@@ -5896,7 +5896,7 @@
           <p:cNvPr id="4" name="">
             <a:extLst xmlns:a="http://schemas.openxmlformats.org/drawingml/2006/main">
               <a:ext uri="{FF2B5EF4-FFF2-40B4-BE49-F238E27FC236}">
-                <a16:creationId xmlns:a16="http://schemas.microsoft.com/office/drawing/2014/main" id="{A4DD5E30-0729-4730-BC92-B9FA871CA96F}"/>
+                <a16:creationId xmlns:a16="http://schemas.microsoft.com/office/drawing/2014/main" id="{2D3244FA-65AB-4BB1-9E39-FCA0E11CD51E}"/>
               </a:ext>
             </a:extLst>
           </p:cNvPr>
@@ -5957,7 +5957,7 @@
           <p:cNvPr id="5" name="">
             <a:extLst xmlns:a="http://schemas.openxmlformats.org/drawingml/2006/main">
               <a:ext uri="{FF2B5EF4-FFF2-40B4-BE49-F238E27FC236}">
-                <a16:creationId xmlns:a16="http://schemas.microsoft.com/office/drawing/2014/main" id="{031FBF14-09BE-498F-87BD-7B45F4BF39CC}"/>
+                <a16:creationId xmlns:a16="http://schemas.microsoft.com/office/drawing/2014/main" id="{D4DE2DC5-5D19-46DF-AAF3-BBCE302F730D}"/>
               </a:ext>
             </a:extLst>
           </p:cNvPr>
@@ -5992,7 +5992,7 @@
           <p:cNvPr id="6" name="">
             <a:extLst xmlns:a="http://schemas.openxmlformats.org/drawingml/2006/main">
               <a:ext uri="{FF2B5EF4-FFF2-40B4-BE49-F238E27FC236}">
-                <a16:creationId xmlns:a16="http://schemas.microsoft.com/office/drawing/2014/main" id="{985CA279-CDF3-41D3-9474-991B579D21EB}"/>
+                <a16:creationId xmlns:a16="http://schemas.microsoft.com/office/drawing/2014/main" id="{E330B7CE-9197-4D38-945E-CF668A4E69EC}"/>
               </a:ext>
             </a:extLst>
           </p:cNvPr>
@@ -6053,7 +6053,7 @@
           <p:cNvPr id="7" name="">
             <a:extLst xmlns:a="http://schemas.openxmlformats.org/drawingml/2006/main">
               <a:ext uri="{FF2B5EF4-FFF2-40B4-BE49-F238E27FC236}">
-                <a16:creationId xmlns:a16="http://schemas.microsoft.com/office/drawing/2014/main" id="{DEFFEB71-573E-47C8-AA66-4E760C12B472}"/>
+                <a16:creationId xmlns:a16="http://schemas.microsoft.com/office/drawing/2014/main" id="{6C946AEE-C31D-48F8-8058-F7CABA9DC713}"/>
               </a:ext>
             </a:extLst>
           </p:cNvPr>
@@ -6114,7 +6114,7 @@
           <p:cNvPr id="8" name="">
             <a:extLst xmlns:a="http://schemas.openxmlformats.org/drawingml/2006/main">
               <a:ext uri="{FF2B5EF4-FFF2-40B4-BE49-F238E27FC236}">
-                <a16:creationId xmlns:a16="http://schemas.microsoft.com/office/drawing/2014/main" id="{12421E63-1628-4832-8D2C-D54B98ED5D29}"/>
+                <a16:creationId xmlns:a16="http://schemas.microsoft.com/office/drawing/2014/main" id="{F5D9B2FB-53D4-4D36-AC74-92B83B329112}"/>
               </a:ext>
             </a:extLst>
           </p:cNvPr>
@@ -6149,7 +6149,7 @@
           <p:cNvPr id="9" name="">
             <a:extLst xmlns:a="http://schemas.openxmlformats.org/drawingml/2006/main">
               <a:ext uri="{FF2B5EF4-FFF2-40B4-BE49-F238E27FC236}">
-                <a16:creationId xmlns:a16="http://schemas.microsoft.com/office/drawing/2014/main" id="{998DCBF3-5457-4466-A865-EA14F79F229A}"/>
+                <a16:creationId xmlns:a16="http://schemas.microsoft.com/office/drawing/2014/main" id="{AB1DC142-AC7E-4AD6-A018-71BD4398267E}"/>
               </a:ext>
             </a:extLst>
           </p:cNvPr>
@@ -6210,7 +6210,7 @@
           <p:cNvPr id="10" name="">
             <a:extLst xmlns:a="http://schemas.openxmlformats.org/drawingml/2006/main">
               <a:ext uri="{FF2B5EF4-FFF2-40B4-BE49-F238E27FC236}">
-                <a16:creationId xmlns:a16="http://schemas.microsoft.com/office/drawing/2014/main" id="{DAF80D18-5603-4635-8315-3C7FEB00674D}"/>
+                <a16:creationId xmlns:a16="http://schemas.microsoft.com/office/drawing/2014/main" id="{EDD3D37F-7981-4117-A093-150B1CC7CCA0}"/>
               </a:ext>
             </a:extLst>
           </p:cNvPr>
@@ -6271,7 +6271,7 @@
           <p:cNvPr id="11" name="">
             <a:extLst xmlns:a="http://schemas.openxmlformats.org/drawingml/2006/main">
               <a:ext uri="{FF2B5EF4-FFF2-40B4-BE49-F238E27FC236}">
-                <a16:creationId xmlns:a16="http://schemas.microsoft.com/office/drawing/2014/main" id="{FA8140B9-A65F-4AE8-A2CF-1B7ABF0066B0}"/>
+                <a16:creationId xmlns:a16="http://schemas.microsoft.com/office/drawing/2014/main" id="{66013771-9200-4686-BDB5-BEAA65F93028}"/>
               </a:ext>
             </a:extLst>
           </p:cNvPr>
@@ -6306,7 +6306,7 @@
           <p:cNvPr id="12" name="">
             <a:extLst xmlns:a="http://schemas.openxmlformats.org/drawingml/2006/main">
               <a:ext uri="{FF2B5EF4-FFF2-40B4-BE49-F238E27FC236}">
-                <a16:creationId xmlns:a16="http://schemas.microsoft.com/office/drawing/2014/main" id="{F569A43D-09ED-4CC7-AF52-3B5F8FE58C66}"/>
+                <a16:creationId xmlns:a16="http://schemas.microsoft.com/office/drawing/2014/main" id="{FF5CDF91-D66D-4B45-91C2-E11CDDD0765B}"/>
               </a:ext>
             </a:extLst>
           </p:cNvPr>
@@ -6367,7 +6367,7 @@
           <p:cNvPr id="13" name="">
             <a:extLst xmlns:a="http://schemas.openxmlformats.org/drawingml/2006/main">
               <a:ext uri="{FF2B5EF4-FFF2-40B4-BE49-F238E27FC236}">
-                <a16:creationId xmlns:a16="http://schemas.microsoft.com/office/drawing/2014/main" id="{C4D301A5-3D89-4D4F-8829-7AB021C2B7C8}"/>
+                <a16:creationId xmlns:a16="http://schemas.microsoft.com/office/drawing/2014/main" id="{08DC4CA7-D0DE-4035-8A41-A5FC1C8BDB6E}"/>
               </a:ext>
             </a:extLst>
           </p:cNvPr>
@@ -6428,7 +6428,7 @@
           <p:cNvPr id="14" name="">
             <a:extLst xmlns:a="http://schemas.openxmlformats.org/drawingml/2006/main">
               <a:ext uri="{FF2B5EF4-FFF2-40B4-BE49-F238E27FC236}">
-                <a16:creationId xmlns:a16="http://schemas.microsoft.com/office/drawing/2014/main" id="{047452E0-C304-41FE-8E7A-CD16B69C4C51}"/>
+                <a16:creationId xmlns:a16="http://schemas.microsoft.com/office/drawing/2014/main" id="{528C7499-CB39-48DA-A981-C66FDEF86758}"/>
               </a:ext>
             </a:extLst>
           </p:cNvPr>
@@ -6463,7 +6463,7 @@
           <p:cNvPr id="15" name="">
             <a:extLst xmlns:a="http://schemas.openxmlformats.org/drawingml/2006/main">
               <a:ext uri="{FF2B5EF4-FFF2-40B4-BE49-F238E27FC236}">
-                <a16:creationId xmlns:a16="http://schemas.microsoft.com/office/drawing/2014/main" id="{7A771576-1228-4C7C-9A03-35EFD34BB245}"/>
+                <a16:creationId xmlns:a16="http://schemas.microsoft.com/office/drawing/2014/main" id="{ACD15E77-19A1-427F-81D0-3B86431031FC}"/>
               </a:ext>
             </a:extLst>
           </p:cNvPr>
@@ -6524,7 +6524,7 @@
           <p:cNvPr id="16" name="">
             <a:extLst xmlns:a="http://schemas.openxmlformats.org/drawingml/2006/main">
               <a:ext uri="{FF2B5EF4-FFF2-40B4-BE49-F238E27FC236}">
-                <a16:creationId xmlns:a16="http://schemas.microsoft.com/office/drawing/2014/main" id="{B1556328-D3FC-4C1C-98B4-C9FB168B652D}"/>
+                <a16:creationId xmlns:a16="http://schemas.microsoft.com/office/drawing/2014/main" id="{EB7256B1-A520-4AC6-8BD8-61F7B63C3370}"/>
               </a:ext>
             </a:extLst>
           </p:cNvPr>
@@ -6585,7 +6585,7 @@
           <p:cNvPr id="17" name="">
             <a:extLst xmlns:a="http://schemas.openxmlformats.org/drawingml/2006/main">
               <a:ext uri="{FF2B5EF4-FFF2-40B4-BE49-F238E27FC236}">
-                <a16:creationId xmlns:a16="http://schemas.microsoft.com/office/drawing/2014/main" id="{D684B5CC-F8E9-4524-9B9A-6506278D7BCC}"/>
+                <a16:creationId xmlns:a16="http://schemas.microsoft.com/office/drawing/2014/main" id="{2AA49DA0-4FB1-499B-BA0F-C8DECC979B3E}"/>
               </a:ext>
             </a:extLst>
           </p:cNvPr>
@@ -6620,7 +6620,7 @@
           <p:cNvPr id="18" name="">
             <a:extLst xmlns:a="http://schemas.openxmlformats.org/drawingml/2006/main">
               <a:ext uri="{FF2B5EF4-FFF2-40B4-BE49-F238E27FC236}">
-                <a16:creationId xmlns:a16="http://schemas.microsoft.com/office/drawing/2014/main" id="{D5B38C85-0734-4AD2-9D9E-945874F36A88}"/>
+                <a16:creationId xmlns:a16="http://schemas.microsoft.com/office/drawing/2014/main" id="{C2CF763E-BE25-423B-92D8-9ABD89245A55}"/>
               </a:ext>
             </a:extLst>
           </p:cNvPr>
@@ -6681,7 +6681,7 @@
           <p:cNvPr id="19" name="">
             <a:extLst xmlns:a="http://schemas.openxmlformats.org/drawingml/2006/main">
               <a:ext uri="{FF2B5EF4-FFF2-40B4-BE49-F238E27FC236}">
-                <a16:creationId xmlns:a16="http://schemas.microsoft.com/office/drawing/2014/main" id="{EE888441-231E-4085-8425-7E58789DCCB1}"/>
+                <a16:creationId xmlns:a16="http://schemas.microsoft.com/office/drawing/2014/main" id="{901E840D-BECF-4C9C-BF90-282FA77F1CBC}"/>
               </a:ext>
             </a:extLst>
           </p:cNvPr>
@@ -6742,7 +6742,7 @@
           <p:cNvPr id="20" name="">
             <a:extLst xmlns:a="http://schemas.openxmlformats.org/drawingml/2006/main">
               <a:ext uri="{FF2B5EF4-FFF2-40B4-BE49-F238E27FC236}">
-                <a16:creationId xmlns:a16="http://schemas.microsoft.com/office/drawing/2014/main" id="{02C07635-5925-488F-9A57-9010A73D1CDC}"/>
+                <a16:creationId xmlns:a16="http://schemas.microsoft.com/office/drawing/2014/main" id="{8C3B2ACA-36D9-444E-A52D-0AF937BF7599}"/>
               </a:ext>
             </a:extLst>
           </p:cNvPr>
@@ -6777,7 +6777,7 @@
           <p:cNvPr id="21" name="">
             <a:extLst xmlns:a="http://schemas.openxmlformats.org/drawingml/2006/main">
               <a:ext uri="{FF2B5EF4-FFF2-40B4-BE49-F238E27FC236}">
-                <a16:creationId xmlns:a16="http://schemas.microsoft.com/office/drawing/2014/main" id="{FE530A04-B818-42D6-8EDC-FBEED45AE075}"/>
+                <a16:creationId xmlns:a16="http://schemas.microsoft.com/office/drawing/2014/main" id="{E604C03B-7CC2-404E-B4E6-CFFC2F2FB9EC}"/>
               </a:ext>
             </a:extLst>
           </p:cNvPr>
@@ -6838,7 +6838,7 @@
           <p:cNvPr id="22" name="">
             <a:extLst xmlns:a="http://schemas.openxmlformats.org/drawingml/2006/main">
               <a:ext uri="{FF2B5EF4-FFF2-40B4-BE49-F238E27FC236}">
-                <a16:creationId xmlns:a16="http://schemas.microsoft.com/office/drawing/2014/main" id="{CBF2E0A8-7831-4500-A22D-7FC295511BF5}"/>
+                <a16:creationId xmlns:a16="http://schemas.microsoft.com/office/drawing/2014/main" id="{C59BE38B-6D86-48DE-91A1-803CB4BEB4B4}"/>
               </a:ext>
             </a:extLst>
           </p:cNvPr>
@@ -7029,7 +7029,7 @@
           <p:cNvPr id="28" name="">
             <a:extLst xmlns:a="http://schemas.openxmlformats.org/drawingml/2006/main">
               <a:ext uri="{FF2B5EF4-FFF2-40B4-BE49-F238E27FC236}">
-                <a16:creationId xmlns:a16="http://schemas.microsoft.com/office/drawing/2014/main" id="{02AC6C72-F2D5-4361-BCA7-E86C01804702}"/>
+                <a16:creationId xmlns:a16="http://schemas.microsoft.com/office/drawing/2014/main" id="{C439CEB6-8E58-4E22-A097-9C4E13982BF9}"/>
               </a:ext>
             </a:extLst>
           </p:cNvPr>
@@ -7090,7 +7090,7 @@
           <p:cNvPr id="29" name="">
             <a:extLst xmlns:a="http://schemas.openxmlformats.org/drawingml/2006/main">
               <a:ext uri="{FF2B5EF4-FFF2-40B4-BE49-F238E27FC236}">
-                <a16:creationId xmlns:a16="http://schemas.microsoft.com/office/drawing/2014/main" id="{73E00D6F-EEF1-4572-BCD0-E31C410096FC}"/>
+                <a16:creationId xmlns:a16="http://schemas.microsoft.com/office/drawing/2014/main" id="{AB4B9DC3-7B4B-46B0-B369-4D75D348E798}"/>
               </a:ext>
             </a:extLst>
           </p:cNvPr>
@@ -7151,7 +7151,7 @@
           <p:cNvPr id="30" name="">
             <a:extLst xmlns:a="http://schemas.openxmlformats.org/drawingml/2006/main">
               <a:ext uri="{FF2B5EF4-FFF2-40B4-BE49-F238E27FC236}">
-                <a16:creationId xmlns:a16="http://schemas.microsoft.com/office/drawing/2014/main" id="{CAF469C2-B1EC-45A8-A318-1CF656432286}"/>
+                <a16:creationId xmlns:a16="http://schemas.microsoft.com/office/drawing/2014/main" id="{15354E14-75A6-4837-8166-3055AFF3AE40}"/>
               </a:ext>
             </a:extLst>
           </p:cNvPr>
@@ -7212,7 +7212,7 @@
           <p:cNvPr id="31" name="">
             <a:extLst xmlns:a="http://schemas.openxmlformats.org/drawingml/2006/main">
               <a:ext uri="{FF2B5EF4-FFF2-40B4-BE49-F238E27FC236}">
-                <a16:creationId xmlns:a16="http://schemas.microsoft.com/office/drawing/2014/main" id="{CF1470FD-A5B9-4F3D-A508-DCFED7D825F2}"/>
+                <a16:creationId xmlns:a16="http://schemas.microsoft.com/office/drawing/2014/main" id="{E4637F34-07F7-4ADA-A6B5-5E4CCE56A8C2}"/>
               </a:ext>
             </a:extLst>
           </p:cNvPr>
@@ -7273,7 +7273,7 @@
           <p:cNvPr id="32" name="">
             <a:extLst xmlns:a="http://schemas.openxmlformats.org/drawingml/2006/main">
               <a:ext uri="{FF2B5EF4-FFF2-40B4-BE49-F238E27FC236}">
-                <a16:creationId xmlns:a16="http://schemas.microsoft.com/office/drawing/2014/main" id="{92FBE816-4235-4D9D-A4DC-CF291C6A179D}"/>
+                <a16:creationId xmlns:a16="http://schemas.microsoft.com/office/drawing/2014/main" id="{70FA98F0-7C81-42E4-95DA-EDA04CB2886F}"/>
               </a:ext>
             </a:extLst>
           </p:cNvPr>
@@ -7334,7 +7334,7 @@
           <p:cNvPr id="33" name="">
             <a:extLst xmlns:a="http://schemas.openxmlformats.org/drawingml/2006/main">
               <a:ext uri="{FF2B5EF4-FFF2-40B4-BE49-F238E27FC236}">
-                <a16:creationId xmlns:a16="http://schemas.microsoft.com/office/drawing/2014/main" id="{F81CA93B-286D-4C7B-BFBC-1D7F1236CB7A}"/>
+                <a16:creationId xmlns:a16="http://schemas.microsoft.com/office/drawing/2014/main" id="{842664D5-6120-4B6B-A1E4-DD5CE099AD9D}"/>
               </a:ext>
             </a:extLst>
           </p:cNvPr>
@@ -7363,7 +7363,7 @@
     </p:spTree>
     <p:extLst>
       <p:ext uri="{BB962C8B-B14F-4D97-AF65-F5344CB8AC3E}">
-        <p14:creationId xmlns:p14="http://schemas.microsoft.com/office/powerpoint/2010/main" val="955048991"/>
+        <p14:creationId xmlns:p14="http://schemas.microsoft.com/office/powerpoint/2010/main" val="679583710"/>
       </p:ext>
     </p:extLst>
   </p:cSld>
@@ -7394,7 +7394,7 @@
           <p:cNvPr id="22" name="">
             <a:extLst xmlns:a="http://schemas.openxmlformats.org/drawingml/2006/main">
               <a:ext uri="{FF2B5EF4-FFF2-40B4-BE49-F238E27FC236}">
-                <a16:creationId xmlns:a16="http://schemas.microsoft.com/office/drawing/2014/main" id="{D689F0A0-2CB5-4509-B75F-D2B457EEFBDB}"/>
+                <a16:creationId xmlns:a16="http://schemas.microsoft.com/office/drawing/2014/main" id="{2A7E0155-B18B-407E-968F-A2E7049C432F}"/>
               </a:ext>
             </a:extLst>
           </p:cNvPr>
@@ -7424,7 +7424,7 @@
           <p:cNvPr id="2" name="">
             <a:extLst xmlns:a="http://schemas.openxmlformats.org/drawingml/2006/main">
               <a:ext uri="{FF2B5EF4-FFF2-40B4-BE49-F238E27FC236}">
-                <a16:creationId xmlns:a16="http://schemas.microsoft.com/office/drawing/2014/main" id="{DDF02826-9451-4E6F-BFC2-8429210FFC2C}"/>
+                <a16:creationId xmlns:a16="http://schemas.microsoft.com/office/drawing/2014/main" id="{2BD25ECC-BBE9-458C-9E48-232C14E89990}"/>
               </a:ext>
             </a:extLst>
           </p:cNvPr>
@@ -7485,7 +7485,7 @@
           <p:cNvPr id="3" name="">
             <a:extLst xmlns:a="http://schemas.openxmlformats.org/drawingml/2006/main">
               <a:ext uri="{FF2B5EF4-FFF2-40B4-BE49-F238E27FC236}">
-                <a16:creationId xmlns:a16="http://schemas.microsoft.com/office/drawing/2014/main" id="{8B698BF8-C005-4FF4-8AE4-A23DA7E6D69E}"/>
+                <a16:creationId xmlns:a16="http://schemas.microsoft.com/office/drawing/2014/main" id="{B89CF861-2EEE-428C-ABBD-C562212A61FF}"/>
               </a:ext>
             </a:extLst>
           </p:cNvPr>
@@ -7546,7 +7546,7 @@
           <p:cNvPr id="4" name="">
             <a:extLst xmlns:a="http://schemas.openxmlformats.org/drawingml/2006/main">
               <a:ext uri="{FF2B5EF4-FFF2-40B4-BE49-F238E27FC236}">
-                <a16:creationId xmlns:a16="http://schemas.microsoft.com/office/drawing/2014/main" id="{5D4B8AF6-573A-4481-A055-874042827B94}"/>
+                <a16:creationId xmlns:a16="http://schemas.microsoft.com/office/drawing/2014/main" id="{9C54001B-7962-437D-90CA-FD091561E4AE}"/>
               </a:ext>
             </a:extLst>
           </p:cNvPr>
@@ -7661,7 +7661,7 @@
           <p:cNvPr id="5" name="">
             <a:extLst xmlns:a="http://schemas.openxmlformats.org/drawingml/2006/main">
               <a:ext uri="{FF2B5EF4-FFF2-40B4-BE49-F238E27FC236}">
-                <a16:creationId xmlns:a16="http://schemas.microsoft.com/office/drawing/2014/main" id="{49ED6DED-9025-434A-B526-F388DC0E8A57}"/>
+                <a16:creationId xmlns:a16="http://schemas.microsoft.com/office/drawing/2014/main" id="{88F6D627-73D3-448D-98BA-E648FB719C7F}"/>
               </a:ext>
             </a:extLst>
           </p:cNvPr>
@@ -7691,7 +7691,7 @@
           <p:cNvPr id="6" name="">
             <a:extLst xmlns:a="http://schemas.openxmlformats.org/drawingml/2006/main">
               <a:ext uri="{FF2B5EF4-FFF2-40B4-BE49-F238E27FC236}">
-                <a16:creationId xmlns:a16="http://schemas.microsoft.com/office/drawing/2014/main" id="{36DFD3CB-AF51-4426-9776-6FECBB68C628}"/>
+                <a16:creationId xmlns:a16="http://schemas.microsoft.com/office/drawing/2014/main" id="{5E11C455-94A0-46CE-95FF-B448F3BFACAB}"/>
               </a:ext>
             </a:extLst>
           </p:cNvPr>
@@ -7752,7 +7752,7 @@
           <p:cNvPr id="7" name="">
             <a:extLst xmlns:a="http://schemas.openxmlformats.org/drawingml/2006/main">
               <a:ext uri="{FF2B5EF4-FFF2-40B4-BE49-F238E27FC236}">
-                <a16:creationId xmlns:a16="http://schemas.microsoft.com/office/drawing/2014/main" id="{42A85909-D464-4FD3-9028-499710FD213F}"/>
+                <a16:creationId xmlns:a16="http://schemas.microsoft.com/office/drawing/2014/main" id="{C4D9AE2D-37F0-4373-BD3D-66716B60F5FE}"/>
               </a:ext>
             </a:extLst>
           </p:cNvPr>
@@ -7813,7 +7813,7 @@
           <p:cNvPr id="8" name="">
             <a:extLst xmlns:a="http://schemas.openxmlformats.org/drawingml/2006/main">
               <a:ext uri="{FF2B5EF4-FFF2-40B4-BE49-F238E27FC236}">
-                <a16:creationId xmlns:a16="http://schemas.microsoft.com/office/drawing/2014/main" id="{F643617B-1564-472C-8DE5-D307C9E7C589}"/>
+                <a16:creationId xmlns:a16="http://schemas.microsoft.com/office/drawing/2014/main" id="{A6C70DDA-1BB0-4124-85F1-C6454B6F9BE8}"/>
               </a:ext>
             </a:extLst>
           </p:cNvPr>
@@ -7874,7 +7874,7 @@
           <p:cNvPr id="9" name="">
             <a:extLst xmlns:a="http://schemas.openxmlformats.org/drawingml/2006/main">
               <a:ext uri="{FF2B5EF4-FFF2-40B4-BE49-F238E27FC236}">
-                <a16:creationId xmlns:a16="http://schemas.microsoft.com/office/drawing/2014/main" id="{C4623B6F-F154-4038-BE58-09D066EAE27F}"/>
+                <a16:creationId xmlns:a16="http://schemas.microsoft.com/office/drawing/2014/main" id="{70E42688-5C15-4E56-8D92-F3418CFA0600}"/>
               </a:ext>
             </a:extLst>
           </p:cNvPr>
@@ -7904,7 +7904,7 @@
           <p:cNvPr id="10" name="">
             <a:extLst xmlns:a="http://schemas.openxmlformats.org/drawingml/2006/main">
               <a:ext uri="{FF2B5EF4-FFF2-40B4-BE49-F238E27FC236}">
-                <a16:creationId xmlns:a16="http://schemas.microsoft.com/office/drawing/2014/main" id="{FE98DE7F-A39F-4934-82A1-3A135A13F8E8}"/>
+                <a16:creationId xmlns:a16="http://schemas.microsoft.com/office/drawing/2014/main" id="{4BD0FFF0-87F8-44A0-BB44-41AC672E77FD}"/>
               </a:ext>
             </a:extLst>
           </p:cNvPr>
@@ -7965,7 +7965,7 @@
           <p:cNvPr id="11" name="">
             <a:extLst xmlns:a="http://schemas.openxmlformats.org/drawingml/2006/main">
               <a:ext uri="{FF2B5EF4-FFF2-40B4-BE49-F238E27FC236}">
-                <a16:creationId xmlns:a16="http://schemas.microsoft.com/office/drawing/2014/main" id="{3F87D695-4D3A-4BF6-908E-6F8063FF6B92}"/>
+                <a16:creationId xmlns:a16="http://schemas.microsoft.com/office/drawing/2014/main" id="{2C1DBED1-F96E-45A6-9069-4FB371BC0A79}"/>
               </a:ext>
             </a:extLst>
           </p:cNvPr>
@@ -8026,7 +8026,7 @@
           <p:cNvPr id="12" name="">
             <a:extLst xmlns:a="http://schemas.openxmlformats.org/drawingml/2006/main">
               <a:ext uri="{FF2B5EF4-FFF2-40B4-BE49-F238E27FC236}">
-                <a16:creationId xmlns:a16="http://schemas.microsoft.com/office/drawing/2014/main" id="{2CEBECCA-AAB4-4BD0-8EF9-19F71083A3C9}"/>
+                <a16:creationId xmlns:a16="http://schemas.microsoft.com/office/drawing/2014/main" id="{55851126-791E-48D9-B303-E2BDB3C5A4C9}"/>
               </a:ext>
             </a:extLst>
           </p:cNvPr>
@@ -8087,7 +8087,7 @@
           <p:cNvPr id="13" name="">
             <a:extLst xmlns:a="http://schemas.openxmlformats.org/drawingml/2006/main">
               <a:ext uri="{FF2B5EF4-FFF2-40B4-BE49-F238E27FC236}">
-                <a16:creationId xmlns:a16="http://schemas.microsoft.com/office/drawing/2014/main" id="{14E9436D-E33D-44B3-AD23-5B440138C882}"/>
+                <a16:creationId xmlns:a16="http://schemas.microsoft.com/office/drawing/2014/main" id="{EF95438C-A737-4673-B816-7008E5F8B34A}"/>
               </a:ext>
             </a:extLst>
           </p:cNvPr>
@@ -8117,7 +8117,7 @@
           <p:cNvPr id="14" name="">
             <a:extLst xmlns:a="http://schemas.openxmlformats.org/drawingml/2006/main">
               <a:ext uri="{FF2B5EF4-FFF2-40B4-BE49-F238E27FC236}">
-                <a16:creationId xmlns:a16="http://schemas.microsoft.com/office/drawing/2014/main" id="{1279F1F4-CDBA-4450-A533-32A9593CA54A}"/>
+                <a16:creationId xmlns:a16="http://schemas.microsoft.com/office/drawing/2014/main" id="{B3EFCA48-F92B-4DBD-A023-08A6DBD6B174}"/>
               </a:ext>
             </a:extLst>
           </p:cNvPr>
@@ -8178,7 +8178,7 @@
           <p:cNvPr id="15" name="">
             <a:extLst xmlns:a="http://schemas.openxmlformats.org/drawingml/2006/main">
               <a:ext uri="{FF2B5EF4-FFF2-40B4-BE49-F238E27FC236}">
-                <a16:creationId xmlns:a16="http://schemas.microsoft.com/office/drawing/2014/main" id="{B50E0D1C-76F9-4829-B298-7AFBC8D6CBEF}"/>
+                <a16:creationId xmlns:a16="http://schemas.microsoft.com/office/drawing/2014/main" id="{9CA6D2C8-43E7-4892-83EB-754CA5628939}"/>
               </a:ext>
             </a:extLst>
           </p:cNvPr>
@@ -8239,7 +8239,7 @@
           <p:cNvPr id="16" name="">
             <a:extLst xmlns:a="http://schemas.openxmlformats.org/drawingml/2006/main">
               <a:ext uri="{FF2B5EF4-FFF2-40B4-BE49-F238E27FC236}">
-                <a16:creationId xmlns:a16="http://schemas.microsoft.com/office/drawing/2014/main" id="{7105388C-8C12-46E7-9EF7-CA9E57E85A81}"/>
+                <a16:creationId xmlns:a16="http://schemas.microsoft.com/office/drawing/2014/main" id="{ABE97E76-F755-4516-8FE2-3F265742A75C}"/>
               </a:ext>
             </a:extLst>
           </p:cNvPr>
@@ -8300,7 +8300,7 @@
           <p:cNvPr id="17" name="">
             <a:extLst xmlns:a="http://schemas.openxmlformats.org/drawingml/2006/main">
               <a:ext uri="{FF2B5EF4-FFF2-40B4-BE49-F238E27FC236}">
-                <a16:creationId xmlns:a16="http://schemas.microsoft.com/office/drawing/2014/main" id="{391A384F-DAD9-44F1-90E8-478C97E9C901}"/>
+                <a16:creationId xmlns:a16="http://schemas.microsoft.com/office/drawing/2014/main" id="{3C2171E5-8E88-47A2-AA56-E4BD6915F714}"/>
               </a:ext>
             </a:extLst>
           </p:cNvPr>
@@ -8361,7 +8361,7 @@
           <p:cNvPr id="18" name="">
             <a:extLst xmlns:a="http://schemas.openxmlformats.org/drawingml/2006/main">
               <a:ext uri="{FF2B5EF4-FFF2-40B4-BE49-F238E27FC236}">
-                <a16:creationId xmlns:a16="http://schemas.microsoft.com/office/drawing/2014/main" id="{F9007655-CF2A-4BC2-A11B-5E882856039A}"/>
+                <a16:creationId xmlns:a16="http://schemas.microsoft.com/office/drawing/2014/main" id="{34131537-61CF-45A2-B407-12A3F2AC78B7}"/>
               </a:ext>
             </a:extLst>
           </p:cNvPr>
@@ -8422,7 +8422,7 @@
           <p:cNvPr id="19" name="">
             <a:extLst xmlns:a="http://schemas.openxmlformats.org/drawingml/2006/main">
               <a:ext uri="{FF2B5EF4-FFF2-40B4-BE49-F238E27FC236}">
-                <a16:creationId xmlns:a16="http://schemas.microsoft.com/office/drawing/2014/main" id="{BB3DC38E-A7E5-4EF3-8413-62CBC085BC44}"/>
+                <a16:creationId xmlns:a16="http://schemas.microsoft.com/office/drawing/2014/main" id="{A78959AB-8CC8-47F1-9D25-CE8383D9AD6D}"/>
               </a:ext>
             </a:extLst>
           </p:cNvPr>
@@ -8483,7 +8483,7 @@
           <p:cNvPr id="20" name="">
             <a:extLst xmlns:a="http://schemas.openxmlformats.org/drawingml/2006/main">
               <a:ext uri="{FF2B5EF4-FFF2-40B4-BE49-F238E27FC236}">
-                <a16:creationId xmlns:a16="http://schemas.microsoft.com/office/drawing/2014/main" id="{3FA2F7F6-3D7D-44BC-8768-9B4AE6328C26}"/>
+                <a16:creationId xmlns:a16="http://schemas.microsoft.com/office/drawing/2014/main" id="{6614E49B-B69F-4D0A-8D24-727A2FD4683A}"/>
               </a:ext>
             </a:extLst>
           </p:cNvPr>
@@ -8544,7 +8544,7 @@
           <p:cNvPr id="21" name="">
             <a:extLst xmlns:a="http://schemas.openxmlformats.org/drawingml/2006/main">
               <a:ext uri="{FF2B5EF4-FFF2-40B4-BE49-F238E27FC236}">
-                <a16:creationId xmlns:a16="http://schemas.microsoft.com/office/drawing/2014/main" id="{EA5E44E6-A541-4337-8A85-AC0EE17044D1}"/>
+                <a16:creationId xmlns:a16="http://schemas.microsoft.com/office/drawing/2014/main" id="{3D0C16E1-77E5-4BC9-BFE9-A66CC9EE6EE5}"/>
               </a:ext>
             </a:extLst>
           </p:cNvPr>
@@ -8573,7 +8573,7 @@
     </p:spTree>
     <p:extLst>
       <p:ext uri="{BB962C8B-B14F-4D97-AF65-F5344CB8AC3E}">
-        <p14:creationId xmlns:p14="http://schemas.microsoft.com/office/powerpoint/2010/main" val="1342132842"/>
+        <p14:creationId xmlns:p14="http://schemas.microsoft.com/office/powerpoint/2010/main" val="695903740"/>
       </p:ext>
     </p:extLst>
   </p:cSld>
@@ -8604,7 +8604,7 @@
           <p:cNvPr id="27" name="">
             <a:extLst xmlns:a="http://schemas.openxmlformats.org/drawingml/2006/main">
               <a:ext uri="{FF2B5EF4-FFF2-40B4-BE49-F238E27FC236}">
-                <a16:creationId xmlns:a16="http://schemas.microsoft.com/office/drawing/2014/main" id="{112C72D8-B985-4261-B07D-3DD6BD618973}"/>
+                <a16:creationId xmlns:a16="http://schemas.microsoft.com/office/drawing/2014/main" id="{1DB20077-640E-47D8-B132-421F572DEB63}"/>
               </a:ext>
             </a:extLst>
           </p:cNvPr>
@@ -8634,7 +8634,7 @@
           <p:cNvPr id="2" name="">
             <a:extLst xmlns:a="http://schemas.openxmlformats.org/drawingml/2006/main">
               <a:ext uri="{FF2B5EF4-FFF2-40B4-BE49-F238E27FC236}">
-                <a16:creationId xmlns:a16="http://schemas.microsoft.com/office/drawing/2014/main" id="{04ACCEC0-5FF4-450B-8DD0-B32F6603ECC1}"/>
+                <a16:creationId xmlns:a16="http://schemas.microsoft.com/office/drawing/2014/main" id="{99E3EB69-DC52-408B-B456-4D4860A34C56}"/>
               </a:ext>
             </a:extLst>
           </p:cNvPr>
@@ -8695,7 +8695,7 @@
           <p:cNvPr id="3" name="">
             <a:extLst xmlns:a="http://schemas.openxmlformats.org/drawingml/2006/main">
               <a:ext uri="{FF2B5EF4-FFF2-40B4-BE49-F238E27FC236}">
-                <a16:creationId xmlns:a16="http://schemas.microsoft.com/office/drawing/2014/main" id="{A84544DF-92B2-446C-ACD1-FE00B09FF652}"/>
+                <a16:creationId xmlns:a16="http://schemas.microsoft.com/office/drawing/2014/main" id="{42F3ABB2-A707-4B83-A80A-09250C3C4E63}"/>
               </a:ext>
             </a:extLst>
           </p:cNvPr>
@@ -8756,7 +8756,7 @@
           <p:cNvPr id="4" name="">
             <a:extLst xmlns:a="http://schemas.openxmlformats.org/drawingml/2006/main">
               <a:ext uri="{FF2B5EF4-FFF2-40B4-BE49-F238E27FC236}">
-                <a16:creationId xmlns:a16="http://schemas.microsoft.com/office/drawing/2014/main" id="{11C11EA9-2CDE-414D-9D2B-27435F87C9A6}"/>
+                <a16:creationId xmlns:a16="http://schemas.microsoft.com/office/drawing/2014/main" id="{E0F13781-997E-4DBE-AF97-DD638802C9D5}"/>
               </a:ext>
             </a:extLst>
           </p:cNvPr>
@@ -8817,7 +8817,7 @@
           <p:cNvPr id="5" name="">
             <a:extLst xmlns:a="http://schemas.openxmlformats.org/drawingml/2006/main">
               <a:ext uri="{FF2B5EF4-FFF2-40B4-BE49-F238E27FC236}">
-                <a16:creationId xmlns:a16="http://schemas.microsoft.com/office/drawing/2014/main" id="{49DB5927-DA89-4D1A-A579-D9E6BDE9E3F1}"/>
+                <a16:creationId xmlns:a16="http://schemas.microsoft.com/office/drawing/2014/main" id="{19ED5FE9-2E9E-42ED-89B7-F235A279F9AE}"/>
               </a:ext>
             </a:extLst>
           </p:cNvPr>
@@ -8848,7 +8848,7 @@
           <p:cNvPr id="6" name="">
             <a:extLst xmlns:a="http://schemas.openxmlformats.org/drawingml/2006/main">
               <a:ext uri="{FF2B5EF4-FFF2-40B4-BE49-F238E27FC236}">
-                <a16:creationId xmlns:a16="http://schemas.microsoft.com/office/drawing/2014/main" id="{C52A5C83-E3C5-4F84-B5D5-D8582BEFB772}"/>
+                <a16:creationId xmlns:a16="http://schemas.microsoft.com/office/drawing/2014/main" id="{CD30DE93-4D67-4C34-AD2A-539C7B2B77E0}"/>
               </a:ext>
             </a:extLst>
           </p:cNvPr>
@@ -8909,7 +8909,7 @@
           <p:cNvPr id="7" name="">
             <a:extLst xmlns:a="http://schemas.openxmlformats.org/drawingml/2006/main">
               <a:ext uri="{FF2B5EF4-FFF2-40B4-BE49-F238E27FC236}">
-                <a16:creationId xmlns:a16="http://schemas.microsoft.com/office/drawing/2014/main" id="{75D6E629-9D29-4693-910F-C15B72076469}"/>
+                <a16:creationId xmlns:a16="http://schemas.microsoft.com/office/drawing/2014/main" id="{4CE305BA-B575-472D-B2D1-FC4651966522}"/>
               </a:ext>
             </a:extLst>
           </p:cNvPr>
@@ -8970,7 +8970,7 @@
           <p:cNvPr id="8" name="">
             <a:extLst xmlns:a="http://schemas.openxmlformats.org/drawingml/2006/main">
               <a:ext uri="{FF2B5EF4-FFF2-40B4-BE49-F238E27FC236}">
-                <a16:creationId xmlns:a16="http://schemas.microsoft.com/office/drawing/2014/main" id="{EAB46EB1-4CE7-46F4-A50C-B44137EB96FD}"/>
+                <a16:creationId xmlns:a16="http://schemas.microsoft.com/office/drawing/2014/main" id="{FA7A8E99-A253-4D7E-B31F-8B8750EE8661}"/>
               </a:ext>
             </a:extLst>
           </p:cNvPr>
@@ -9058,7 +9058,7 @@
           <p:cNvPr id="9" name="">
             <a:extLst xmlns:a="http://schemas.openxmlformats.org/drawingml/2006/main">
               <a:ext uri="{FF2B5EF4-FFF2-40B4-BE49-F238E27FC236}">
-                <a16:creationId xmlns:a16="http://schemas.microsoft.com/office/drawing/2014/main" id="{F5608B44-F72D-47CE-AD46-C7D8A1112194}"/>
+                <a16:creationId xmlns:a16="http://schemas.microsoft.com/office/drawing/2014/main" id="{3BA1C8A9-A952-4C97-8559-829A41FEEC9D}"/>
               </a:ext>
             </a:extLst>
           </p:cNvPr>
@@ -9090,7 +9090,7 @@
           <p:cNvPr id="10" name="">
             <a:extLst xmlns:a="http://schemas.openxmlformats.org/drawingml/2006/main">
               <a:ext uri="{FF2B5EF4-FFF2-40B4-BE49-F238E27FC236}">
-                <a16:creationId xmlns:a16="http://schemas.microsoft.com/office/drawing/2014/main" id="{2B0332F6-9F01-4AE9-BAF8-A47E31372878}"/>
+                <a16:creationId xmlns:a16="http://schemas.microsoft.com/office/drawing/2014/main" id="{E8857F9D-488C-48C5-978D-B9A8FC1B0672}"/>
               </a:ext>
             </a:extLst>
           </p:cNvPr>
@@ -9121,7 +9121,7 @@
           <p:cNvPr id="11" name="">
             <a:extLst xmlns:a="http://schemas.openxmlformats.org/drawingml/2006/main">
               <a:ext uri="{FF2B5EF4-FFF2-40B4-BE49-F238E27FC236}">
-                <a16:creationId xmlns:a16="http://schemas.microsoft.com/office/drawing/2014/main" id="{C1C2497C-E006-46E6-8A0B-693134937304}"/>
+                <a16:creationId xmlns:a16="http://schemas.microsoft.com/office/drawing/2014/main" id="{94A8B976-1925-414A-8F3F-C58EF6E31127}"/>
               </a:ext>
             </a:extLst>
           </p:cNvPr>
@@ -9182,7 +9182,7 @@
           <p:cNvPr id="12" name="">
             <a:extLst xmlns:a="http://schemas.openxmlformats.org/drawingml/2006/main">
               <a:ext uri="{FF2B5EF4-FFF2-40B4-BE49-F238E27FC236}">
-                <a16:creationId xmlns:a16="http://schemas.microsoft.com/office/drawing/2014/main" id="{73A47AB2-D8A2-4FBF-8BF9-2DCB4B85E085}"/>
+                <a16:creationId xmlns:a16="http://schemas.microsoft.com/office/drawing/2014/main" id="{3BBBC687-78E7-43B8-A85D-65DCB4EC70F8}"/>
               </a:ext>
             </a:extLst>
           </p:cNvPr>
@@ -9243,7 +9243,7 @@
           <p:cNvPr id="13" name="">
             <a:extLst xmlns:a="http://schemas.openxmlformats.org/drawingml/2006/main">
               <a:ext uri="{FF2B5EF4-FFF2-40B4-BE49-F238E27FC236}">
-                <a16:creationId xmlns:a16="http://schemas.microsoft.com/office/drawing/2014/main" id="{DC892AF7-187C-4DA5-A014-8F2D7A8850CA}"/>
+                <a16:creationId xmlns:a16="http://schemas.microsoft.com/office/drawing/2014/main" id="{A43103FC-25FB-4356-9EB7-F189FFFE5818}"/>
               </a:ext>
             </a:extLst>
           </p:cNvPr>
@@ -9331,7 +9331,7 @@
           <p:cNvPr id="14" name="">
             <a:extLst xmlns:a="http://schemas.openxmlformats.org/drawingml/2006/main">
               <a:ext uri="{FF2B5EF4-FFF2-40B4-BE49-F238E27FC236}">
-                <a16:creationId xmlns:a16="http://schemas.microsoft.com/office/drawing/2014/main" id="{4271C054-C406-4403-9B6D-5492F17397A2}"/>
+                <a16:creationId xmlns:a16="http://schemas.microsoft.com/office/drawing/2014/main" id="{1040F55D-7716-4EB0-A578-E311EC938F4E}"/>
               </a:ext>
             </a:extLst>
           </p:cNvPr>
@@ -9363,7 +9363,7 @@
           <p:cNvPr id="15" name="">
             <a:extLst xmlns:a="http://schemas.openxmlformats.org/drawingml/2006/main">
               <a:ext uri="{FF2B5EF4-FFF2-40B4-BE49-F238E27FC236}">
-                <a16:creationId xmlns:a16="http://schemas.microsoft.com/office/drawing/2014/main" id="{6D60F643-7DBD-435D-B98D-7A8DA3C3DD71}"/>
+                <a16:creationId xmlns:a16="http://schemas.microsoft.com/office/drawing/2014/main" id="{CCF48745-BAD4-49FA-9993-D2AD612FEAF5}"/>
               </a:ext>
             </a:extLst>
           </p:cNvPr>
@@ -9394,7 +9394,7 @@
           <p:cNvPr id="16" name="">
             <a:extLst xmlns:a="http://schemas.openxmlformats.org/drawingml/2006/main">
               <a:ext uri="{FF2B5EF4-FFF2-40B4-BE49-F238E27FC236}">
-                <a16:creationId xmlns:a16="http://schemas.microsoft.com/office/drawing/2014/main" id="{61827904-ABD3-4685-80AD-68BA53AAFEEB}"/>
+                <a16:creationId xmlns:a16="http://schemas.microsoft.com/office/drawing/2014/main" id="{FED67B19-C1D9-426C-83C4-AB1A7BFBE029}"/>
               </a:ext>
             </a:extLst>
           </p:cNvPr>
@@ -9455,7 +9455,7 @@
           <p:cNvPr id="17" name="">
             <a:extLst xmlns:a="http://schemas.openxmlformats.org/drawingml/2006/main">
               <a:ext uri="{FF2B5EF4-FFF2-40B4-BE49-F238E27FC236}">
-                <a16:creationId xmlns:a16="http://schemas.microsoft.com/office/drawing/2014/main" id="{AF1CD4D3-ABA2-4ED4-9F18-A13D2184076C}"/>
+                <a16:creationId xmlns:a16="http://schemas.microsoft.com/office/drawing/2014/main" id="{C8A6F82C-E69B-4CB8-AB4F-02070883E002}"/>
               </a:ext>
             </a:extLst>
           </p:cNvPr>
@@ -9516,7 +9516,7 @@
           <p:cNvPr id="18" name="">
             <a:extLst xmlns:a="http://schemas.openxmlformats.org/drawingml/2006/main">
               <a:ext uri="{FF2B5EF4-FFF2-40B4-BE49-F238E27FC236}">
-                <a16:creationId xmlns:a16="http://schemas.microsoft.com/office/drawing/2014/main" id="{9BDA90F7-4828-46EB-BC2B-C2E08F93D695}"/>
+                <a16:creationId xmlns:a16="http://schemas.microsoft.com/office/drawing/2014/main" id="{6589774C-344A-49E2-A8E3-67727A7E5402}"/>
               </a:ext>
             </a:extLst>
           </p:cNvPr>
@@ -9604,7 +9604,7 @@
           <p:cNvPr id="19" name="">
             <a:extLst xmlns:a="http://schemas.openxmlformats.org/drawingml/2006/main">
               <a:ext uri="{FF2B5EF4-FFF2-40B4-BE49-F238E27FC236}">
-                <a16:creationId xmlns:a16="http://schemas.microsoft.com/office/drawing/2014/main" id="{19AE3E19-E900-4284-B56A-74FC432F1394}"/>
+                <a16:creationId xmlns:a16="http://schemas.microsoft.com/office/drawing/2014/main" id="{209027AB-5323-44D5-BAE3-57C0A934F206}"/>
               </a:ext>
             </a:extLst>
           </p:cNvPr>
@@ -9636,7 +9636,7 @@
           <p:cNvPr id="20" name="">
             <a:extLst xmlns:a="http://schemas.openxmlformats.org/drawingml/2006/main">
               <a:ext uri="{FF2B5EF4-FFF2-40B4-BE49-F238E27FC236}">
-                <a16:creationId xmlns:a16="http://schemas.microsoft.com/office/drawing/2014/main" id="{077763CF-68A9-4E61-873C-D9DFCB8D4FC5}"/>
+                <a16:creationId xmlns:a16="http://schemas.microsoft.com/office/drawing/2014/main" id="{1D9AFBB0-566B-4CF9-BEE9-3EC3803F3F63}"/>
               </a:ext>
             </a:extLst>
           </p:cNvPr>
@@ -9667,7 +9667,7 @@
           <p:cNvPr id="21" name="">
             <a:extLst xmlns:a="http://schemas.openxmlformats.org/drawingml/2006/main">
               <a:ext uri="{FF2B5EF4-FFF2-40B4-BE49-F238E27FC236}">
-                <a16:creationId xmlns:a16="http://schemas.microsoft.com/office/drawing/2014/main" id="{6C8ECD6F-CDE3-45E2-9AAA-CF454BB83AE2}"/>
+                <a16:creationId xmlns:a16="http://schemas.microsoft.com/office/drawing/2014/main" id="{3C29B6F0-52FE-43F3-925B-15B83D55DF18}"/>
               </a:ext>
             </a:extLst>
           </p:cNvPr>
@@ -9728,7 +9728,7 @@
           <p:cNvPr id="22" name="">
             <a:extLst xmlns:a="http://schemas.openxmlformats.org/drawingml/2006/main">
               <a:ext uri="{FF2B5EF4-FFF2-40B4-BE49-F238E27FC236}">
-                <a16:creationId xmlns:a16="http://schemas.microsoft.com/office/drawing/2014/main" id="{0D4A3C20-0B99-493F-970C-E365165D31E9}"/>
+                <a16:creationId xmlns:a16="http://schemas.microsoft.com/office/drawing/2014/main" id="{01025CB3-542D-49AF-94EF-7E7FA68E8563}"/>
               </a:ext>
             </a:extLst>
           </p:cNvPr>
@@ -9789,7 +9789,7 @@
           <p:cNvPr id="23" name="">
             <a:extLst xmlns:a="http://schemas.openxmlformats.org/drawingml/2006/main">
               <a:ext uri="{FF2B5EF4-FFF2-40B4-BE49-F238E27FC236}">
-                <a16:creationId xmlns:a16="http://schemas.microsoft.com/office/drawing/2014/main" id="{DACADB6B-B3EA-4396-A263-45979DF7F633}"/>
+                <a16:creationId xmlns:a16="http://schemas.microsoft.com/office/drawing/2014/main" id="{8D4F5FD8-B505-4D31-AD31-B481DBBBA7C5}"/>
               </a:ext>
             </a:extLst>
           </p:cNvPr>
@@ -9877,7 +9877,7 @@
           <p:cNvPr id="24" name="">
             <a:extLst xmlns:a="http://schemas.openxmlformats.org/drawingml/2006/main">
               <a:ext uri="{FF2B5EF4-FFF2-40B4-BE49-F238E27FC236}">
-                <a16:creationId xmlns:a16="http://schemas.microsoft.com/office/drawing/2014/main" id="{9BA95692-4ED5-49CB-8816-E2F8F376D13E}"/>
+                <a16:creationId xmlns:a16="http://schemas.microsoft.com/office/drawing/2014/main" id="{477CAE97-929D-4659-937F-51B8FC7F3780}"/>
               </a:ext>
             </a:extLst>
           </p:cNvPr>
@@ -9909,7 +9909,7 @@
           <p:cNvPr id="25" name="">
             <a:extLst xmlns:a="http://schemas.openxmlformats.org/drawingml/2006/main">
               <a:ext uri="{FF2B5EF4-FFF2-40B4-BE49-F238E27FC236}">
-                <a16:creationId xmlns:a16="http://schemas.microsoft.com/office/drawing/2014/main" id="{5DEE9EFF-7E17-4409-97DE-41C6473D3BC9}"/>
+                <a16:creationId xmlns:a16="http://schemas.microsoft.com/office/drawing/2014/main" id="{32BFB40F-CF78-40F4-9E5D-51146DEBA2B6}"/>
               </a:ext>
             </a:extLst>
           </p:cNvPr>
@@ -9970,7 +9970,7 @@
           <p:cNvPr id="26" name="">
             <a:extLst xmlns:a="http://schemas.openxmlformats.org/drawingml/2006/main">
               <a:ext uri="{FF2B5EF4-FFF2-40B4-BE49-F238E27FC236}">
-                <a16:creationId xmlns:a16="http://schemas.microsoft.com/office/drawing/2014/main" id="{1BA9BFAD-74E2-45E8-8EEB-8A96FBDF5F29}"/>
+                <a16:creationId xmlns:a16="http://schemas.microsoft.com/office/drawing/2014/main" id="{A097C915-444C-40B1-9054-0137527C5081}"/>
               </a:ext>
             </a:extLst>
           </p:cNvPr>
@@ -10029,7 +10029,7 @@
     </p:spTree>
     <p:extLst>
       <p:ext uri="{BB962C8B-B14F-4D97-AF65-F5344CB8AC3E}">
-        <p14:creationId xmlns:p14="http://schemas.microsoft.com/office/powerpoint/2010/main" val="2014430975"/>
+        <p14:creationId xmlns:p14="http://schemas.microsoft.com/office/powerpoint/2010/main" val="1878064113"/>
       </p:ext>
     </p:extLst>
   </p:cSld>
@@ -10060,7 +10060,7 @@
           <p:cNvPr id="49" name="">
             <a:extLst xmlns:a="http://schemas.openxmlformats.org/drawingml/2006/main">
               <a:ext uri="{FF2B5EF4-FFF2-40B4-BE49-F238E27FC236}">
-                <a16:creationId xmlns:a16="http://schemas.microsoft.com/office/drawing/2014/main" id="{B355CEE5-2E0B-474C-8DC7-FFD99F070379}"/>
+                <a16:creationId xmlns:a16="http://schemas.microsoft.com/office/drawing/2014/main" id="{7B722D90-0EAC-4408-81B9-D441DDBDE421}"/>
               </a:ext>
             </a:extLst>
           </p:cNvPr>
@@ -10090,7 +10090,7 @@
           <p:cNvPr id="2" name="">
             <a:extLst xmlns:a="http://schemas.openxmlformats.org/drawingml/2006/main">
               <a:ext uri="{FF2B5EF4-FFF2-40B4-BE49-F238E27FC236}">
-                <a16:creationId xmlns:a16="http://schemas.microsoft.com/office/drawing/2014/main" id="{8AF03B1F-3AA0-4764-AD6B-7E5083F89844}"/>
+                <a16:creationId xmlns:a16="http://schemas.microsoft.com/office/drawing/2014/main" id="{7AB8317F-5B1B-4346-9EDF-A5AE49552B1E}"/>
               </a:ext>
             </a:extLst>
           </p:cNvPr>
@@ -10151,7 +10151,7 @@
           <p:cNvPr id="3" name="">
             <a:extLst xmlns:a="http://schemas.openxmlformats.org/drawingml/2006/main">
               <a:ext uri="{FF2B5EF4-FFF2-40B4-BE49-F238E27FC236}">
-                <a16:creationId xmlns:a16="http://schemas.microsoft.com/office/drawing/2014/main" id="{6FB2EFA4-9E15-4637-A8D3-18B44B5995F9}"/>
+                <a16:creationId xmlns:a16="http://schemas.microsoft.com/office/drawing/2014/main" id="{8814B686-32AB-4AE2-9F2C-28A197F9C36B}"/>
               </a:ext>
             </a:extLst>
           </p:cNvPr>
@@ -10212,7 +10212,7 @@
           <p:cNvPr id="4" name="">
             <a:extLst xmlns:a="http://schemas.openxmlformats.org/drawingml/2006/main">
               <a:ext uri="{FF2B5EF4-FFF2-40B4-BE49-F238E27FC236}">
-                <a16:creationId xmlns:a16="http://schemas.microsoft.com/office/drawing/2014/main" id="{2451595A-A38C-4D75-8734-7C1805E32F1E}"/>
+                <a16:creationId xmlns:a16="http://schemas.microsoft.com/office/drawing/2014/main" id="{CE4A0715-08CE-4680-8888-13B62578BCD7}"/>
               </a:ext>
             </a:extLst>
           </p:cNvPr>
@@ -10273,7 +10273,7 @@
           <p:cNvPr id="5" name="">
             <a:extLst xmlns:a="http://schemas.openxmlformats.org/drawingml/2006/main">
               <a:ext uri="{FF2B5EF4-FFF2-40B4-BE49-F238E27FC236}">
-                <a16:creationId xmlns:a16="http://schemas.microsoft.com/office/drawing/2014/main" id="{FB8A3FBE-5B28-491C-A9CA-AC5BE46906E3}"/>
+                <a16:creationId xmlns:a16="http://schemas.microsoft.com/office/drawing/2014/main" id="{10808284-0F65-4A0C-BD22-40CF4AA1DFE6}"/>
               </a:ext>
             </a:extLst>
           </p:cNvPr>
@@ -10304,19 +10304,19 @@
           <p:cNvPr id="6" name="">
             <a:extLst xmlns:a="http://schemas.openxmlformats.org/drawingml/2006/main">
               <a:ext uri="{FF2B5EF4-FFF2-40B4-BE49-F238E27FC236}">
-                <a16:creationId xmlns:a16="http://schemas.microsoft.com/office/drawing/2014/main" id="{97B107BA-75A1-40F6-A2D1-D621B9C9FE2C}"/>
-              </a:ext>
-            </a:extLst>
-          </p:cNvPr>
-          <p:cNvSpPr>
-            <a:spLocks xmlns:a="http://schemas.openxmlformats.org/drawingml/2006/main" noGrp="1"/>
-          </p:cNvSpPr>
-          <p:nvPr/>
-        </p:nvSpPr>
-        <p:spPr>
-          <a:xfrm xmlns:a="http://schemas.openxmlformats.org/drawingml/2006/main">
-            <a:off x="6572250" y="1066800"/>
-            <a:ext cx="5010150" cy="285750"/>
+                <a16:creationId xmlns:a16="http://schemas.microsoft.com/office/drawing/2014/main" id="{674052CA-179D-48D9-B51D-C5D4CF314C9B}"/>
+              </a:ext>
+            </a:extLst>
+          </p:cNvPr>
+          <p:cNvSpPr>
+            <a:spLocks xmlns:a="http://schemas.openxmlformats.org/drawingml/2006/main" noGrp="1"/>
+          </p:cNvSpPr>
+          <p:nvPr/>
+        </p:nvSpPr>
+        <p:spPr>
+          <a:xfrm xmlns:a="http://schemas.openxmlformats.org/drawingml/2006/main">
+            <a:off x="5429250" y="1066800"/>
+            <a:ext cx="6153150" cy="323850"/>
           </a:xfrm>
           <a:prstGeom xmlns:a="http://schemas.openxmlformats.org/drawingml/2006/main" prst="rect">
             <a:avLst/>
@@ -10355,7 +10355,7 @@
                 <a:ea typeface="Arial"/>
                 <a:cs typeface="Arial"/>
               </a:rPr>
-              <a:t>שלושה מסלולים חולקים מקור אחד: חי, גולמי ומאושר</a:t>
+              <a:t>מסלולים נפרדים למהירות, ראיה גולמית ואישור — ושכבת החלטה מעליהם</a:t>
             </a:r>
           </a:p>
         </p:txBody>
@@ -10365,7 +10365,7 @@
           <p:cNvPr id="7" name="">
             <a:extLst xmlns:a="http://schemas.openxmlformats.org/drawingml/2006/main">
               <a:ext uri="{FF2B5EF4-FFF2-40B4-BE49-F238E27FC236}">
-                <a16:creationId xmlns:a16="http://schemas.microsoft.com/office/drawing/2014/main" id="{2BF6B16A-D44D-4D9D-B785-CAEB598B29F9}"/>
+                <a16:creationId xmlns:a16="http://schemas.microsoft.com/office/drawing/2014/main" id="{2A234097-E3DC-4C7E-9F4B-360B07F90D1D}"/>
               </a:ext>
             </a:extLst>
           </p:cNvPr>
@@ -10426,7 +10426,7 @@
           <p:cNvPr id="8" name="">
             <a:extLst xmlns:a="http://schemas.openxmlformats.org/drawingml/2006/main">
               <a:ext uri="{FF2B5EF4-FFF2-40B4-BE49-F238E27FC236}">
-                <a16:creationId xmlns:a16="http://schemas.microsoft.com/office/drawing/2014/main" id="{B8849EAA-BBCA-41DF-AE46-3AFF0A2C3CFC}"/>
+                <a16:creationId xmlns:a16="http://schemas.microsoft.com/office/drawing/2014/main" id="{723B9F9B-780E-42C7-9562-CC1A39CCAD04}"/>
               </a:ext>
             </a:extLst>
           </p:cNvPr>
@@ -10461,7 +10461,7 @@
           <p:cNvPr id="9" name="">
             <a:extLst xmlns:a="http://schemas.openxmlformats.org/drawingml/2006/main">
               <a:ext uri="{FF2B5EF4-FFF2-40B4-BE49-F238E27FC236}">
-                <a16:creationId xmlns:a16="http://schemas.microsoft.com/office/drawing/2014/main" id="{4033EB87-F2EC-48A9-8901-92C1B023B360}"/>
+                <a16:creationId xmlns:a16="http://schemas.microsoft.com/office/drawing/2014/main" id="{D5235689-98BB-4F39-B970-852702A94D2B}"/>
               </a:ext>
             </a:extLst>
           </p:cNvPr>
@@ -10512,7 +10512,7 @@
                 <a:ea typeface="Cascadia Mono"/>
                 <a:cs typeface="Cascadia Mono"/>
               </a:rPr>
-              <a:t>Alpaca + SEC</a:t>
+              <a:t>Alpaca</a:t>
             </a:r>
           </a:p>
         </p:txBody>
@@ -10522,7 +10522,7 @@
           <p:cNvPr id="10" name="">
             <a:extLst xmlns:a="http://schemas.openxmlformats.org/drawingml/2006/main">
               <a:ext uri="{FF2B5EF4-FFF2-40B4-BE49-F238E27FC236}">
-                <a16:creationId xmlns:a16="http://schemas.microsoft.com/office/drawing/2014/main" id="{C62ACC0B-5211-456F-9E94-F874D01703F1}"/>
+                <a16:creationId xmlns:a16="http://schemas.microsoft.com/office/drawing/2014/main" id="{D49290A3-E204-47C0-8A16-6A56E98F8311}"/>
               </a:ext>
             </a:extLst>
           </p:cNvPr>
@@ -10573,7 +10573,7 @@
                 <a:ea typeface="Arial"/>
                 <a:cs typeface="Arial"/>
               </a:rPr>
-              <a:t>מקורות נתונים</a:t>
+              <a:t>נתוני שוק</a:t>
             </a:r>
           </a:p>
         </p:txBody>
@@ -10583,7 +10583,7 @@
           <p:cNvPr id="11" name="">
             <a:extLst xmlns:a="http://schemas.openxmlformats.org/drawingml/2006/main">
               <a:ext uri="{FF2B5EF4-FFF2-40B4-BE49-F238E27FC236}">
-                <a16:creationId xmlns:a16="http://schemas.microsoft.com/office/drawing/2014/main" id="{D34B8174-27DC-4D85-991E-2405367A2361}"/>
+                <a16:creationId xmlns:a16="http://schemas.microsoft.com/office/drawing/2014/main" id="{49330905-83DA-4F11-A099-B028FDA03998}"/>
               </a:ext>
             </a:extLst>
           </p:cNvPr>
@@ -10618,7 +10618,7 @@
           <p:cNvPr id="12" name="">
             <a:extLst xmlns:a="http://schemas.openxmlformats.org/drawingml/2006/main">
               <a:ext uri="{FF2B5EF4-FFF2-40B4-BE49-F238E27FC236}">
-                <a16:creationId xmlns:a16="http://schemas.microsoft.com/office/drawing/2014/main" id="{579284EA-66D6-4BBA-8018-202C3323BD77}"/>
+                <a16:creationId xmlns:a16="http://schemas.microsoft.com/office/drawing/2014/main" id="{A7F03EA3-0C89-4BE0-81BC-CEF713F42388}"/>
               </a:ext>
             </a:extLst>
           </p:cNvPr>
@@ -10679,7 +10679,7 @@
           <p:cNvPr id="13" name="">
             <a:extLst xmlns:a="http://schemas.openxmlformats.org/drawingml/2006/main">
               <a:ext uri="{FF2B5EF4-FFF2-40B4-BE49-F238E27FC236}">
-                <a16:creationId xmlns:a16="http://schemas.microsoft.com/office/drawing/2014/main" id="{EBE6A52F-5DAC-40F9-91B0-9797F054421C}"/>
+                <a16:creationId xmlns:a16="http://schemas.microsoft.com/office/drawing/2014/main" id="{41CDE7F4-450C-465C-9E45-D62655F48D60}"/>
               </a:ext>
             </a:extLst>
           </p:cNvPr>
@@ -10740,7 +10740,7 @@
           <p:cNvPr id="14" name="">
             <a:extLst xmlns:a="http://schemas.openxmlformats.org/drawingml/2006/main">
               <a:ext uri="{FF2B5EF4-FFF2-40B4-BE49-F238E27FC236}">
-                <a16:creationId xmlns:a16="http://schemas.microsoft.com/office/drawing/2014/main" id="{4B49ED5C-EB5C-443E-B27A-4425C5F6EBFC}"/>
+                <a16:creationId xmlns:a16="http://schemas.microsoft.com/office/drawing/2014/main" id="{C854425E-8C07-4FB5-99ED-D423783C669F}"/>
               </a:ext>
             </a:extLst>
           </p:cNvPr>
@@ -10775,7 +10775,7 @@
           <p:cNvPr id="15" name="">
             <a:extLst xmlns:a="http://schemas.openxmlformats.org/drawingml/2006/main">
               <a:ext uri="{FF2B5EF4-FFF2-40B4-BE49-F238E27FC236}">
-                <a16:creationId xmlns:a16="http://schemas.microsoft.com/office/drawing/2014/main" id="{68D70357-013F-41DC-A129-FCECAA6AD7FF}"/>
+                <a16:creationId xmlns:a16="http://schemas.microsoft.com/office/drawing/2014/main" id="{584EFBC1-8886-45ED-9724-2C962E870711}"/>
               </a:ext>
             </a:extLst>
           </p:cNvPr>
@@ -10836,7 +10836,7 @@
           <p:cNvPr id="16" name="">
             <a:extLst xmlns:a="http://schemas.openxmlformats.org/drawingml/2006/main">
               <a:ext uri="{FF2B5EF4-FFF2-40B4-BE49-F238E27FC236}">
-                <a16:creationId xmlns:a16="http://schemas.microsoft.com/office/drawing/2014/main" id="{6586CE0E-8450-45F7-90C4-9B8E8C985761}"/>
+                <a16:creationId xmlns:a16="http://schemas.microsoft.com/office/drawing/2014/main" id="{255101E2-84B9-4B6A-B592-F1D8FBE434BB}"/>
               </a:ext>
             </a:extLst>
           </p:cNvPr>
@@ -10897,7 +10897,7 @@
           <p:cNvPr id="17" name="">
             <a:extLst xmlns:a="http://schemas.openxmlformats.org/drawingml/2006/main">
               <a:ext uri="{FF2B5EF4-FFF2-40B4-BE49-F238E27FC236}">
-                <a16:creationId xmlns:a16="http://schemas.microsoft.com/office/drawing/2014/main" id="{762F66E6-340D-41AE-88F3-9F6141B23DCC}"/>
+                <a16:creationId xmlns:a16="http://schemas.microsoft.com/office/drawing/2014/main" id="{5457C834-8814-4C8F-96A6-07DB5D9CC6BE}"/>
               </a:ext>
             </a:extLst>
           </p:cNvPr>
@@ -10932,7 +10932,7 @@
           <p:cNvPr id="18" name="">
             <a:extLst xmlns:a="http://schemas.openxmlformats.org/drawingml/2006/main">
               <a:ext uri="{FF2B5EF4-FFF2-40B4-BE49-F238E27FC236}">
-                <a16:creationId xmlns:a16="http://schemas.microsoft.com/office/drawing/2014/main" id="{CFFD2CCD-D4BF-46A0-9B2F-CE1C1573641E}"/>
+                <a16:creationId xmlns:a16="http://schemas.microsoft.com/office/drawing/2014/main" id="{511F9D5E-F25D-4340-A285-55BADFDC0CD3}"/>
               </a:ext>
             </a:extLst>
           </p:cNvPr>
@@ -10993,7 +10993,7 @@
           <p:cNvPr id="19" name="">
             <a:extLst xmlns:a="http://schemas.openxmlformats.org/drawingml/2006/main">
               <a:ext uri="{FF2B5EF4-FFF2-40B4-BE49-F238E27FC236}">
-                <a16:creationId xmlns:a16="http://schemas.microsoft.com/office/drawing/2014/main" id="{0DFA206B-6BB8-46B4-B85F-D1F70449AA27}"/>
+                <a16:creationId xmlns:a16="http://schemas.microsoft.com/office/drawing/2014/main" id="{4E0F5F27-5D4E-4065-9205-B547DF102BBD}"/>
               </a:ext>
             </a:extLst>
           </p:cNvPr>
@@ -11054,7 +11054,7 @@
           <p:cNvPr id="20" name="">
             <a:extLst xmlns:a="http://schemas.openxmlformats.org/drawingml/2006/main">
               <a:ext uri="{FF2B5EF4-FFF2-40B4-BE49-F238E27FC236}">
-                <a16:creationId xmlns:a16="http://schemas.microsoft.com/office/drawing/2014/main" id="{99376762-32EC-479A-B976-FD8C000951F3}"/>
+                <a16:creationId xmlns:a16="http://schemas.microsoft.com/office/drawing/2014/main" id="{625311D5-016E-4E2C-8F56-2989D7BA6663}"/>
               </a:ext>
             </a:extLst>
           </p:cNvPr>
@@ -11089,7 +11089,7 @@
           <p:cNvPr id="21" name="">
             <a:extLst xmlns:a="http://schemas.openxmlformats.org/drawingml/2006/main">
               <a:ext uri="{FF2B5EF4-FFF2-40B4-BE49-F238E27FC236}">
-                <a16:creationId xmlns:a16="http://schemas.microsoft.com/office/drawing/2014/main" id="{13190E4D-86B0-4820-866B-16088790CA89}"/>
+                <a16:creationId xmlns:a16="http://schemas.microsoft.com/office/drawing/2014/main" id="{DF8BCCC5-CD52-4AB5-82BA-57BCE3189ACE}"/>
               </a:ext>
             </a:extLst>
           </p:cNvPr>
@@ -11150,7 +11150,7 @@
           <p:cNvPr id="22" name="">
             <a:extLst xmlns:a="http://schemas.openxmlformats.org/drawingml/2006/main">
               <a:ext uri="{FF2B5EF4-FFF2-40B4-BE49-F238E27FC236}">
-                <a16:creationId xmlns:a16="http://schemas.microsoft.com/office/drawing/2014/main" id="{AC27A1B3-E284-48CD-AD56-E21363D40648}"/>
+                <a16:creationId xmlns:a16="http://schemas.microsoft.com/office/drawing/2014/main" id="{0E77B536-A299-431A-8B36-F30CCD424E96}"/>
               </a:ext>
             </a:extLst>
           </p:cNvPr>
@@ -11211,7 +11211,7 @@
           <p:cNvPr id="23" name="">
             <a:extLst xmlns:a="http://schemas.openxmlformats.org/drawingml/2006/main">
               <a:ext uri="{FF2B5EF4-FFF2-40B4-BE49-F238E27FC236}">
-                <a16:creationId xmlns:a16="http://schemas.microsoft.com/office/drawing/2014/main" id="{AE1FADED-A798-4C46-B4F0-E1A1854A1425}"/>
+                <a16:creationId xmlns:a16="http://schemas.microsoft.com/office/drawing/2014/main" id="{1CBF602D-5FD7-4880-81F4-2F68B61E9630}"/>
               </a:ext>
             </a:extLst>
           </p:cNvPr>
@@ -11246,7 +11246,7 @@
           <p:cNvPr id="24" name="">
             <a:extLst xmlns:a="http://schemas.openxmlformats.org/drawingml/2006/main">
               <a:ext uri="{FF2B5EF4-FFF2-40B4-BE49-F238E27FC236}">
-                <a16:creationId xmlns:a16="http://schemas.microsoft.com/office/drawing/2014/main" id="{6AFD6F72-A352-46FF-A700-D02FBF95353C}"/>
+                <a16:creationId xmlns:a16="http://schemas.microsoft.com/office/drawing/2014/main" id="{A7E0D2E1-A54F-4283-A6B9-3F1C90E2DEBE}"/>
               </a:ext>
             </a:extLst>
           </p:cNvPr>
@@ -11307,7 +11307,7 @@
           <p:cNvPr id="25" name="">
             <a:extLst xmlns:a="http://schemas.openxmlformats.org/drawingml/2006/main">
               <a:ext uri="{FF2B5EF4-FFF2-40B4-BE49-F238E27FC236}">
-                <a16:creationId xmlns:a16="http://schemas.microsoft.com/office/drawing/2014/main" id="{B1885119-4A1B-4316-B0D8-61457A2169AF}"/>
+                <a16:creationId xmlns:a16="http://schemas.microsoft.com/office/drawing/2014/main" id="{40B5D9C6-3DC6-47E7-813B-F8692C750985}"/>
               </a:ext>
             </a:extLst>
           </p:cNvPr>
@@ -11498,7 +11498,7 @@
           <p:cNvPr id="31" name="">
             <a:extLst xmlns:a="http://schemas.openxmlformats.org/drawingml/2006/main">
               <a:ext uri="{FF2B5EF4-FFF2-40B4-BE49-F238E27FC236}">
-                <a16:creationId xmlns:a16="http://schemas.microsoft.com/office/drawing/2014/main" id="{2C2391E5-20FA-4DC8-97C4-B4BFDB9FC44F}"/>
+                <a16:creationId xmlns:a16="http://schemas.microsoft.com/office/drawing/2014/main" id="{6202982F-C6B7-49C2-8E7E-878DE103A8C0}"/>
               </a:ext>
             </a:extLst>
           </p:cNvPr>
@@ -11559,7 +11559,7 @@
           <p:cNvPr id="32" name="">
             <a:extLst xmlns:a="http://schemas.openxmlformats.org/drawingml/2006/main">
               <a:ext uri="{FF2B5EF4-FFF2-40B4-BE49-F238E27FC236}">
-                <a16:creationId xmlns:a16="http://schemas.microsoft.com/office/drawing/2014/main" id="{7741F8FA-9092-4DA0-8BD5-E1F8CC39BAF9}"/>
+                <a16:creationId xmlns:a16="http://schemas.microsoft.com/office/drawing/2014/main" id="{BBF898C3-B6B5-4F6C-94B7-94D451CC1C6B}"/>
               </a:ext>
             </a:extLst>
           </p:cNvPr>
@@ -11594,7 +11594,7 @@
           <p:cNvPr id="33" name="">
             <a:extLst xmlns:a="http://schemas.openxmlformats.org/drawingml/2006/main">
               <a:ext uri="{FF2B5EF4-FFF2-40B4-BE49-F238E27FC236}">
-                <a16:creationId xmlns:a16="http://schemas.microsoft.com/office/drawing/2014/main" id="{1B39A5AD-4C69-4750-9473-14682E0DD3ED}"/>
+                <a16:creationId xmlns:a16="http://schemas.microsoft.com/office/drawing/2014/main" id="{21B99974-3307-47DD-AFE3-00D58AA5BBBE}"/>
               </a:ext>
             </a:extLst>
           </p:cNvPr>
@@ -11655,7 +11655,7 @@
           <p:cNvPr id="34" name="">
             <a:extLst xmlns:a="http://schemas.openxmlformats.org/drawingml/2006/main">
               <a:ext uri="{FF2B5EF4-FFF2-40B4-BE49-F238E27FC236}">
-                <a16:creationId xmlns:a16="http://schemas.microsoft.com/office/drawing/2014/main" id="{7EB47F87-D02D-4FF9-8AC8-4FD851050BD1}"/>
+                <a16:creationId xmlns:a16="http://schemas.microsoft.com/office/drawing/2014/main" id="{8FCD4FB5-C0EC-40C3-B333-9233BF78069E}"/>
               </a:ext>
             </a:extLst>
           </p:cNvPr>
@@ -11716,7 +11716,7 @@
           <p:cNvPr id="35" name="">
             <a:extLst xmlns:a="http://schemas.openxmlformats.org/drawingml/2006/main">
               <a:ext uri="{FF2B5EF4-FFF2-40B4-BE49-F238E27FC236}">
-                <a16:creationId xmlns:a16="http://schemas.microsoft.com/office/drawing/2014/main" id="{7827CECF-DC42-4368-B354-4591F0A43CAC}"/>
+                <a16:creationId xmlns:a16="http://schemas.microsoft.com/office/drawing/2014/main" id="{2F5EACF6-3203-48BA-A6F8-AA4727A48237}"/>
               </a:ext>
             </a:extLst>
           </p:cNvPr>
@@ -11751,7 +11751,7 @@
           <p:cNvPr id="36" name="">
             <a:extLst xmlns:a="http://schemas.openxmlformats.org/drawingml/2006/main">
               <a:ext uri="{FF2B5EF4-FFF2-40B4-BE49-F238E27FC236}">
-                <a16:creationId xmlns:a16="http://schemas.microsoft.com/office/drawing/2014/main" id="{943DF5BC-CF9D-48E2-9C26-7748E4CE2D1D}"/>
+                <a16:creationId xmlns:a16="http://schemas.microsoft.com/office/drawing/2014/main" id="{9FCB886E-DA06-4A72-859C-E807B25A7067}"/>
               </a:ext>
             </a:extLst>
           </p:cNvPr>
@@ -11812,7 +11812,7 @@
           <p:cNvPr id="37" name="">
             <a:extLst xmlns:a="http://schemas.openxmlformats.org/drawingml/2006/main">
               <a:ext uri="{FF2B5EF4-FFF2-40B4-BE49-F238E27FC236}">
-                <a16:creationId xmlns:a16="http://schemas.microsoft.com/office/drawing/2014/main" id="{ADC27465-8799-48F5-83A5-A28F221C8380}"/>
+                <a16:creationId xmlns:a16="http://schemas.microsoft.com/office/drawing/2014/main" id="{5FA9BBD1-A05E-44FC-9254-906D80D0E1DB}"/>
               </a:ext>
             </a:extLst>
           </p:cNvPr>
@@ -11873,7 +11873,7 @@
           <p:cNvPr id="38" name="">
             <a:extLst xmlns:a="http://schemas.openxmlformats.org/drawingml/2006/main">
               <a:ext uri="{FF2B5EF4-FFF2-40B4-BE49-F238E27FC236}">
-                <a16:creationId xmlns:a16="http://schemas.microsoft.com/office/drawing/2014/main" id="{28D3E287-3927-4570-9EF3-21BE699E54EB}"/>
+                <a16:creationId xmlns:a16="http://schemas.microsoft.com/office/drawing/2014/main" id="{809BD5D7-ECC8-430B-8EF0-99DD8DC7842E}"/>
               </a:ext>
             </a:extLst>
           </p:cNvPr>
@@ -11908,7 +11908,7 @@
           <p:cNvPr id="39" name="">
             <a:extLst xmlns:a="http://schemas.openxmlformats.org/drawingml/2006/main">
               <a:ext uri="{FF2B5EF4-FFF2-40B4-BE49-F238E27FC236}">
-                <a16:creationId xmlns:a16="http://schemas.microsoft.com/office/drawing/2014/main" id="{A45B228A-A6B2-4010-96DD-E3E48412B874}"/>
+                <a16:creationId xmlns:a16="http://schemas.microsoft.com/office/drawing/2014/main" id="{D9988921-D916-4BAA-A727-D5B8E7397F34}"/>
               </a:ext>
             </a:extLst>
           </p:cNvPr>
@@ -11969,7 +11969,7 @@
           <p:cNvPr id="40" name="">
             <a:extLst xmlns:a="http://schemas.openxmlformats.org/drawingml/2006/main">
               <a:ext uri="{FF2B5EF4-FFF2-40B4-BE49-F238E27FC236}">
-                <a16:creationId xmlns:a16="http://schemas.microsoft.com/office/drawing/2014/main" id="{45CE53C2-11A5-40C2-B63B-831B87269263}"/>
+                <a16:creationId xmlns:a16="http://schemas.microsoft.com/office/drawing/2014/main" id="{D0130A7F-4EBD-458A-99F8-8A1A03BFEAC5}"/>
               </a:ext>
             </a:extLst>
           </p:cNvPr>
@@ -12140,7 +12140,7 @@
           <p:cNvPr id="45" name="">
             <a:extLst xmlns:a="http://schemas.openxmlformats.org/drawingml/2006/main">
               <a:ext uri="{FF2B5EF4-FFF2-40B4-BE49-F238E27FC236}">
-                <a16:creationId xmlns:a16="http://schemas.microsoft.com/office/drawing/2014/main" id="{CDBD9042-3CD7-4D32-A7E8-DB5574B435E7}"/>
+                <a16:creationId xmlns:a16="http://schemas.microsoft.com/office/drawing/2014/main" id="{39E154C0-7DDA-4DF2-B333-53B3C0873C0D}"/>
               </a:ext>
             </a:extLst>
           </p:cNvPr>
@@ -12201,7 +12201,7 @@
           <p:cNvPr id="46" name="">
             <a:extLst xmlns:a="http://schemas.openxmlformats.org/drawingml/2006/main">
               <a:ext uri="{FF2B5EF4-FFF2-40B4-BE49-F238E27FC236}">
-                <a16:creationId xmlns:a16="http://schemas.microsoft.com/office/drawing/2014/main" id="{D0C8D10C-10BB-40B1-869E-8DFEC2D9DB6D}"/>
+                <a16:creationId xmlns:a16="http://schemas.microsoft.com/office/drawing/2014/main" id="{2F265310-474E-4356-B736-D05C298AFFD6}"/>
               </a:ext>
             </a:extLst>
           </p:cNvPr>
@@ -12262,7 +12262,7 @@
           <p:cNvPr id="47" name="">
             <a:extLst xmlns:a="http://schemas.openxmlformats.org/drawingml/2006/main">
               <a:ext uri="{FF2B5EF4-FFF2-40B4-BE49-F238E27FC236}">
-                <a16:creationId xmlns:a16="http://schemas.microsoft.com/office/drawing/2014/main" id="{F2311593-621E-4B80-BCA6-29F06CCD62A5}"/>
+                <a16:creationId xmlns:a16="http://schemas.microsoft.com/office/drawing/2014/main" id="{6DAAAB4B-44FF-4699-BE70-92CE486CD245}"/>
               </a:ext>
             </a:extLst>
           </p:cNvPr>
@@ -12313,7 +12313,7 @@
                 <a:ea typeface="Arial"/>
                 <a:cs typeface="Arial"/>
               </a:rPr>
-              <a:t>Airflow אינו מפעיל שירותי Streaming. הוא מתזמן רק עבודות שמתחילות ומסתיימות.</a:t>
+              <a:t>התזמור אינו מפעיל עיבוד רציף. הוא מנהל רק עבודות תחומות, לרבות דיווחי חברות ונתוני עבר.</a:t>
             </a:r>
           </a:p>
         </p:txBody>
@@ -12323,7 +12323,7 @@
           <p:cNvPr id="48" name="">
             <a:extLst xmlns:a="http://schemas.openxmlformats.org/drawingml/2006/main">
               <a:ext uri="{FF2B5EF4-FFF2-40B4-BE49-F238E27FC236}">
-                <a16:creationId xmlns:a16="http://schemas.microsoft.com/office/drawing/2014/main" id="{4C9A6797-FF3E-4099-90E3-DC04B189F003}"/>
+                <a16:creationId xmlns:a16="http://schemas.microsoft.com/office/drawing/2014/main" id="{82F139EE-599A-47B3-8438-A31CED37D236}"/>
               </a:ext>
             </a:extLst>
           </p:cNvPr>
@@ -12374,7 +12374,7 @@
                 <a:ea typeface="Arial"/>
                 <a:cs typeface="Arial"/>
               </a:rPr>
-              <a:t>Bronze שומר את הראיה. Silver מנקה ומנרמל. Gold מוכן לצריכת המוצר.</a:t>
+              <a:t>השכבה הגולמית שומרת ראיה; השכבה הנקייה מנרמלת; שכבת ההגשה מזינה כללים ומודל.</a:t>
             </a:r>
           </a:p>
         </p:txBody>
@@ -12382,7 +12382,7 @@
     </p:spTree>
     <p:extLst>
       <p:ext uri="{BB962C8B-B14F-4D97-AF65-F5344CB8AC3E}">
-        <p14:creationId xmlns:p14="http://schemas.microsoft.com/office/powerpoint/2010/main" val="1796314297"/>
+        <p14:creationId xmlns:p14="http://schemas.microsoft.com/office/powerpoint/2010/main" val="1625394252"/>
       </p:ext>
     </p:extLst>
   </p:cSld>
@@ -12413,7 +12413,7 @@
           <p:cNvPr id="47" name="">
             <a:extLst xmlns:a="http://schemas.openxmlformats.org/drawingml/2006/main">
               <a:ext uri="{FF2B5EF4-FFF2-40B4-BE49-F238E27FC236}">
-                <a16:creationId xmlns:a16="http://schemas.microsoft.com/office/drawing/2014/main" id="{2EDB9626-2405-4174-9981-EE23F08C971C}"/>
+                <a16:creationId xmlns:a16="http://schemas.microsoft.com/office/drawing/2014/main" id="{D67B86DD-6833-4170-BE6C-725A92746E89}"/>
               </a:ext>
             </a:extLst>
           </p:cNvPr>
@@ -12443,7 +12443,7 @@
           <p:cNvPr id="2" name="">
             <a:extLst xmlns:a="http://schemas.openxmlformats.org/drawingml/2006/main">
               <a:ext uri="{FF2B5EF4-FFF2-40B4-BE49-F238E27FC236}">
-                <a16:creationId xmlns:a16="http://schemas.microsoft.com/office/drawing/2014/main" id="{39976DD3-2CBC-49C1-B7BA-3C93BFF28969}"/>
+                <a16:creationId xmlns:a16="http://schemas.microsoft.com/office/drawing/2014/main" id="{E5CB359D-A504-40AA-BC63-E156E7C0DCBB}"/>
               </a:ext>
             </a:extLst>
           </p:cNvPr>
@@ -12504,7 +12504,7 @@
           <p:cNvPr id="3" name="">
             <a:extLst xmlns:a="http://schemas.openxmlformats.org/drawingml/2006/main">
               <a:ext uri="{FF2B5EF4-FFF2-40B4-BE49-F238E27FC236}">
-                <a16:creationId xmlns:a16="http://schemas.microsoft.com/office/drawing/2014/main" id="{ACE12306-D03C-4935-A2F0-421F565E2F4E}"/>
+                <a16:creationId xmlns:a16="http://schemas.microsoft.com/office/drawing/2014/main" id="{0C4BFB19-C626-43A0-A71D-FAC2713F8C98}"/>
               </a:ext>
             </a:extLst>
           </p:cNvPr>
@@ -12565,7 +12565,7 @@
           <p:cNvPr id="4" name="">
             <a:extLst xmlns:a="http://schemas.openxmlformats.org/drawingml/2006/main">
               <a:ext uri="{FF2B5EF4-FFF2-40B4-BE49-F238E27FC236}">
-                <a16:creationId xmlns:a16="http://schemas.microsoft.com/office/drawing/2014/main" id="{70220A14-3E7E-4930-A817-487BAADE9D60}"/>
+                <a16:creationId xmlns:a16="http://schemas.microsoft.com/office/drawing/2014/main" id="{C213719B-67BF-4372-AE83-9F86D39DFD85}"/>
               </a:ext>
             </a:extLst>
           </p:cNvPr>
@@ -12626,7 +12626,7 @@
           <p:cNvPr id="5" name="">
             <a:extLst xmlns:a="http://schemas.openxmlformats.org/drawingml/2006/main">
               <a:ext uri="{FF2B5EF4-FFF2-40B4-BE49-F238E27FC236}">
-                <a16:creationId xmlns:a16="http://schemas.microsoft.com/office/drawing/2014/main" id="{452D2526-4839-40E8-A5F5-E563B7980941}"/>
+                <a16:creationId xmlns:a16="http://schemas.microsoft.com/office/drawing/2014/main" id="{CA06BC3F-ECAE-4C96-8770-C309E1FC1F2C}"/>
               </a:ext>
             </a:extLst>
           </p:cNvPr>
@@ -12657,7 +12657,7 @@
           <p:cNvPr id="6" name="">
             <a:extLst xmlns:a="http://schemas.openxmlformats.org/drawingml/2006/main">
               <a:ext uri="{FF2B5EF4-FFF2-40B4-BE49-F238E27FC236}">
-                <a16:creationId xmlns:a16="http://schemas.microsoft.com/office/drawing/2014/main" id="{B5390265-5448-4B92-9495-39D447CBB73E}"/>
+                <a16:creationId xmlns:a16="http://schemas.microsoft.com/office/drawing/2014/main" id="{B84C5600-3E8C-45EB-A6BD-14C4223E611B}"/>
               </a:ext>
             </a:extLst>
           </p:cNvPr>
@@ -12718,7 +12718,7 @@
           <p:cNvPr id="7" name="">
             <a:extLst xmlns:a="http://schemas.openxmlformats.org/drawingml/2006/main">
               <a:ext uri="{FF2B5EF4-FFF2-40B4-BE49-F238E27FC236}">
-                <a16:creationId xmlns:a16="http://schemas.microsoft.com/office/drawing/2014/main" id="{347EF960-FBFE-4A28-92AB-FB9A1CDDEEC8}"/>
+                <a16:creationId xmlns:a16="http://schemas.microsoft.com/office/drawing/2014/main" id="{ABC45591-1718-400E-9D0B-3A9DE1E81B0D}"/>
               </a:ext>
             </a:extLst>
           </p:cNvPr>
@@ -12779,7 +12779,7 @@
           <p:cNvPr id="8" name="">
             <a:extLst xmlns:a="http://schemas.openxmlformats.org/drawingml/2006/main">
               <a:ext uri="{FF2B5EF4-FFF2-40B4-BE49-F238E27FC236}">
-                <a16:creationId xmlns:a16="http://schemas.microsoft.com/office/drawing/2014/main" id="{69E7125E-874A-49B0-A73E-6E95DFA15D3F}"/>
+                <a16:creationId xmlns:a16="http://schemas.microsoft.com/office/drawing/2014/main" id="{5DC5BA81-D722-43C4-90C4-E22D16F8D8CA}"/>
               </a:ext>
             </a:extLst>
           </p:cNvPr>
@@ -12814,7 +12814,7 @@
           <p:cNvPr id="9" name="">
             <a:extLst xmlns:a="http://schemas.openxmlformats.org/drawingml/2006/main">
               <a:ext uri="{FF2B5EF4-FFF2-40B4-BE49-F238E27FC236}">
-                <a16:creationId xmlns:a16="http://schemas.microsoft.com/office/drawing/2014/main" id="{A990CC93-1EF3-457C-A28F-F2D3906F1239}"/>
+                <a16:creationId xmlns:a16="http://schemas.microsoft.com/office/drawing/2014/main" id="{E4D74A06-36EE-4E8B-A0B4-119687162AF3}"/>
               </a:ext>
             </a:extLst>
           </p:cNvPr>
@@ -12875,7 +12875,7 @@
           <p:cNvPr id="10" name="">
             <a:extLst xmlns:a="http://schemas.openxmlformats.org/drawingml/2006/main">
               <a:ext uri="{FF2B5EF4-FFF2-40B4-BE49-F238E27FC236}">
-                <a16:creationId xmlns:a16="http://schemas.microsoft.com/office/drawing/2014/main" id="{F47A6CD7-D718-48BC-BE4C-BD440B4DBFC3}"/>
+                <a16:creationId xmlns:a16="http://schemas.microsoft.com/office/drawing/2014/main" id="{DCA5AB2B-0161-4F92-B43D-B1EC912BD876}"/>
               </a:ext>
             </a:extLst>
           </p:cNvPr>
@@ -12936,7 +12936,7 @@
           <p:cNvPr id="11" name="">
             <a:extLst xmlns:a="http://schemas.openxmlformats.org/drawingml/2006/main">
               <a:ext uri="{FF2B5EF4-FFF2-40B4-BE49-F238E27FC236}">
-                <a16:creationId xmlns:a16="http://schemas.microsoft.com/office/drawing/2014/main" id="{92FE1806-791F-4545-8365-1668A8854800}"/>
+                <a16:creationId xmlns:a16="http://schemas.microsoft.com/office/drawing/2014/main" id="{2C75F63F-9C85-4654-BEED-8A161FCDE6F3}"/>
               </a:ext>
             </a:extLst>
           </p:cNvPr>
@@ -12971,7 +12971,7 @@
           <p:cNvPr id="12" name="">
             <a:extLst xmlns:a="http://schemas.openxmlformats.org/drawingml/2006/main">
               <a:ext uri="{FF2B5EF4-FFF2-40B4-BE49-F238E27FC236}">
-                <a16:creationId xmlns:a16="http://schemas.microsoft.com/office/drawing/2014/main" id="{EC4CAC79-541A-46FA-B55B-C8B6999C3AD9}"/>
+                <a16:creationId xmlns:a16="http://schemas.microsoft.com/office/drawing/2014/main" id="{8B4A0536-3D2E-41AA-8847-84B81E20F7B5}"/>
               </a:ext>
             </a:extLst>
           </p:cNvPr>
@@ -13032,7 +13032,7 @@
           <p:cNvPr id="13" name="">
             <a:extLst xmlns:a="http://schemas.openxmlformats.org/drawingml/2006/main">
               <a:ext uri="{FF2B5EF4-FFF2-40B4-BE49-F238E27FC236}">
-                <a16:creationId xmlns:a16="http://schemas.microsoft.com/office/drawing/2014/main" id="{DD871329-4718-4D52-91E1-3129BAB2E8DB}"/>
+                <a16:creationId xmlns:a16="http://schemas.microsoft.com/office/drawing/2014/main" id="{A773194D-B8E8-4040-8AA8-C69166AB7EDD}"/>
               </a:ext>
             </a:extLst>
           </p:cNvPr>
@@ -13071,7 +13071,7 @@
           <p:cNvPr id="14" name="">
             <a:extLst xmlns:a="http://schemas.openxmlformats.org/drawingml/2006/main">
               <a:ext uri="{FF2B5EF4-FFF2-40B4-BE49-F238E27FC236}">
-                <a16:creationId xmlns:a16="http://schemas.microsoft.com/office/drawing/2014/main" id="{BF13A5EB-40F7-430D-8FDA-BEE94CAE691E}"/>
+                <a16:creationId xmlns:a16="http://schemas.microsoft.com/office/drawing/2014/main" id="{66C07C95-04A7-4808-BF1F-735FAB1B9D93}"/>
               </a:ext>
             </a:extLst>
           </p:cNvPr>
@@ -13106,7 +13106,7 @@
           <p:cNvPr id="15" name="">
             <a:extLst xmlns:a="http://schemas.openxmlformats.org/drawingml/2006/main">
               <a:ext uri="{FF2B5EF4-FFF2-40B4-BE49-F238E27FC236}">
-                <a16:creationId xmlns:a16="http://schemas.microsoft.com/office/drawing/2014/main" id="{9C7B2B5A-33D2-4CDB-A675-0FA753878002}"/>
+                <a16:creationId xmlns:a16="http://schemas.microsoft.com/office/drawing/2014/main" id="{5184EB5B-48E3-445A-AE25-431FCB7ED277}"/>
               </a:ext>
             </a:extLst>
           </p:cNvPr>
@@ -13167,7 +13167,7 @@
           <p:cNvPr id="16" name="">
             <a:extLst xmlns:a="http://schemas.openxmlformats.org/drawingml/2006/main">
               <a:ext uri="{FF2B5EF4-FFF2-40B4-BE49-F238E27FC236}">
-                <a16:creationId xmlns:a16="http://schemas.microsoft.com/office/drawing/2014/main" id="{5B49CAF7-0045-464D-8CF7-A0AC543A4183}"/>
+                <a16:creationId xmlns:a16="http://schemas.microsoft.com/office/drawing/2014/main" id="{01B2A27B-4EBA-4ACF-BDD0-DC4026FDA993}"/>
               </a:ext>
             </a:extLst>
           </p:cNvPr>
@@ -13206,7 +13206,7 @@
           <p:cNvPr id="17" name="">
             <a:extLst xmlns:a="http://schemas.openxmlformats.org/drawingml/2006/main">
               <a:ext uri="{FF2B5EF4-FFF2-40B4-BE49-F238E27FC236}">
-                <a16:creationId xmlns:a16="http://schemas.microsoft.com/office/drawing/2014/main" id="{87E1CBEC-EA41-4794-AD30-0815834D842D}"/>
+                <a16:creationId xmlns:a16="http://schemas.microsoft.com/office/drawing/2014/main" id="{B0E157CB-48B8-4986-BC3C-F4238E2151DB}"/>
               </a:ext>
             </a:extLst>
           </p:cNvPr>
@@ -13241,7 +13241,7 @@
           <p:cNvPr id="18" name="">
             <a:extLst xmlns:a="http://schemas.openxmlformats.org/drawingml/2006/main">
               <a:ext uri="{FF2B5EF4-FFF2-40B4-BE49-F238E27FC236}">
-                <a16:creationId xmlns:a16="http://schemas.microsoft.com/office/drawing/2014/main" id="{57D98A60-55C9-439F-91FC-60AFCF2E822F}"/>
+                <a16:creationId xmlns:a16="http://schemas.microsoft.com/office/drawing/2014/main" id="{4E661456-998F-451D-9325-41190E628911}"/>
               </a:ext>
             </a:extLst>
           </p:cNvPr>
@@ -13302,7 +13302,7 @@
           <p:cNvPr id="19" name="">
             <a:extLst xmlns:a="http://schemas.openxmlformats.org/drawingml/2006/main">
               <a:ext uri="{FF2B5EF4-FFF2-40B4-BE49-F238E27FC236}">
-                <a16:creationId xmlns:a16="http://schemas.microsoft.com/office/drawing/2014/main" id="{49FD9DF5-BAB0-45BD-B463-75E914118C73}"/>
+                <a16:creationId xmlns:a16="http://schemas.microsoft.com/office/drawing/2014/main" id="{2A7DF634-2FBC-4FA4-ADD4-4D60F36F17C9}"/>
               </a:ext>
             </a:extLst>
           </p:cNvPr>
@@ -13419,7 +13419,7 @@
           <p:cNvPr id="23" name="">
             <a:extLst xmlns:a="http://schemas.openxmlformats.org/drawingml/2006/main">
               <a:ext uri="{FF2B5EF4-FFF2-40B4-BE49-F238E27FC236}">
-                <a16:creationId xmlns:a16="http://schemas.microsoft.com/office/drawing/2014/main" id="{903573B0-9A76-4110-B5CA-35F6D775A480}"/>
+                <a16:creationId xmlns:a16="http://schemas.microsoft.com/office/drawing/2014/main" id="{D7DB36C7-447A-4052-BC01-CADF05FE9260}"/>
               </a:ext>
             </a:extLst>
           </p:cNvPr>
@@ -13480,7 +13480,7 @@
           <p:cNvPr id="24" name="">
             <a:extLst xmlns:a="http://schemas.openxmlformats.org/drawingml/2006/main">
               <a:ext uri="{FF2B5EF4-FFF2-40B4-BE49-F238E27FC236}">
-                <a16:creationId xmlns:a16="http://schemas.microsoft.com/office/drawing/2014/main" id="{DC9F1A04-4E15-4104-B477-DEA8E4F21B14}"/>
+                <a16:creationId xmlns:a16="http://schemas.microsoft.com/office/drawing/2014/main" id="{4C94934B-3835-4725-AB43-A8515ECF92E1}"/>
               </a:ext>
             </a:extLst>
           </p:cNvPr>
@@ -13511,7 +13511,7 @@
           <p:cNvPr id="25" name="">
             <a:extLst xmlns:a="http://schemas.openxmlformats.org/drawingml/2006/main">
               <a:ext uri="{FF2B5EF4-FFF2-40B4-BE49-F238E27FC236}">
-                <a16:creationId xmlns:a16="http://schemas.microsoft.com/office/drawing/2014/main" id="{8A01FBBC-1CEE-4685-B470-ED329109E571}"/>
+                <a16:creationId xmlns:a16="http://schemas.microsoft.com/office/drawing/2014/main" id="{8A782D1A-4417-40ED-BFB2-B3C719FC921E}"/>
               </a:ext>
             </a:extLst>
           </p:cNvPr>
@@ -13572,7 +13572,7 @@
           <p:cNvPr id="26" name="">
             <a:extLst xmlns:a="http://schemas.openxmlformats.org/drawingml/2006/main">
               <a:ext uri="{FF2B5EF4-FFF2-40B4-BE49-F238E27FC236}">
-                <a16:creationId xmlns:a16="http://schemas.microsoft.com/office/drawing/2014/main" id="{86B93658-BECD-49CC-BC8F-BA75B03E52B6}"/>
+                <a16:creationId xmlns:a16="http://schemas.microsoft.com/office/drawing/2014/main" id="{4E48FC53-8B9E-4B5E-85F6-E532502DF0DA}"/>
               </a:ext>
             </a:extLst>
           </p:cNvPr>
@@ -13633,7 +13633,7 @@
           <p:cNvPr id="27" name="">
             <a:extLst xmlns:a="http://schemas.openxmlformats.org/drawingml/2006/main">
               <a:ext uri="{FF2B5EF4-FFF2-40B4-BE49-F238E27FC236}">
-                <a16:creationId xmlns:a16="http://schemas.microsoft.com/office/drawing/2014/main" id="{459264C5-A417-4E20-A384-A1531D7EA0BD}"/>
+                <a16:creationId xmlns:a16="http://schemas.microsoft.com/office/drawing/2014/main" id="{2FF63020-E441-46A7-B370-2E3363651DDE}"/>
               </a:ext>
             </a:extLst>
           </p:cNvPr>
@@ -13668,7 +13668,7 @@
           <p:cNvPr id="28" name="">
             <a:extLst xmlns:a="http://schemas.openxmlformats.org/drawingml/2006/main">
               <a:ext uri="{FF2B5EF4-FFF2-40B4-BE49-F238E27FC236}">
-                <a16:creationId xmlns:a16="http://schemas.microsoft.com/office/drawing/2014/main" id="{2CCF3C07-2487-49AD-8FBE-2EC214D3894B}"/>
+                <a16:creationId xmlns:a16="http://schemas.microsoft.com/office/drawing/2014/main" id="{4F43C237-E1F6-4D82-8953-46890832A821}"/>
               </a:ext>
             </a:extLst>
           </p:cNvPr>
@@ -13729,7 +13729,7 @@
           <p:cNvPr id="29" name="">
             <a:extLst xmlns:a="http://schemas.openxmlformats.org/drawingml/2006/main">
               <a:ext uri="{FF2B5EF4-FFF2-40B4-BE49-F238E27FC236}">
-                <a16:creationId xmlns:a16="http://schemas.microsoft.com/office/drawing/2014/main" id="{18C41384-B4BE-4381-979F-8BCA48EF7C90}"/>
+                <a16:creationId xmlns:a16="http://schemas.microsoft.com/office/drawing/2014/main" id="{313BD3B4-A446-4304-914C-73B5DFEEC4E0}"/>
               </a:ext>
             </a:extLst>
           </p:cNvPr>
@@ -13768,7 +13768,7 @@
           <p:cNvPr id="30" name="">
             <a:extLst xmlns:a="http://schemas.openxmlformats.org/drawingml/2006/main">
               <a:ext uri="{FF2B5EF4-FFF2-40B4-BE49-F238E27FC236}">
-                <a16:creationId xmlns:a16="http://schemas.microsoft.com/office/drawing/2014/main" id="{85AC2E97-D143-4F4A-AF0D-2F956B072F7E}"/>
+                <a16:creationId xmlns:a16="http://schemas.microsoft.com/office/drawing/2014/main" id="{DB40E47C-86BA-42C6-8903-874128EED022}"/>
               </a:ext>
             </a:extLst>
           </p:cNvPr>
@@ -13803,7 +13803,7 @@
           <p:cNvPr id="31" name="">
             <a:extLst xmlns:a="http://schemas.openxmlformats.org/drawingml/2006/main">
               <a:ext uri="{FF2B5EF4-FFF2-40B4-BE49-F238E27FC236}">
-                <a16:creationId xmlns:a16="http://schemas.microsoft.com/office/drawing/2014/main" id="{E4A651E2-140F-4936-BA26-F9171E5B3FC9}"/>
+                <a16:creationId xmlns:a16="http://schemas.microsoft.com/office/drawing/2014/main" id="{15C637C9-7D31-4CA8-A91E-4EE63B47121D}"/>
               </a:ext>
             </a:extLst>
           </p:cNvPr>
@@ -13864,7 +13864,7 @@
           <p:cNvPr id="32" name="">
             <a:extLst xmlns:a="http://schemas.openxmlformats.org/drawingml/2006/main">
               <a:ext uri="{FF2B5EF4-FFF2-40B4-BE49-F238E27FC236}">
-                <a16:creationId xmlns:a16="http://schemas.microsoft.com/office/drawing/2014/main" id="{359C0EA0-0BF9-4881-B433-E42107927AD2}"/>
+                <a16:creationId xmlns:a16="http://schemas.microsoft.com/office/drawing/2014/main" id="{C69A4FEC-0211-41F3-AC73-42DA76BAF232}"/>
               </a:ext>
             </a:extLst>
           </p:cNvPr>
@@ -13903,7 +13903,7 @@
           <p:cNvPr id="33" name="">
             <a:extLst xmlns:a="http://schemas.openxmlformats.org/drawingml/2006/main">
               <a:ext uri="{FF2B5EF4-FFF2-40B4-BE49-F238E27FC236}">
-                <a16:creationId xmlns:a16="http://schemas.microsoft.com/office/drawing/2014/main" id="{E94C2087-D69A-483F-8B3D-1B10F5BBC9F7}"/>
+                <a16:creationId xmlns:a16="http://schemas.microsoft.com/office/drawing/2014/main" id="{745B0282-303D-405B-A927-800CD80EAEA9}"/>
               </a:ext>
             </a:extLst>
           </p:cNvPr>
@@ -13938,7 +13938,7 @@
           <p:cNvPr id="34" name="">
             <a:extLst xmlns:a="http://schemas.openxmlformats.org/drawingml/2006/main">
               <a:ext uri="{FF2B5EF4-FFF2-40B4-BE49-F238E27FC236}">
-                <a16:creationId xmlns:a16="http://schemas.microsoft.com/office/drawing/2014/main" id="{BF721081-7FF4-4665-BC18-761A09EA7D3C}"/>
+                <a16:creationId xmlns:a16="http://schemas.microsoft.com/office/drawing/2014/main" id="{7A5F911B-6004-474B-8FE0-B4CA775B562C}"/>
               </a:ext>
             </a:extLst>
           </p:cNvPr>
@@ -13999,7 +13999,7 @@
           <p:cNvPr id="35" name="">
             <a:extLst xmlns:a="http://schemas.openxmlformats.org/drawingml/2006/main">
               <a:ext uri="{FF2B5EF4-FFF2-40B4-BE49-F238E27FC236}">
-                <a16:creationId xmlns:a16="http://schemas.microsoft.com/office/drawing/2014/main" id="{CB528E77-B478-42E8-A72A-6A4B3A716788}"/>
+                <a16:creationId xmlns:a16="http://schemas.microsoft.com/office/drawing/2014/main" id="{57FFEA74-2E78-46E4-94EE-7D2B1944D766}"/>
               </a:ext>
             </a:extLst>
           </p:cNvPr>
@@ -14038,7 +14038,7 @@
           <p:cNvPr id="36" name="">
             <a:extLst xmlns:a="http://schemas.openxmlformats.org/drawingml/2006/main">
               <a:ext uri="{FF2B5EF4-FFF2-40B4-BE49-F238E27FC236}">
-                <a16:creationId xmlns:a16="http://schemas.microsoft.com/office/drawing/2014/main" id="{8D8BFAAC-CDA9-44ED-A52D-E628A2F2112A}"/>
+                <a16:creationId xmlns:a16="http://schemas.microsoft.com/office/drawing/2014/main" id="{6933CC96-DDAE-443B-B4DA-D98E362F987C}"/>
               </a:ext>
             </a:extLst>
           </p:cNvPr>
@@ -14073,7 +14073,7 @@
           <p:cNvPr id="37" name="">
             <a:extLst xmlns:a="http://schemas.openxmlformats.org/drawingml/2006/main">
               <a:ext uri="{FF2B5EF4-FFF2-40B4-BE49-F238E27FC236}">
-                <a16:creationId xmlns:a16="http://schemas.microsoft.com/office/drawing/2014/main" id="{ECC3257D-65B1-49C6-91AC-BEC6523B46CC}"/>
+                <a16:creationId xmlns:a16="http://schemas.microsoft.com/office/drawing/2014/main" id="{7C23A044-5BCE-4896-BB90-4C3E35A19F0C}"/>
               </a:ext>
             </a:extLst>
           </p:cNvPr>
@@ -14134,7 +14134,7 @@
           <p:cNvPr id="38" name="">
             <a:extLst xmlns:a="http://schemas.openxmlformats.org/drawingml/2006/main">
               <a:ext uri="{FF2B5EF4-FFF2-40B4-BE49-F238E27FC236}">
-                <a16:creationId xmlns:a16="http://schemas.microsoft.com/office/drawing/2014/main" id="{3CA12F22-407E-44B6-A8B4-420261CFC827}"/>
+                <a16:creationId xmlns:a16="http://schemas.microsoft.com/office/drawing/2014/main" id="{04666E74-BA3E-46AB-82A6-75088FE7A92B}"/>
               </a:ext>
             </a:extLst>
           </p:cNvPr>
@@ -14173,7 +14173,7 @@
           <p:cNvPr id="39" name="">
             <a:extLst xmlns:a="http://schemas.openxmlformats.org/drawingml/2006/main">
               <a:ext uri="{FF2B5EF4-FFF2-40B4-BE49-F238E27FC236}">
-                <a16:creationId xmlns:a16="http://schemas.microsoft.com/office/drawing/2014/main" id="{A071BB5C-C8C3-4001-BA02-2B8CC5270A14}"/>
+                <a16:creationId xmlns:a16="http://schemas.microsoft.com/office/drawing/2014/main" id="{03CC2C9C-979A-4461-9D80-7D97E4A486B7}"/>
               </a:ext>
             </a:extLst>
           </p:cNvPr>
@@ -14208,7 +14208,7 @@
           <p:cNvPr id="40" name="">
             <a:extLst xmlns:a="http://schemas.openxmlformats.org/drawingml/2006/main">
               <a:ext uri="{FF2B5EF4-FFF2-40B4-BE49-F238E27FC236}">
-                <a16:creationId xmlns:a16="http://schemas.microsoft.com/office/drawing/2014/main" id="{7076848A-5B75-4F20-AC09-53AEE25BAE4F}"/>
+                <a16:creationId xmlns:a16="http://schemas.microsoft.com/office/drawing/2014/main" id="{90B28BB4-F53F-421A-820B-59CB1336388C}"/>
               </a:ext>
             </a:extLst>
           </p:cNvPr>
@@ -14269,7 +14269,7 @@
           <p:cNvPr id="41" name="">
             <a:extLst xmlns:a="http://schemas.openxmlformats.org/drawingml/2006/main">
               <a:ext uri="{FF2B5EF4-FFF2-40B4-BE49-F238E27FC236}">
-                <a16:creationId xmlns:a16="http://schemas.microsoft.com/office/drawing/2014/main" id="{324C4FEB-37E3-48CE-8287-B18B3166D8BC}"/>
+                <a16:creationId xmlns:a16="http://schemas.microsoft.com/office/drawing/2014/main" id="{A1EAFF10-ADE9-4F62-980C-453EFCC0B112}"/>
               </a:ext>
             </a:extLst>
           </p:cNvPr>
@@ -14412,7 +14412,7 @@
           <p:cNvPr id="46" name="">
             <a:extLst xmlns:a="http://schemas.openxmlformats.org/drawingml/2006/main">
               <a:ext uri="{FF2B5EF4-FFF2-40B4-BE49-F238E27FC236}">
-                <a16:creationId xmlns:a16="http://schemas.microsoft.com/office/drawing/2014/main" id="{DBCF332E-5921-498A-A60D-EC7B083DDC74}"/>
+                <a16:creationId xmlns:a16="http://schemas.microsoft.com/office/drawing/2014/main" id="{57AC2D64-A599-4EA2-9FC1-4E3D20C13B52}"/>
               </a:ext>
             </a:extLst>
           </p:cNvPr>
@@ -14471,7 +14471,7 @@
     </p:spTree>
     <p:extLst>
       <p:ext uri="{BB962C8B-B14F-4D97-AF65-F5344CB8AC3E}">
-        <p14:creationId xmlns:p14="http://schemas.microsoft.com/office/powerpoint/2010/main" val="1773300724"/>
+        <p14:creationId xmlns:p14="http://schemas.microsoft.com/office/powerpoint/2010/main" val="482803751"/>
       </p:ext>
     </p:extLst>
   </p:cSld>
@@ -14502,7 +14502,7 @@
           <p:cNvPr id="34" name="">
             <a:extLst xmlns:a="http://schemas.openxmlformats.org/drawingml/2006/main">
               <a:ext uri="{FF2B5EF4-FFF2-40B4-BE49-F238E27FC236}">
-                <a16:creationId xmlns:a16="http://schemas.microsoft.com/office/drawing/2014/main" id="{9341C389-1052-444B-AE43-91F6A9ED858C}"/>
+                <a16:creationId xmlns:a16="http://schemas.microsoft.com/office/drawing/2014/main" id="{4D797930-9D09-48EA-BBBD-97BA64243114}"/>
               </a:ext>
             </a:extLst>
           </p:cNvPr>
@@ -14532,7 +14532,7 @@
           <p:cNvPr id="2" name="">
             <a:extLst xmlns:a="http://schemas.openxmlformats.org/drawingml/2006/main">
               <a:ext uri="{FF2B5EF4-FFF2-40B4-BE49-F238E27FC236}">
-                <a16:creationId xmlns:a16="http://schemas.microsoft.com/office/drawing/2014/main" id="{68197A9B-B6F8-4EA2-8FDA-01569E59E20E}"/>
+                <a16:creationId xmlns:a16="http://schemas.microsoft.com/office/drawing/2014/main" id="{3D659C84-62A1-493B-B34B-8698A763F4C6}"/>
               </a:ext>
             </a:extLst>
           </p:cNvPr>
@@ -14593,7 +14593,7 @@
           <p:cNvPr id="3" name="">
             <a:extLst xmlns:a="http://schemas.openxmlformats.org/drawingml/2006/main">
               <a:ext uri="{FF2B5EF4-FFF2-40B4-BE49-F238E27FC236}">
-                <a16:creationId xmlns:a16="http://schemas.microsoft.com/office/drawing/2014/main" id="{F567B29F-4A51-4302-B11A-369BD8018B65}"/>
+                <a16:creationId xmlns:a16="http://schemas.microsoft.com/office/drawing/2014/main" id="{84FB3995-B6BD-438A-9489-C23EEE11991C}"/>
               </a:ext>
             </a:extLst>
           </p:cNvPr>
@@ -14654,7 +14654,7 @@
           <p:cNvPr id="4" name="">
             <a:extLst xmlns:a="http://schemas.openxmlformats.org/drawingml/2006/main">
               <a:ext uri="{FF2B5EF4-FFF2-40B4-BE49-F238E27FC236}">
-                <a16:creationId xmlns:a16="http://schemas.microsoft.com/office/drawing/2014/main" id="{4AFC39CF-1046-4834-BA86-B84684E0AC89}"/>
+                <a16:creationId xmlns:a16="http://schemas.microsoft.com/office/drawing/2014/main" id="{D72C4C09-AF3D-45B8-B264-01C1B97102B2}"/>
               </a:ext>
             </a:extLst>
           </p:cNvPr>
@@ -14715,7 +14715,7 @@
           <p:cNvPr id="5" name="">
             <a:extLst xmlns:a="http://schemas.openxmlformats.org/drawingml/2006/main">
               <a:ext uri="{FF2B5EF4-FFF2-40B4-BE49-F238E27FC236}">
-                <a16:creationId xmlns:a16="http://schemas.microsoft.com/office/drawing/2014/main" id="{E787CE58-9158-43E3-AA66-E5CB4511A632}"/>
+                <a16:creationId xmlns:a16="http://schemas.microsoft.com/office/drawing/2014/main" id="{5EBC0BB8-0E8B-48D6-A6BB-63D553D14A07}"/>
               </a:ext>
             </a:extLst>
           </p:cNvPr>
@@ -14746,7 +14746,7 @@
           <p:cNvPr id="6" name="">
             <a:extLst xmlns:a="http://schemas.openxmlformats.org/drawingml/2006/main">
               <a:ext uri="{FF2B5EF4-FFF2-40B4-BE49-F238E27FC236}">
-                <a16:creationId xmlns:a16="http://schemas.microsoft.com/office/drawing/2014/main" id="{044A4C70-1621-4932-8477-C5A93F1EB8E8}"/>
+                <a16:creationId xmlns:a16="http://schemas.microsoft.com/office/drawing/2014/main" id="{02C8AD41-9287-4793-BD16-AB3920483602}"/>
               </a:ext>
             </a:extLst>
           </p:cNvPr>
@@ -14807,7 +14807,7 @@
           <p:cNvPr id="7" name="">
             <a:extLst xmlns:a="http://schemas.openxmlformats.org/drawingml/2006/main">
               <a:ext uri="{FF2B5EF4-FFF2-40B4-BE49-F238E27FC236}">
-                <a16:creationId xmlns:a16="http://schemas.microsoft.com/office/drawing/2014/main" id="{0BF386C5-DD65-4791-9A6B-280119349D4C}"/>
+                <a16:creationId xmlns:a16="http://schemas.microsoft.com/office/drawing/2014/main" id="{2917EA90-0B79-4F85-971E-073D53636ADA}"/>
               </a:ext>
             </a:extLst>
           </p:cNvPr>
@@ -14868,7 +14868,7 @@
           <p:cNvPr id="8" name="">
             <a:extLst xmlns:a="http://schemas.openxmlformats.org/drawingml/2006/main">
               <a:ext uri="{FF2B5EF4-FFF2-40B4-BE49-F238E27FC236}">
-                <a16:creationId xmlns:a16="http://schemas.microsoft.com/office/drawing/2014/main" id="{E14AFC39-1956-4AB0-9382-670793632BF0}"/>
+                <a16:creationId xmlns:a16="http://schemas.microsoft.com/office/drawing/2014/main" id="{615C8287-FCD9-49E3-A905-7DA08CC69D9E}"/>
               </a:ext>
             </a:extLst>
           </p:cNvPr>
@@ -14929,7 +14929,7 @@
           <p:cNvPr id="9" name="">
             <a:extLst xmlns:a="http://schemas.openxmlformats.org/drawingml/2006/main">
               <a:ext uri="{FF2B5EF4-FFF2-40B4-BE49-F238E27FC236}">
-                <a16:creationId xmlns:a16="http://schemas.microsoft.com/office/drawing/2014/main" id="{3F496A77-A731-42E4-AB06-DD2FBCD7A70A}"/>
+                <a16:creationId xmlns:a16="http://schemas.microsoft.com/office/drawing/2014/main" id="{83BE4B84-2830-4517-9E44-391E5ABE47D5}"/>
               </a:ext>
             </a:extLst>
           </p:cNvPr>
@@ -14960,7 +14960,7 @@
           <p:cNvPr id="10" name="">
             <a:extLst xmlns:a="http://schemas.openxmlformats.org/drawingml/2006/main">
               <a:ext uri="{FF2B5EF4-FFF2-40B4-BE49-F238E27FC236}">
-                <a16:creationId xmlns:a16="http://schemas.microsoft.com/office/drawing/2014/main" id="{4D13A5A0-4C5E-4749-A7D4-31986968DF56}"/>
+                <a16:creationId xmlns:a16="http://schemas.microsoft.com/office/drawing/2014/main" id="{7DE0538D-FBB5-4523-AB21-5CD52E0640E7}"/>
               </a:ext>
             </a:extLst>
           </p:cNvPr>
@@ -15021,7 +15021,7 @@
           <p:cNvPr id="11" name="">
             <a:extLst xmlns:a="http://schemas.openxmlformats.org/drawingml/2006/main">
               <a:ext uri="{FF2B5EF4-FFF2-40B4-BE49-F238E27FC236}">
-                <a16:creationId xmlns:a16="http://schemas.microsoft.com/office/drawing/2014/main" id="{35E40B05-6DA3-4680-8FF1-12749B2E51BF}"/>
+                <a16:creationId xmlns:a16="http://schemas.microsoft.com/office/drawing/2014/main" id="{9707DC8A-055A-491E-8DEE-1C2C17C14A3F}"/>
               </a:ext>
             </a:extLst>
           </p:cNvPr>
@@ -15082,7 +15082,7 @@
           <p:cNvPr id="12" name="">
             <a:extLst xmlns:a="http://schemas.openxmlformats.org/drawingml/2006/main">
               <a:ext uri="{FF2B5EF4-FFF2-40B4-BE49-F238E27FC236}">
-                <a16:creationId xmlns:a16="http://schemas.microsoft.com/office/drawing/2014/main" id="{3736E7EC-784C-472C-9739-97734D24766B}"/>
+                <a16:creationId xmlns:a16="http://schemas.microsoft.com/office/drawing/2014/main" id="{CE5F10C6-9E7E-49E4-8116-69BD2407BF08}"/>
               </a:ext>
             </a:extLst>
           </p:cNvPr>
@@ -15143,7 +15143,7 @@
           <p:cNvPr id="13" name="">
             <a:extLst xmlns:a="http://schemas.openxmlformats.org/drawingml/2006/main">
               <a:ext uri="{FF2B5EF4-FFF2-40B4-BE49-F238E27FC236}">
-                <a16:creationId xmlns:a16="http://schemas.microsoft.com/office/drawing/2014/main" id="{DB4F689A-826C-4490-BEE1-8324B1BE1EBA}"/>
+                <a16:creationId xmlns:a16="http://schemas.microsoft.com/office/drawing/2014/main" id="{DD707F7A-1D32-465D-8C7C-7D7AA0639E81}"/>
               </a:ext>
             </a:extLst>
           </p:cNvPr>
@@ -15174,7 +15174,7 @@
           <p:cNvPr id="14" name="">
             <a:extLst xmlns:a="http://schemas.openxmlformats.org/drawingml/2006/main">
               <a:ext uri="{FF2B5EF4-FFF2-40B4-BE49-F238E27FC236}">
-                <a16:creationId xmlns:a16="http://schemas.microsoft.com/office/drawing/2014/main" id="{0B8F4769-CD76-4445-98EE-8903856D14CD}"/>
+                <a16:creationId xmlns:a16="http://schemas.microsoft.com/office/drawing/2014/main" id="{D3C1A0B5-CEA7-4A77-B91A-3A1685733B23}"/>
               </a:ext>
             </a:extLst>
           </p:cNvPr>
@@ -15235,7 +15235,7 @@
           <p:cNvPr id="15" name="">
             <a:extLst xmlns:a="http://schemas.openxmlformats.org/drawingml/2006/main">
               <a:ext uri="{FF2B5EF4-FFF2-40B4-BE49-F238E27FC236}">
-                <a16:creationId xmlns:a16="http://schemas.microsoft.com/office/drawing/2014/main" id="{35E368E5-4407-4DA9-A25B-22ADBE17D68F}"/>
+                <a16:creationId xmlns:a16="http://schemas.microsoft.com/office/drawing/2014/main" id="{C4100845-8DC2-48DF-BE94-1DB94D5E3405}"/>
               </a:ext>
             </a:extLst>
           </p:cNvPr>
@@ -15296,7 +15296,7 @@
           <p:cNvPr id="16" name="">
             <a:extLst xmlns:a="http://schemas.openxmlformats.org/drawingml/2006/main">
               <a:ext uri="{FF2B5EF4-FFF2-40B4-BE49-F238E27FC236}">
-                <a16:creationId xmlns:a16="http://schemas.microsoft.com/office/drawing/2014/main" id="{0499F8E8-007F-4945-A1BA-5A9F0FFBDB05}"/>
+                <a16:creationId xmlns:a16="http://schemas.microsoft.com/office/drawing/2014/main" id="{686CDFCE-2AD8-4BAC-887A-24B85119459D}"/>
               </a:ext>
             </a:extLst>
           </p:cNvPr>
@@ -15357,7 +15357,7 @@
           <p:cNvPr id="17" name="">
             <a:extLst xmlns:a="http://schemas.openxmlformats.org/drawingml/2006/main">
               <a:ext uri="{FF2B5EF4-FFF2-40B4-BE49-F238E27FC236}">
-                <a16:creationId xmlns:a16="http://schemas.microsoft.com/office/drawing/2014/main" id="{CDCD1CFF-4527-4BF3-A328-F663A954B17F}"/>
+                <a16:creationId xmlns:a16="http://schemas.microsoft.com/office/drawing/2014/main" id="{77FE06C6-C4F4-4A66-AEDF-8640C2B19F09}"/>
               </a:ext>
             </a:extLst>
           </p:cNvPr>
@@ -15388,7 +15388,7 @@
           <p:cNvPr id="18" name="">
             <a:extLst xmlns:a="http://schemas.openxmlformats.org/drawingml/2006/main">
               <a:ext uri="{FF2B5EF4-FFF2-40B4-BE49-F238E27FC236}">
-                <a16:creationId xmlns:a16="http://schemas.microsoft.com/office/drawing/2014/main" id="{BD7857A4-8D45-4610-B29C-4C415893F404}"/>
+                <a16:creationId xmlns:a16="http://schemas.microsoft.com/office/drawing/2014/main" id="{9E0CEA4A-582F-4502-95B4-D0A34A7DC59F}"/>
               </a:ext>
             </a:extLst>
           </p:cNvPr>
@@ -15449,7 +15449,7 @@
           <p:cNvPr id="19" name="">
             <a:extLst xmlns:a="http://schemas.openxmlformats.org/drawingml/2006/main">
               <a:ext uri="{FF2B5EF4-FFF2-40B4-BE49-F238E27FC236}">
-                <a16:creationId xmlns:a16="http://schemas.microsoft.com/office/drawing/2014/main" id="{E8A56630-C7E6-4701-ACA9-778121A4F7A7}"/>
+                <a16:creationId xmlns:a16="http://schemas.microsoft.com/office/drawing/2014/main" id="{9D0BA45C-96D6-4B0A-804C-6F8B75973264}"/>
               </a:ext>
             </a:extLst>
           </p:cNvPr>
@@ -15510,7 +15510,7 @@
           <p:cNvPr id="20" name="">
             <a:extLst xmlns:a="http://schemas.openxmlformats.org/drawingml/2006/main">
               <a:ext uri="{FF2B5EF4-FFF2-40B4-BE49-F238E27FC236}">
-                <a16:creationId xmlns:a16="http://schemas.microsoft.com/office/drawing/2014/main" id="{68C94B74-6A99-4F22-B776-8CC2F3AC5BD2}"/>
+                <a16:creationId xmlns:a16="http://schemas.microsoft.com/office/drawing/2014/main" id="{1CAA4362-62EA-47B5-972E-5F4820520831}"/>
               </a:ext>
             </a:extLst>
           </p:cNvPr>
@@ -15571,7 +15571,7 @@
           <p:cNvPr id="21" name="">
             <a:extLst xmlns:a="http://schemas.openxmlformats.org/drawingml/2006/main">
               <a:ext uri="{FF2B5EF4-FFF2-40B4-BE49-F238E27FC236}">
-                <a16:creationId xmlns:a16="http://schemas.microsoft.com/office/drawing/2014/main" id="{2EC03EE3-04B7-4982-AE0E-B1F4FDCE0FC3}"/>
+                <a16:creationId xmlns:a16="http://schemas.microsoft.com/office/drawing/2014/main" id="{4A97391C-8D54-4D96-9E2E-9EB25B965998}"/>
               </a:ext>
             </a:extLst>
           </p:cNvPr>
@@ -15602,7 +15602,7 @@
           <p:cNvPr id="22" name="">
             <a:extLst xmlns:a="http://schemas.openxmlformats.org/drawingml/2006/main">
               <a:ext uri="{FF2B5EF4-FFF2-40B4-BE49-F238E27FC236}">
-                <a16:creationId xmlns:a16="http://schemas.microsoft.com/office/drawing/2014/main" id="{F4DF516A-FD99-477D-8B72-298A13961216}"/>
+                <a16:creationId xmlns:a16="http://schemas.microsoft.com/office/drawing/2014/main" id="{496B88BA-DDEB-47E4-83B5-82F279062BF8}"/>
               </a:ext>
             </a:extLst>
           </p:cNvPr>
@@ -15663,7 +15663,7 @@
           <p:cNvPr id="23" name="">
             <a:extLst xmlns:a="http://schemas.openxmlformats.org/drawingml/2006/main">
               <a:ext uri="{FF2B5EF4-FFF2-40B4-BE49-F238E27FC236}">
-                <a16:creationId xmlns:a16="http://schemas.microsoft.com/office/drawing/2014/main" id="{453A1F88-2FE2-4216-B9A1-1329C6111AAE}"/>
+                <a16:creationId xmlns:a16="http://schemas.microsoft.com/office/drawing/2014/main" id="{A12F2F78-8634-44EA-8B03-B48BD251C7A9}"/>
               </a:ext>
             </a:extLst>
           </p:cNvPr>
@@ -15724,7 +15724,7 @@
           <p:cNvPr id="24" name="">
             <a:extLst xmlns:a="http://schemas.openxmlformats.org/drawingml/2006/main">
               <a:ext uri="{FF2B5EF4-FFF2-40B4-BE49-F238E27FC236}">
-                <a16:creationId xmlns:a16="http://schemas.microsoft.com/office/drawing/2014/main" id="{B5ADA390-6FBB-4DDB-8563-5D54D328FF0F}"/>
+                <a16:creationId xmlns:a16="http://schemas.microsoft.com/office/drawing/2014/main" id="{4003AEF4-1B68-498E-98E6-3EBB466E774F}"/>
               </a:ext>
             </a:extLst>
           </p:cNvPr>
@@ -15785,7 +15785,7 @@
           <p:cNvPr id="25" name="">
             <a:extLst xmlns:a="http://schemas.openxmlformats.org/drawingml/2006/main">
               <a:ext uri="{FF2B5EF4-FFF2-40B4-BE49-F238E27FC236}">
-                <a16:creationId xmlns:a16="http://schemas.microsoft.com/office/drawing/2014/main" id="{30DCDBAD-FC98-4825-9FA9-E8CE9F4590DF}"/>
+                <a16:creationId xmlns:a16="http://schemas.microsoft.com/office/drawing/2014/main" id="{8DA22A3C-A598-4053-A7CD-332C575CF37D}"/>
               </a:ext>
             </a:extLst>
           </p:cNvPr>
@@ -15816,7 +15816,7 @@
           <p:cNvPr id="26" name="">
             <a:extLst xmlns:a="http://schemas.openxmlformats.org/drawingml/2006/main">
               <a:ext uri="{FF2B5EF4-FFF2-40B4-BE49-F238E27FC236}">
-                <a16:creationId xmlns:a16="http://schemas.microsoft.com/office/drawing/2014/main" id="{BCBFE7B4-F9DE-482D-9BFB-5C16DA278FAE}"/>
+                <a16:creationId xmlns:a16="http://schemas.microsoft.com/office/drawing/2014/main" id="{A6D54BD9-2F9C-454D-85BD-21D57C5AE0E4}"/>
               </a:ext>
             </a:extLst>
           </p:cNvPr>
@@ -15877,7 +15877,7 @@
           <p:cNvPr id="27" name="">
             <a:extLst xmlns:a="http://schemas.openxmlformats.org/drawingml/2006/main">
               <a:ext uri="{FF2B5EF4-FFF2-40B4-BE49-F238E27FC236}">
-                <a16:creationId xmlns:a16="http://schemas.microsoft.com/office/drawing/2014/main" id="{489F13CF-63C7-47B4-BD9F-0803B975FA74}"/>
+                <a16:creationId xmlns:a16="http://schemas.microsoft.com/office/drawing/2014/main" id="{6BC9CA48-2622-438E-8158-6B923D10D441}"/>
               </a:ext>
             </a:extLst>
           </p:cNvPr>
@@ -15938,7 +15938,7 @@
           <p:cNvPr id="28" name="">
             <a:extLst xmlns:a="http://schemas.openxmlformats.org/drawingml/2006/main">
               <a:ext uri="{FF2B5EF4-FFF2-40B4-BE49-F238E27FC236}">
-                <a16:creationId xmlns:a16="http://schemas.microsoft.com/office/drawing/2014/main" id="{DCDD9F4D-8F09-4CC8-934C-DC5117E5C7AE}"/>
+                <a16:creationId xmlns:a16="http://schemas.microsoft.com/office/drawing/2014/main" id="{513DC519-E2F5-4CE0-9126-A313558A35A4}"/>
               </a:ext>
             </a:extLst>
           </p:cNvPr>
@@ -15999,7 +15999,7 @@
           <p:cNvPr id="29" name="">
             <a:extLst xmlns:a="http://schemas.openxmlformats.org/drawingml/2006/main">
               <a:ext uri="{FF2B5EF4-FFF2-40B4-BE49-F238E27FC236}">
-                <a16:creationId xmlns:a16="http://schemas.microsoft.com/office/drawing/2014/main" id="{4582EA6E-1F61-480C-9387-1E234848246C}"/>
+                <a16:creationId xmlns:a16="http://schemas.microsoft.com/office/drawing/2014/main" id="{A730E0AF-251E-4E2A-B7B6-F8C5F2CECC06}"/>
               </a:ext>
             </a:extLst>
           </p:cNvPr>
@@ -16030,7 +16030,7 @@
           <p:cNvPr id="30" name="">
             <a:extLst xmlns:a="http://schemas.openxmlformats.org/drawingml/2006/main">
               <a:ext uri="{FF2B5EF4-FFF2-40B4-BE49-F238E27FC236}">
-                <a16:creationId xmlns:a16="http://schemas.microsoft.com/office/drawing/2014/main" id="{F7D2438B-59A4-48C8-86AF-72B2148931DD}"/>
+                <a16:creationId xmlns:a16="http://schemas.microsoft.com/office/drawing/2014/main" id="{297741D5-41C9-441D-BF2D-A3E128E81185}"/>
               </a:ext>
             </a:extLst>
           </p:cNvPr>
@@ -16091,7 +16091,7 @@
           <p:cNvPr id="31" name="">
             <a:extLst xmlns:a="http://schemas.openxmlformats.org/drawingml/2006/main">
               <a:ext uri="{FF2B5EF4-FFF2-40B4-BE49-F238E27FC236}">
-                <a16:creationId xmlns:a16="http://schemas.microsoft.com/office/drawing/2014/main" id="{A460E5D0-FE42-4B86-8091-08F21B31D2CF}"/>
+                <a16:creationId xmlns:a16="http://schemas.microsoft.com/office/drawing/2014/main" id="{5EF87B73-71F7-4395-9D10-034DCB235F10}"/>
               </a:ext>
             </a:extLst>
           </p:cNvPr>
@@ -16152,7 +16152,7 @@
           <p:cNvPr id="32" name="">
             <a:extLst xmlns:a="http://schemas.openxmlformats.org/drawingml/2006/main">
               <a:ext uri="{FF2B5EF4-FFF2-40B4-BE49-F238E27FC236}">
-                <a16:creationId xmlns:a16="http://schemas.microsoft.com/office/drawing/2014/main" id="{A0DDEE4B-D981-4EFF-98E6-287660B50D82}"/>
+                <a16:creationId xmlns:a16="http://schemas.microsoft.com/office/drawing/2014/main" id="{3F3AEADD-EBCA-4836-A23C-4C9C04754FA8}"/>
               </a:ext>
             </a:extLst>
           </p:cNvPr>
@@ -16213,7 +16213,7 @@
           <p:cNvPr id="33" name="">
             <a:extLst xmlns:a="http://schemas.openxmlformats.org/drawingml/2006/main">
               <a:ext uri="{FF2B5EF4-FFF2-40B4-BE49-F238E27FC236}">
-                <a16:creationId xmlns:a16="http://schemas.microsoft.com/office/drawing/2014/main" id="{00911890-96FD-4542-8B3E-1DEA9D5B5632}"/>
+                <a16:creationId xmlns:a16="http://schemas.microsoft.com/office/drawing/2014/main" id="{F14244F6-15AA-4A2C-A45A-8762756D3C42}"/>
               </a:ext>
             </a:extLst>
           </p:cNvPr>
@@ -16272,7 +16272,7 @@
     </p:spTree>
     <p:extLst>
       <p:ext uri="{BB962C8B-B14F-4D97-AF65-F5344CB8AC3E}">
-        <p14:creationId xmlns:p14="http://schemas.microsoft.com/office/powerpoint/2010/main" val="696539477"/>
+        <p14:creationId xmlns:p14="http://schemas.microsoft.com/office/powerpoint/2010/main" val="691260585"/>
       </p:ext>
     </p:extLst>
   </p:cSld>
@@ -16300,10 +16300,10 @@
       </p:grpSpPr>
       <p:sp>
         <p:nvSpPr>
-          <p:cNvPr id="16" name="">
-            <a:extLst xmlns:a="http://schemas.openxmlformats.org/drawingml/2006/main">
-              <a:ext uri="{FF2B5EF4-FFF2-40B4-BE49-F238E27FC236}">
-                <a16:creationId xmlns:a16="http://schemas.microsoft.com/office/drawing/2014/main" id="{0BB3E85D-93C7-4020-AE52-541CA8015F38}"/>
+          <p:cNvPr id="18" name="">
+            <a:extLst xmlns:a="http://schemas.openxmlformats.org/drawingml/2006/main">
+              <a:ext uri="{FF2B5EF4-FFF2-40B4-BE49-F238E27FC236}">
+                <a16:creationId xmlns:a16="http://schemas.microsoft.com/office/drawing/2014/main" id="{8036BFF0-CBDC-4DD3-A6BB-2422A637FBB8}"/>
               </a:ext>
             </a:extLst>
           </p:cNvPr>
@@ -16333,7 +16333,7 @@
           <p:cNvPr id="2" name="">
             <a:extLst xmlns:a="http://schemas.openxmlformats.org/drawingml/2006/main">
               <a:ext uri="{FF2B5EF4-FFF2-40B4-BE49-F238E27FC236}">
-                <a16:creationId xmlns:a16="http://schemas.microsoft.com/office/drawing/2014/main" id="{584A1CFA-DC88-469F-8C48-68CDF490957F}"/>
+                <a16:creationId xmlns:a16="http://schemas.microsoft.com/office/drawing/2014/main" id="{8CB46549-98A3-4184-BEE9-A66A18E864D0}"/>
               </a:ext>
             </a:extLst>
           </p:cNvPr>
@@ -16394,7 +16394,7 @@
           <p:cNvPr id="3" name="">
             <a:extLst xmlns:a="http://schemas.openxmlformats.org/drawingml/2006/main">
               <a:ext uri="{FF2B5EF4-FFF2-40B4-BE49-F238E27FC236}">
-                <a16:creationId xmlns:a16="http://schemas.microsoft.com/office/drawing/2014/main" id="{56356B3F-389F-4A54-A8C9-D682794B6682}"/>
+                <a16:creationId xmlns:a16="http://schemas.microsoft.com/office/drawing/2014/main" id="{B0E08833-5718-4376-8934-14D6D71247AF}"/>
               </a:ext>
             </a:extLst>
           </p:cNvPr>
@@ -16455,7 +16455,7 @@
           <p:cNvPr id="4" name="">
             <a:extLst xmlns:a="http://schemas.openxmlformats.org/drawingml/2006/main">
               <a:ext uri="{FF2B5EF4-FFF2-40B4-BE49-F238E27FC236}">
-                <a16:creationId xmlns:a16="http://schemas.microsoft.com/office/drawing/2014/main" id="{0BF06A99-DC82-40F9-83A8-508812D2A034}"/>
+                <a16:creationId xmlns:a16="http://schemas.microsoft.com/office/drawing/2014/main" id="{87B58F21-3D0D-4DFA-A3B0-DB5227FE51F4}"/>
               </a:ext>
             </a:extLst>
           </p:cNvPr>
@@ -16516,7 +16516,7 @@
           <p:cNvPr id="5" name="">
             <a:extLst xmlns:a="http://schemas.openxmlformats.org/drawingml/2006/main">
               <a:ext uri="{FF2B5EF4-FFF2-40B4-BE49-F238E27FC236}">
-                <a16:creationId xmlns:a16="http://schemas.microsoft.com/office/drawing/2014/main" id="{C896BA7F-6A2F-4C5A-9FA5-71CD0432E6D4}"/>
+                <a16:creationId xmlns:a16="http://schemas.microsoft.com/office/drawing/2014/main" id="{FCE554A5-D350-4DB0-9024-AD5ECC2DD8A3}"/>
               </a:ext>
             </a:extLst>
           </p:cNvPr>
@@ -16544,15 +16544,15 @@
       </p:sp>
       <p:pic>
         <p:nvPicPr>
-          <p:cNvPr id="21" name=""/>
+          <p:cNvPr id="23" name=""/>
           <p:cNvPicPr>
             <a:picLocks xmlns:a="http://schemas.openxmlformats.org/drawingml/2006/main" noChangeAspect="1"/>
           </p:cNvPicPr>
           <p:nvPr/>
         </p:nvPicPr>
         <p:blipFill>
-          <a:blip xmlns:r="http://schemas.openxmlformats.org/officeDocument/2006/relationships" xmlns:a="http://schemas.openxmlformats.org/drawingml/2006/main" r:embed="R931929e2cb114cd6"/>
-          <a:srcRect xmlns:a="http://schemas.openxmlformats.org/drawingml/2006/main" l="1048" t="0" r="1048" b="0"/>
+          <a:blip xmlns:r="http://schemas.openxmlformats.org/officeDocument/2006/relationships" xmlns:a="http://schemas.openxmlformats.org/drawingml/2006/main" r:embed="R90d1c04bab8f48df"/>
+          <a:srcRect xmlns:a="http://schemas.openxmlformats.org/drawingml/2006/main" l="0" t="4036" r="0" b="4036"/>
           <a:stretch xmlns:a="http://schemas.openxmlformats.org/drawingml/2006/main">
             <a:fillRect l="0" t="0" r="0" b="0"/>
           </a:stretch>
@@ -16574,7 +16574,7 @@
           <p:cNvPr id="7" name="">
             <a:extLst xmlns:a="http://schemas.openxmlformats.org/drawingml/2006/main">
               <a:ext uri="{FF2B5EF4-FFF2-40B4-BE49-F238E27FC236}">
-                <a16:creationId xmlns:a16="http://schemas.microsoft.com/office/drawing/2014/main" id="{E0262062-5193-404E-B8C4-7A1442D14060}"/>
+                <a16:creationId xmlns:a16="http://schemas.microsoft.com/office/drawing/2014/main" id="{4BA9AFBF-7793-41E6-A29C-65CB8F6331F0}"/>
               </a:ext>
             </a:extLst>
           </p:cNvPr>
@@ -16635,7 +16635,7 @@
           <p:cNvPr id="8" name="">
             <a:extLst xmlns:a="http://schemas.openxmlformats.org/drawingml/2006/main">
               <a:ext uri="{FF2B5EF4-FFF2-40B4-BE49-F238E27FC236}">
-                <a16:creationId xmlns:a16="http://schemas.microsoft.com/office/drawing/2014/main" id="{3A6C6C62-189B-4AE3-A72E-276B3162BF13}"/>
+                <a16:creationId xmlns:a16="http://schemas.microsoft.com/office/drawing/2014/main" id="{53D0F816-7EAB-44FE-8FFB-153DF104263A}"/>
               </a:ext>
             </a:extLst>
           </p:cNvPr>
@@ -16696,7 +16696,7 @@
           <p:cNvPr id="9" name="">
             <a:extLst xmlns:a="http://schemas.openxmlformats.org/drawingml/2006/main">
               <a:ext uri="{FF2B5EF4-FFF2-40B4-BE49-F238E27FC236}">
-                <a16:creationId xmlns:a16="http://schemas.microsoft.com/office/drawing/2014/main" id="{FB6A549B-67B2-4807-B7B8-E5D63D1CA8E2}"/>
+                <a16:creationId xmlns:a16="http://schemas.microsoft.com/office/drawing/2014/main" id="{E02B0106-C9C1-4617-B1AD-CDD9599B83DE}"/>
               </a:ext>
             </a:extLst>
           </p:cNvPr>
@@ -16727,18 +16727,18 @@
           <p:cNvPr id="10" name="">
             <a:extLst xmlns:a="http://schemas.openxmlformats.org/drawingml/2006/main">
               <a:ext uri="{FF2B5EF4-FFF2-40B4-BE49-F238E27FC236}">
-                <a16:creationId xmlns:a16="http://schemas.microsoft.com/office/drawing/2014/main" id="{84D9933D-7629-49D6-9561-8CD6C6B42B41}"/>
-              </a:ext>
-            </a:extLst>
-          </p:cNvPr>
-          <p:cNvSpPr>
-            <a:spLocks xmlns:a="http://schemas.openxmlformats.org/drawingml/2006/main" noGrp="1"/>
-          </p:cNvSpPr>
-          <p:nvPr/>
-        </p:nvSpPr>
-        <p:spPr>
-          <a:xfrm xmlns:a="http://schemas.openxmlformats.org/drawingml/2006/main">
-            <a:off x="8743950" y="3371850"/>
+                <a16:creationId xmlns:a16="http://schemas.microsoft.com/office/drawing/2014/main" id="{89FF6839-AB57-4EA0-801B-F0B555EFB531}"/>
+              </a:ext>
+            </a:extLst>
+          </p:cNvPr>
+          <p:cNvSpPr>
+            <a:spLocks xmlns:a="http://schemas.openxmlformats.org/drawingml/2006/main" noGrp="1"/>
+          </p:cNvSpPr>
+          <p:nvPr/>
+        </p:nvSpPr>
+        <p:spPr>
+          <a:xfrm xmlns:a="http://schemas.openxmlformats.org/drawingml/2006/main">
+            <a:off x="8743950" y="3314700"/>
             <a:ext cx="1428750" cy="333375"/>
           </a:xfrm>
           <a:prstGeom xmlns:a="http://schemas.openxmlformats.org/drawingml/2006/main" prst="rect">
@@ -16760,7 +16760,7 @@
                 <a:spcPct val="100000"/>
               </a:lnSpc>
               <a:buNone/>
-              <a:defRPr sz="1950" b="1">
+              <a:defRPr sz="1800" b="1">
                 <a:solidFill>
                   <a:srgbClr val="35D4B5"/>
                 </a:solidFill>
@@ -16770,7 +16770,7 @@
               </a:defRPr>
             </a:pPr>
             <a:r>
-              <a:rPr sz="1950" b="1">
+              <a:rPr sz="1800" b="1">
                 <a:solidFill>
                   <a:srgbClr val="35D4B5"/>
                 </a:solidFill>
@@ -16788,18 +16788,18 @@
           <p:cNvPr id="11" name="">
             <a:extLst xmlns:a="http://schemas.openxmlformats.org/drawingml/2006/main">
               <a:ext uri="{FF2B5EF4-FFF2-40B4-BE49-F238E27FC236}">
-                <a16:creationId xmlns:a16="http://schemas.microsoft.com/office/drawing/2014/main" id="{2DF594B6-AA30-4D41-9720-15B23B9B38D4}"/>
-              </a:ext>
-            </a:extLst>
-          </p:cNvPr>
-          <p:cNvSpPr>
-            <a:spLocks xmlns:a="http://schemas.openxmlformats.org/drawingml/2006/main" noGrp="1"/>
-          </p:cNvSpPr>
-          <p:nvPr/>
-        </p:nvSpPr>
-        <p:spPr>
-          <a:xfrm xmlns:a="http://schemas.openxmlformats.org/drawingml/2006/main">
-            <a:off x="10001250" y="3409950"/>
+                <a16:creationId xmlns:a16="http://schemas.microsoft.com/office/drawing/2014/main" id="{06F64E7C-5252-4D7F-9059-B1AC4FE1F0DA}"/>
+              </a:ext>
+            </a:extLst>
+          </p:cNvPr>
+          <p:cNvSpPr>
+            <a:spLocks xmlns:a="http://schemas.openxmlformats.org/drawingml/2006/main" noGrp="1"/>
+          </p:cNvSpPr>
+          <p:nvPr/>
+        </p:nvSpPr>
+        <p:spPr>
+          <a:xfrm xmlns:a="http://schemas.openxmlformats.org/drawingml/2006/main">
+            <a:off x="10001250" y="3352800"/>
             <a:ext cx="1581150" cy="285750"/>
           </a:xfrm>
           <a:prstGeom xmlns:a="http://schemas.openxmlformats.org/drawingml/2006/main" prst="rect">
@@ -16849,18 +16849,18 @@
           <p:cNvPr id="12" name="">
             <a:extLst xmlns:a="http://schemas.openxmlformats.org/drawingml/2006/main">
               <a:ext uri="{FF2B5EF4-FFF2-40B4-BE49-F238E27FC236}">
-                <a16:creationId xmlns:a16="http://schemas.microsoft.com/office/drawing/2014/main" id="{3D3DB077-AC9E-4EB8-913F-A794A98DE35D}"/>
-              </a:ext>
-            </a:extLst>
-          </p:cNvPr>
-          <p:cNvSpPr>
-            <a:spLocks xmlns:a="http://schemas.openxmlformats.org/drawingml/2006/main" noGrp="1"/>
-          </p:cNvSpPr>
-          <p:nvPr/>
-        </p:nvSpPr>
-        <p:spPr>
-          <a:xfrm xmlns:a="http://schemas.openxmlformats.org/drawingml/2006/main">
-            <a:off x="8743950" y="4152900"/>
+                <a16:creationId xmlns:a16="http://schemas.microsoft.com/office/drawing/2014/main" id="{C78F558F-AC1A-455E-ADAE-449B37E466EA}"/>
+              </a:ext>
+            </a:extLst>
+          </p:cNvPr>
+          <p:cNvSpPr>
+            <a:spLocks xmlns:a="http://schemas.openxmlformats.org/drawingml/2006/main" noGrp="1"/>
+          </p:cNvSpPr>
+          <p:nvPr/>
+        </p:nvSpPr>
+        <p:spPr>
+          <a:xfrm xmlns:a="http://schemas.openxmlformats.org/drawingml/2006/main">
+            <a:off x="8743950" y="3924300"/>
             <a:ext cx="1428750" cy="333375"/>
           </a:xfrm>
           <a:prstGeom xmlns:a="http://schemas.openxmlformats.org/drawingml/2006/main" prst="rect">
@@ -16882,7 +16882,7 @@
                 <a:spcPct val="100000"/>
               </a:lnSpc>
               <a:buNone/>
-              <a:defRPr sz="1950" b="1">
+              <a:defRPr sz="1800" b="1">
                 <a:solidFill>
                   <a:srgbClr val="5B91FF"/>
                 </a:solidFill>
@@ -16892,7 +16892,7 @@
               </a:defRPr>
             </a:pPr>
             <a:r>
-              <a:rPr sz="1950" b="1">
+              <a:rPr sz="1800" b="1">
                 <a:solidFill>
                   <a:srgbClr val="5B91FF"/>
                 </a:solidFill>
@@ -16900,7 +16900,7 @@
                 <a:ea typeface="Cascadia Mono"/>
                 <a:cs typeface="Cascadia Mono"/>
               </a:rPr>
-              <a:t>57,217</a:t>
+              <a:t>72,850</a:t>
             </a:r>
           </a:p>
         </p:txBody>
@@ -16910,18 +16910,18 @@
           <p:cNvPr id="13" name="">
             <a:extLst xmlns:a="http://schemas.openxmlformats.org/drawingml/2006/main">
               <a:ext uri="{FF2B5EF4-FFF2-40B4-BE49-F238E27FC236}">
-                <a16:creationId xmlns:a16="http://schemas.microsoft.com/office/drawing/2014/main" id="{4EB272F4-796B-44CD-B49C-AE81CF50D207}"/>
-              </a:ext>
-            </a:extLst>
-          </p:cNvPr>
-          <p:cNvSpPr>
-            <a:spLocks xmlns:a="http://schemas.openxmlformats.org/drawingml/2006/main" noGrp="1"/>
-          </p:cNvSpPr>
-          <p:nvPr/>
-        </p:nvSpPr>
-        <p:spPr>
-          <a:xfrm xmlns:a="http://schemas.openxmlformats.org/drawingml/2006/main">
-            <a:off x="10001250" y="4191000"/>
+                <a16:creationId xmlns:a16="http://schemas.microsoft.com/office/drawing/2014/main" id="{4325FBFA-8781-48F5-8887-7689B55C849D}"/>
+              </a:ext>
+            </a:extLst>
+          </p:cNvPr>
+          <p:cNvSpPr>
+            <a:spLocks xmlns:a="http://schemas.openxmlformats.org/drawingml/2006/main" noGrp="1"/>
+          </p:cNvSpPr>
+          <p:nvPr/>
+        </p:nvSpPr>
+        <p:spPr>
+          <a:xfrm xmlns:a="http://schemas.openxmlformats.org/drawingml/2006/main">
+            <a:off x="10001250" y="3962400"/>
             <a:ext cx="1581150" cy="285750"/>
           </a:xfrm>
           <a:prstGeom xmlns:a="http://schemas.openxmlformats.org/drawingml/2006/main" prst="rect">
@@ -16961,7 +16961,7 @@
                 <a:ea typeface="Arial"/>
                 <a:cs typeface="Arial"/>
               </a:rPr>
-              <a:t>רשומות Gold</a:t>
+              <a:t>נרות Gold</a:t>
             </a:r>
           </a:p>
         </p:txBody>
@@ -16971,18 +16971,18 @@
           <p:cNvPr id="14" name="">
             <a:extLst xmlns:a="http://schemas.openxmlformats.org/drawingml/2006/main">
               <a:ext uri="{FF2B5EF4-FFF2-40B4-BE49-F238E27FC236}">
-                <a16:creationId xmlns:a16="http://schemas.microsoft.com/office/drawing/2014/main" id="{E38A0A75-0C0C-48EC-8D1B-316D4BB2D5AA}"/>
-              </a:ext>
-            </a:extLst>
-          </p:cNvPr>
-          <p:cNvSpPr>
-            <a:spLocks xmlns:a="http://schemas.openxmlformats.org/drawingml/2006/main" noGrp="1"/>
-          </p:cNvSpPr>
-          <p:nvPr/>
-        </p:nvSpPr>
-        <p:spPr>
-          <a:xfrm xmlns:a="http://schemas.openxmlformats.org/drawingml/2006/main">
-            <a:off x="8743950" y="4933950"/>
+                <a16:creationId xmlns:a16="http://schemas.microsoft.com/office/drawing/2014/main" id="{F26D2D24-B63A-407F-9E65-B70BCE92C8A4}"/>
+              </a:ext>
+            </a:extLst>
+          </p:cNvPr>
+          <p:cNvSpPr>
+            <a:spLocks xmlns:a="http://schemas.openxmlformats.org/drawingml/2006/main" noGrp="1"/>
+          </p:cNvSpPr>
+          <p:nvPr/>
+        </p:nvSpPr>
+        <p:spPr>
+          <a:xfrm xmlns:a="http://schemas.openxmlformats.org/drawingml/2006/main">
+            <a:off x="8743950" y="4533900"/>
             <a:ext cx="1428750" cy="333375"/>
           </a:xfrm>
           <a:prstGeom xmlns:a="http://schemas.openxmlformats.org/drawingml/2006/main" prst="rect">
@@ -17004,7 +17004,129 @@
                 <a:spcPct val="100000"/>
               </a:lnSpc>
               <a:buNone/>
-              <a:defRPr sz="1950" b="1">
+              <a:defRPr sz="1800" b="1">
+                <a:solidFill>
+                  <a:srgbClr val="5B91FF"/>
+                </a:solidFill>
+                <a:latin typeface="Cascadia Mono"/>
+                <a:ea typeface="Cascadia Mono"/>
+                <a:cs typeface="Cascadia Mono"/>
+              </a:defRPr>
+            </a:pPr>
+            <a:r>
+              <a:rPr sz="1800" b="1">
+                <a:solidFill>
+                  <a:srgbClr val="5B91FF"/>
+                </a:solidFill>
+                <a:latin typeface="Cascadia Mono"/>
+                <a:ea typeface="Cascadia Mono"/>
+                <a:cs typeface="Cascadia Mono"/>
+              </a:rPr>
+              <a:t>65,616</a:t>
+            </a:r>
+          </a:p>
+        </p:txBody>
+      </p:sp>
+      <p:sp>
+        <p:nvSpPr>
+          <p:cNvPr id="15" name="">
+            <a:extLst xmlns:a="http://schemas.openxmlformats.org/drawingml/2006/main">
+              <a:ext uri="{FF2B5EF4-FFF2-40B4-BE49-F238E27FC236}">
+                <a16:creationId xmlns:a16="http://schemas.microsoft.com/office/drawing/2014/main" id="{6B22A782-8F70-4EF5-B56F-49377671F4AC}"/>
+              </a:ext>
+            </a:extLst>
+          </p:cNvPr>
+          <p:cNvSpPr>
+            <a:spLocks xmlns:a="http://schemas.openxmlformats.org/drawingml/2006/main" noGrp="1"/>
+          </p:cNvSpPr>
+          <p:nvPr/>
+        </p:nvSpPr>
+        <p:spPr>
+          <a:xfrm xmlns:a="http://schemas.openxmlformats.org/drawingml/2006/main">
+            <a:off x="10001250" y="4572000"/>
+            <a:ext cx="1581150" cy="285750"/>
+          </a:xfrm>
+          <a:prstGeom xmlns:a="http://schemas.openxmlformats.org/drawingml/2006/main" prst="rect">
+            <a:avLst/>
+          </a:prstGeom>
+          <a:noFill xmlns:a="http://schemas.openxmlformats.org/drawingml/2006/main"/>
+          <a:ln xmlns:a="http://schemas.openxmlformats.org/drawingml/2006/main" w="0">
+            <a:noFill/>
+          </a:ln>
+        </p:spPr>
+        <p:txBody>
+          <a:bodyPr xmlns:a="http://schemas.openxmlformats.org/drawingml/2006/main" wrap="square" lIns="0" tIns="0" rIns="0" bIns="0" anchor="t">
+            <a:normAutofit fontScale="100000"/>
+          </a:bodyPr>
+          <a:lstStyle xmlns:a="http://schemas.openxmlformats.org/drawingml/2006/main"/>
+          <a:p xmlns:a="http://schemas.openxmlformats.org/drawingml/2006/main">
+            <a:pPr algn="r" rtl="1">
+              <a:lnSpc>
+                <a:spcPct val="100000"/>
+              </a:lnSpc>
+              <a:buNone/>
+              <a:defRPr sz="1425" b="0" lang="he-IL">
+                <a:solidFill>
+                  <a:srgbClr val="9AB1C5"/>
+                </a:solidFill>
+                <a:latin typeface="Arial"/>
+                <a:ea typeface="Arial"/>
+                <a:cs typeface="Arial"/>
+              </a:defRPr>
+            </a:pPr>
+            <a:r>
+              <a:rPr sz="1425" b="0" lang="he-IL">
+                <a:solidFill>
+                  <a:srgbClr val="9AB1C5"/>
+                </a:solidFill>
+                <a:latin typeface="Arial"/>
+                <a:ea typeface="Arial"/>
+                <a:cs typeface="Arial"/>
+              </a:rPr>
+              <a:t>נרות Certified</a:t>
+            </a:r>
+          </a:p>
+        </p:txBody>
+      </p:sp>
+      <p:sp>
+        <p:nvSpPr>
+          <p:cNvPr id="16" name="">
+            <a:extLst xmlns:a="http://schemas.openxmlformats.org/drawingml/2006/main">
+              <a:ext uri="{FF2B5EF4-FFF2-40B4-BE49-F238E27FC236}">
+                <a16:creationId xmlns:a16="http://schemas.microsoft.com/office/drawing/2014/main" id="{D0C06A59-14F5-4BC5-AB43-BA4A7DDDB894}"/>
+              </a:ext>
+            </a:extLst>
+          </p:cNvPr>
+          <p:cNvSpPr>
+            <a:spLocks xmlns:a="http://schemas.openxmlformats.org/drawingml/2006/main" noGrp="1"/>
+          </p:cNvSpPr>
+          <p:nvPr/>
+        </p:nvSpPr>
+        <p:spPr>
+          <a:xfrm xmlns:a="http://schemas.openxmlformats.org/drawingml/2006/main">
+            <a:off x="8743950" y="5143500"/>
+            <a:ext cx="1428750" cy="333375"/>
+          </a:xfrm>
+          <a:prstGeom xmlns:a="http://schemas.openxmlformats.org/drawingml/2006/main" prst="rect">
+            <a:avLst/>
+          </a:prstGeom>
+          <a:noFill xmlns:a="http://schemas.openxmlformats.org/drawingml/2006/main"/>
+          <a:ln xmlns:a="http://schemas.openxmlformats.org/drawingml/2006/main" w="0">
+            <a:noFill/>
+          </a:ln>
+        </p:spPr>
+        <p:txBody>
+          <a:bodyPr xmlns:a="http://schemas.openxmlformats.org/drawingml/2006/main" wrap="square" lIns="0" tIns="0" rIns="0" bIns="0" anchor="t">
+            <a:normAutofit fontScale="100000"/>
+          </a:bodyPr>
+          <a:lstStyle xmlns:a="http://schemas.openxmlformats.org/drawingml/2006/main"/>
+          <a:p xmlns:a="http://schemas.openxmlformats.org/drawingml/2006/main">
+            <a:pPr algn="l">
+              <a:lnSpc>
+                <a:spcPct val="100000"/>
+              </a:lnSpc>
+              <a:buNone/>
+              <a:defRPr sz="1800" b="1">
                 <a:solidFill>
                   <a:srgbClr val="35D4B5"/>
                 </a:solidFill>
@@ -17014,7 +17136,7 @@
               </a:defRPr>
             </a:pPr>
             <a:r>
-              <a:rPr sz="1950" b="1">
+              <a:rPr sz="1800" b="1">
                 <a:solidFill>
                   <a:srgbClr val="35D4B5"/>
                 </a:solidFill>
@@ -17029,21 +17151,21 @@
       </p:sp>
       <p:sp>
         <p:nvSpPr>
-          <p:cNvPr id="15" name="">
-            <a:extLst xmlns:a="http://schemas.openxmlformats.org/drawingml/2006/main">
-              <a:ext uri="{FF2B5EF4-FFF2-40B4-BE49-F238E27FC236}">
-                <a16:creationId xmlns:a16="http://schemas.microsoft.com/office/drawing/2014/main" id="{516AD771-A57B-4F1A-B4B0-21382023B765}"/>
-              </a:ext>
-            </a:extLst>
-          </p:cNvPr>
-          <p:cNvSpPr>
-            <a:spLocks xmlns:a="http://schemas.openxmlformats.org/drawingml/2006/main" noGrp="1"/>
-          </p:cNvSpPr>
-          <p:nvPr/>
-        </p:nvSpPr>
-        <p:spPr>
-          <a:xfrm xmlns:a="http://schemas.openxmlformats.org/drawingml/2006/main">
-            <a:off x="10001250" y="4972050"/>
+          <p:cNvPr id="17" name="">
+            <a:extLst xmlns:a="http://schemas.openxmlformats.org/drawingml/2006/main">
+              <a:ext uri="{FF2B5EF4-FFF2-40B4-BE49-F238E27FC236}">
+                <a16:creationId xmlns:a16="http://schemas.microsoft.com/office/drawing/2014/main" id="{57BBA33D-6A3A-4EB0-B60C-BB850670E5FE}"/>
+              </a:ext>
+            </a:extLst>
+          </p:cNvPr>
+          <p:cNvSpPr>
+            <a:spLocks xmlns:a="http://schemas.openxmlformats.org/drawingml/2006/main" noGrp="1"/>
+          </p:cNvSpPr>
+          <p:nvPr/>
+        </p:nvSpPr>
+        <p:spPr>
+          <a:xfrm xmlns:a="http://schemas.openxmlformats.org/drawingml/2006/main">
+            <a:off x="10001250" y="5181600"/>
             <a:ext cx="1581150" cy="285750"/>
           </a:xfrm>
           <a:prstGeom xmlns:a="http://schemas.openxmlformats.org/drawingml/2006/main" prst="rect">
@@ -17083,7 +17205,7 @@
                 <a:ea typeface="Arial"/>
                 <a:cs typeface="Arial"/>
               </a:rPr>
-              <a:t>דיווחי SEC</a:t>
+              <a:t>רשומות SEC</a:t>
             </a:r>
           </a:p>
         </p:txBody>
@@ -17091,7 +17213,7 @@
     </p:spTree>
     <p:extLst>
       <p:ext uri="{BB962C8B-B14F-4D97-AF65-F5344CB8AC3E}">
-        <p14:creationId xmlns:p14="http://schemas.microsoft.com/office/powerpoint/2010/main" val="126305167"/>
+        <p14:creationId xmlns:p14="http://schemas.microsoft.com/office/powerpoint/2010/main" val="468008539"/>
       </p:ext>
     </p:extLst>
   </p:cSld>
@@ -17119,10 +17241,10 @@
       </p:grpSpPr>
       <p:sp>
         <p:nvSpPr>
-          <p:cNvPr id="20" name="">
-            <a:extLst xmlns:a="http://schemas.openxmlformats.org/drawingml/2006/main">
-              <a:ext uri="{FF2B5EF4-FFF2-40B4-BE49-F238E27FC236}">
-                <a16:creationId xmlns:a16="http://schemas.microsoft.com/office/drawing/2014/main" id="{1F7E09F4-1AD2-4883-AAB8-8A848D0245B8}"/>
+          <p:cNvPr id="21" name="">
+            <a:extLst xmlns:a="http://schemas.openxmlformats.org/drawingml/2006/main">
+              <a:ext uri="{FF2B5EF4-FFF2-40B4-BE49-F238E27FC236}">
+                <a16:creationId xmlns:a16="http://schemas.microsoft.com/office/drawing/2014/main" id="{F120A499-3116-4FE3-AFB3-71CCEDCFC31B}"/>
               </a:ext>
             </a:extLst>
           </p:cNvPr>
@@ -17152,7 +17274,7 @@
           <p:cNvPr id="2" name="">
             <a:extLst xmlns:a="http://schemas.openxmlformats.org/drawingml/2006/main">
               <a:ext uri="{FF2B5EF4-FFF2-40B4-BE49-F238E27FC236}">
-                <a16:creationId xmlns:a16="http://schemas.microsoft.com/office/drawing/2014/main" id="{C2AAEA7B-B41A-4490-9F86-9CEE527684D4}"/>
+                <a16:creationId xmlns:a16="http://schemas.microsoft.com/office/drawing/2014/main" id="{5C578608-7826-41A1-85CA-3FB48971EE2A}"/>
               </a:ext>
             </a:extLst>
           </p:cNvPr>
@@ -17213,7 +17335,7 @@
           <p:cNvPr id="3" name="">
             <a:extLst xmlns:a="http://schemas.openxmlformats.org/drawingml/2006/main">
               <a:ext uri="{FF2B5EF4-FFF2-40B4-BE49-F238E27FC236}">
-                <a16:creationId xmlns:a16="http://schemas.microsoft.com/office/drawing/2014/main" id="{37ECD0AB-FA4C-4955-A68C-A0C7320C19FB}"/>
+                <a16:creationId xmlns:a16="http://schemas.microsoft.com/office/drawing/2014/main" id="{A81E865C-D7D7-43F0-9044-13F63A20CC16}"/>
               </a:ext>
             </a:extLst>
           </p:cNvPr>
@@ -17264,7 +17386,7 @@
                 <a:ea typeface="Arial"/>
                 <a:cs typeface="Arial"/>
               </a:rPr>
-              <a:t>המלצה שמראה גם את הסיכון</a:t>
+              <a:t>החלטה שמפרידה בין ראיה, הסתברות וסיכון</a:t>
             </a:r>
           </a:p>
         </p:txBody>
@@ -17274,7 +17396,7 @@
           <p:cNvPr id="4" name="">
             <a:extLst xmlns:a="http://schemas.openxmlformats.org/drawingml/2006/main">
               <a:ext uri="{FF2B5EF4-FFF2-40B4-BE49-F238E27FC236}">
-                <a16:creationId xmlns:a16="http://schemas.microsoft.com/office/drawing/2014/main" id="{8E3535E6-8635-4FA7-83DC-2FDB6654E631}"/>
+                <a16:creationId xmlns:a16="http://schemas.microsoft.com/office/drawing/2014/main" id="{06D79530-B2AC-449D-BF8F-7F41385FFDA8}"/>
               </a:ext>
             </a:extLst>
           </p:cNvPr>
@@ -17335,7 +17457,7 @@
           <p:cNvPr id="5" name="">
             <a:extLst xmlns:a="http://schemas.openxmlformats.org/drawingml/2006/main">
               <a:ext uri="{FF2B5EF4-FFF2-40B4-BE49-F238E27FC236}">
-                <a16:creationId xmlns:a16="http://schemas.microsoft.com/office/drawing/2014/main" id="{1B4B0BF6-F3DD-4486-9C78-67C67F10D133}"/>
+                <a16:creationId xmlns:a16="http://schemas.microsoft.com/office/drawing/2014/main" id="{AA5F0764-2FE6-4DBE-9222-256766FC04AF}"/>
               </a:ext>
             </a:extLst>
           </p:cNvPr>
@@ -17363,15 +17485,15 @@
       </p:sp>
       <p:pic>
         <p:nvPicPr>
-          <p:cNvPr id="25" name=""/>
+          <p:cNvPr id="26" name=""/>
           <p:cNvPicPr>
             <a:picLocks xmlns:a="http://schemas.openxmlformats.org/drawingml/2006/main" noChangeAspect="1"/>
           </p:cNvPicPr>
           <p:nvPr/>
         </p:nvPicPr>
         <p:blipFill>
-          <a:blip xmlns:r="http://schemas.openxmlformats.org/officeDocument/2006/relationships" xmlns:a="http://schemas.openxmlformats.org/drawingml/2006/main" r:embed="R907a8f7a63db40fa"/>
-          <a:srcRect xmlns:a="http://schemas.openxmlformats.org/drawingml/2006/main" l="2553" t="0" r="2553" b="0"/>
+          <a:blip xmlns:r="http://schemas.openxmlformats.org/officeDocument/2006/relationships" xmlns:a="http://schemas.openxmlformats.org/drawingml/2006/main" r:embed="Reab10b23189f4080"/>
+          <a:srcRect xmlns:a="http://schemas.openxmlformats.org/drawingml/2006/main" l="0" t="2578" r="0" b="2578"/>
           <a:stretch xmlns:a="http://schemas.openxmlformats.org/drawingml/2006/main">
             <a:fillRect l="0" t="0" r="0" b="0"/>
           </a:stretch>
@@ -17393,7 +17515,7 @@
           <p:cNvPr id="7" name="">
             <a:extLst xmlns:a="http://schemas.openxmlformats.org/drawingml/2006/main">
               <a:ext uri="{FF2B5EF4-FFF2-40B4-BE49-F238E27FC236}">
-                <a16:creationId xmlns:a16="http://schemas.microsoft.com/office/drawing/2014/main" id="{A5D49015-65F4-4140-A565-75D713E17DDD}"/>
+                <a16:creationId xmlns:a16="http://schemas.microsoft.com/office/drawing/2014/main" id="{4F38D792-F814-47BF-A12A-858C8ACDF96B}"/>
               </a:ext>
             </a:extLst>
           </p:cNvPr>
@@ -17444,7 +17566,7 @@
                 <a:ea typeface="Arial"/>
                 <a:cs typeface="Arial"/>
               </a:rPr>
-              <a:t>לא מחיר קסם</a:t>
+              <a:t>שלוש שכבות שונות</a:t>
             </a:r>
           </a:p>
         </p:txBody>
@@ -17454,7 +17576,7 @@
           <p:cNvPr id="8" name="">
             <a:extLst xmlns:a="http://schemas.openxmlformats.org/drawingml/2006/main">
               <a:ext uri="{FF2B5EF4-FFF2-40B4-BE49-F238E27FC236}">
-                <a16:creationId xmlns:a16="http://schemas.microsoft.com/office/drawing/2014/main" id="{868A1A18-011C-45D9-9A67-1E0C8D51C45A}"/>
+                <a16:creationId xmlns:a16="http://schemas.microsoft.com/office/drawing/2014/main" id="{827B9068-C3A7-4525-8E3E-CE6F11DF2799}"/>
               </a:ext>
             </a:extLst>
           </p:cNvPr>
@@ -17505,7 +17627,7 @@
                 <a:ea typeface="Cascadia Mono"/>
                 <a:cs typeface="Cascadia Mono"/>
               </a:rPr>
-              <a:t>BUY ZONE</a:t>
+              <a:t>RULE SCORE</a:t>
             </a:r>
           </a:p>
         </p:txBody>
@@ -17515,7 +17637,7 @@
           <p:cNvPr id="9" name="">
             <a:extLst xmlns:a="http://schemas.openxmlformats.org/drawingml/2006/main">
               <a:ext uri="{FF2B5EF4-FFF2-40B4-BE49-F238E27FC236}">
-                <a16:creationId xmlns:a16="http://schemas.microsoft.com/office/drawing/2014/main" id="{975BB02A-F904-4884-A5F6-787151BDB96A}"/>
+                <a16:creationId xmlns:a16="http://schemas.microsoft.com/office/drawing/2014/main" id="{94B84358-1F5C-4AAB-87AE-AF90222D892C}"/>
               </a:ext>
             </a:extLst>
           </p:cNvPr>
@@ -17566,7 +17688,7 @@
                 <a:ea typeface="Arial"/>
                 <a:cs typeface="Arial"/>
               </a:rPr>
-              <a:t>טווח כניסה</a:t>
+              <a:t>מה הכללים תומכים</a:t>
             </a:r>
           </a:p>
         </p:txBody>
@@ -17576,7 +17698,7 @@
           <p:cNvPr id="10" name="">
             <a:extLst xmlns:a="http://schemas.openxmlformats.org/drawingml/2006/main">
               <a:ext uri="{FF2B5EF4-FFF2-40B4-BE49-F238E27FC236}">
-                <a16:creationId xmlns:a16="http://schemas.microsoft.com/office/drawing/2014/main" id="{7EB357AC-7C5D-45D5-B654-6A2E7AA249A2}"/>
+                <a16:creationId xmlns:a16="http://schemas.microsoft.com/office/drawing/2014/main" id="{61C57D3C-72B7-41F9-8377-4B65081AD0E5}"/>
               </a:ext>
             </a:extLst>
           </p:cNvPr>
@@ -17627,7 +17749,7 @@
                 <a:ea typeface="Cascadia Mono"/>
                 <a:cs typeface="Cascadia Mono"/>
               </a:rPr>
-              <a:t>STOP</a:t>
+              <a:t>MODEL PROBABILITY</a:t>
             </a:r>
           </a:p>
         </p:txBody>
@@ -17637,7 +17759,7 @@
           <p:cNvPr id="11" name="">
             <a:extLst xmlns:a="http://schemas.openxmlformats.org/drawingml/2006/main">
               <a:ext uri="{FF2B5EF4-FFF2-40B4-BE49-F238E27FC236}">
-                <a16:creationId xmlns:a16="http://schemas.microsoft.com/office/drawing/2014/main" id="{AFF28FF6-087D-41DC-B88C-9D5A8CA697DB}"/>
+                <a16:creationId xmlns:a16="http://schemas.microsoft.com/office/drawing/2014/main" id="{DEFDB20B-9F36-4091-B9A7-34C2D16BB90F}"/>
               </a:ext>
             </a:extLst>
           </p:cNvPr>
@@ -17688,7 +17810,7 @@
                 <a:ea typeface="Arial"/>
                 <a:cs typeface="Arial"/>
               </a:rPr>
-              <a:t>נקודת ביטול</a:t>
+              <a:t>רק לאחר אימון ואימות</a:t>
             </a:r>
           </a:p>
         </p:txBody>
@@ -17698,7 +17820,7 @@
           <p:cNvPr id="12" name="">
             <a:extLst xmlns:a="http://schemas.openxmlformats.org/drawingml/2006/main">
               <a:ext uri="{FF2B5EF4-FFF2-40B4-BE49-F238E27FC236}">
-                <a16:creationId xmlns:a16="http://schemas.microsoft.com/office/drawing/2014/main" id="{FFFE3CF1-86C2-40DE-A80E-21710B66D210}"/>
+                <a16:creationId xmlns:a16="http://schemas.microsoft.com/office/drawing/2014/main" id="{B80A0973-5478-456D-914D-1DABE6F48871}"/>
               </a:ext>
             </a:extLst>
           </p:cNvPr>
@@ -17749,7 +17871,7 @@
                 <a:ea typeface="Cascadia Mono"/>
                 <a:cs typeface="Cascadia Mono"/>
               </a:rPr>
-              <a:t>TARGET 1 / 2</a:t>
+              <a:t>DATA CONFIDENCE</a:t>
             </a:r>
           </a:p>
         </p:txBody>
@@ -17759,7 +17881,7 @@
           <p:cNvPr id="13" name="">
             <a:extLst xmlns:a="http://schemas.openxmlformats.org/drawingml/2006/main">
               <a:ext uri="{FF2B5EF4-FFF2-40B4-BE49-F238E27FC236}">
-                <a16:creationId xmlns:a16="http://schemas.microsoft.com/office/drawing/2014/main" id="{20C7F0B5-1839-4364-87C5-1026F973F65C}"/>
+                <a16:creationId xmlns:a16="http://schemas.microsoft.com/office/drawing/2014/main" id="{C00A22B0-DF40-4F1E-9FAD-F1ACC1D02C1E}"/>
               </a:ext>
             </a:extLst>
           </p:cNvPr>
@@ -17810,7 +17932,7 @@
                 <a:ea typeface="Arial"/>
                 <a:cs typeface="Arial"/>
               </a:rPr>
-              <a:t>שני תרחישי מימוש</a:t>
+              <a:t>איכות, כיסוי וטריות</a:t>
             </a:r>
           </a:p>
         </p:txBody>
@@ -17820,7 +17942,7 @@
           <p:cNvPr id="14" name="">
             <a:extLst xmlns:a="http://schemas.openxmlformats.org/drawingml/2006/main">
               <a:ext uri="{FF2B5EF4-FFF2-40B4-BE49-F238E27FC236}">
-                <a16:creationId xmlns:a16="http://schemas.microsoft.com/office/drawing/2014/main" id="{F533EC21-F47E-4298-BDCA-98040F2BA989}"/>
+                <a16:creationId xmlns:a16="http://schemas.microsoft.com/office/drawing/2014/main" id="{AFA73872-C3A2-4DAF-B153-00C1FA50B44D}"/>
               </a:ext>
             </a:extLst>
           </p:cNvPr>
@@ -17871,7 +17993,7 @@
                 <a:ea typeface="Cascadia Mono"/>
                 <a:cs typeface="Cascadia Mono"/>
               </a:rPr>
-              <a:t>RISK / REWARD</a:t>
+              <a:t>LEVELS + RISK</a:t>
             </a:r>
           </a:p>
         </p:txBody>
@@ -17881,7 +18003,7 @@
           <p:cNvPr id="15" name="">
             <a:extLst xmlns:a="http://schemas.openxmlformats.org/drawingml/2006/main">
               <a:ext uri="{FF2B5EF4-FFF2-40B4-BE49-F238E27FC236}">
-                <a16:creationId xmlns:a16="http://schemas.microsoft.com/office/drawing/2014/main" id="{148B2B85-DB37-4673-8610-CCA84D4B7D01}"/>
+                <a16:creationId xmlns:a16="http://schemas.microsoft.com/office/drawing/2014/main" id="{466123D5-AD74-4065-988E-DF00956E5A54}"/>
               </a:ext>
             </a:extLst>
           </p:cNvPr>
@@ -17932,7 +18054,7 @@
                 <a:ea typeface="Arial"/>
                 <a:cs typeface="Arial"/>
               </a:rPr>
-              <a:t>סיכון מול פוטנציאל</a:t>
+              <a:t>כניסה, ביטול ויעדים</a:t>
             </a:r>
           </a:p>
         </p:txBody>
@@ -17942,7 +18064,7 @@
           <p:cNvPr id="16" name="">
             <a:extLst xmlns:a="http://schemas.openxmlformats.org/drawingml/2006/main">
               <a:ext uri="{FF2B5EF4-FFF2-40B4-BE49-F238E27FC236}">
-                <a16:creationId xmlns:a16="http://schemas.microsoft.com/office/drawing/2014/main" id="{22E230D6-6216-4A83-83F5-34983D90FC44}"/>
+                <a16:creationId xmlns:a16="http://schemas.microsoft.com/office/drawing/2014/main" id="{096A507A-D13D-4CC6-9DDD-B3744DC9CF1D}"/>
               </a:ext>
             </a:extLst>
           </p:cNvPr>
@@ -17972,7 +18094,7 @@
           <p:cNvPr id="17" name="">
             <a:extLst xmlns:a="http://schemas.openxmlformats.org/drawingml/2006/main">
               <a:ext uri="{FF2B5EF4-FFF2-40B4-BE49-F238E27FC236}">
-                <a16:creationId xmlns:a16="http://schemas.microsoft.com/office/drawing/2014/main" id="{9E8B4689-4259-409D-81D7-C0C6C6383B3A}"/>
+                <a16:creationId xmlns:a16="http://schemas.microsoft.com/office/drawing/2014/main" id="{E349B7E0-BB12-464E-BAD0-B8E3F4ABBF42}"/>
               </a:ext>
             </a:extLst>
           </p:cNvPr>
@@ -18023,7 +18145,7 @@
                 <a:ea typeface="Cascadia Mono"/>
                 <a:cs typeface="Cascadia Mono"/>
               </a:rPr>
-              <a:t>1 / 20</a:t>
+              <a:t>2 / 20</a:t>
             </a:r>
           </a:p>
         </p:txBody>
@@ -18033,7 +18155,7 @@
           <p:cNvPr id="18" name="">
             <a:extLst xmlns:a="http://schemas.openxmlformats.org/drawingml/2006/main">
               <a:ext uri="{FF2B5EF4-FFF2-40B4-BE49-F238E27FC236}">
-                <a16:creationId xmlns:a16="http://schemas.microsoft.com/office/drawing/2014/main" id="{488B5C29-9D6C-40DB-8B7A-2768232867A7}"/>
+                <a16:creationId xmlns:a16="http://schemas.microsoft.com/office/drawing/2014/main" id="{F662E5D9-2A51-4A98-B250-22847001FCD8}"/>
               </a:ext>
             </a:extLst>
           </p:cNvPr>
@@ -18094,19 +18216,19 @@
           <p:cNvPr id="19" name="">
             <a:extLst xmlns:a="http://schemas.openxmlformats.org/drawingml/2006/main">
               <a:ext uri="{FF2B5EF4-FFF2-40B4-BE49-F238E27FC236}">
-                <a16:creationId xmlns:a16="http://schemas.microsoft.com/office/drawing/2014/main" id="{523FF695-B1E4-4633-BFA4-6C8C8638F394}"/>
-              </a:ext>
-            </a:extLst>
-          </p:cNvPr>
-          <p:cNvSpPr>
-            <a:spLocks xmlns:a="http://schemas.openxmlformats.org/drawingml/2006/main" noGrp="1"/>
-          </p:cNvSpPr>
-          <p:nvPr/>
-        </p:nvSpPr>
-        <p:spPr>
-          <a:xfrm xmlns:a="http://schemas.openxmlformats.org/drawingml/2006/main">
-            <a:off x="8763000" y="5619750"/>
-            <a:ext cx="2762250" cy="247650"/>
+                <a16:creationId xmlns:a16="http://schemas.microsoft.com/office/drawing/2014/main" id="{C325848E-2CEB-4B8D-837F-96B2A0136459}"/>
+              </a:ext>
+            </a:extLst>
+          </p:cNvPr>
+          <p:cNvSpPr>
+            <a:spLocks xmlns:a="http://schemas.openxmlformats.org/drawingml/2006/main" noGrp="1"/>
+          </p:cNvSpPr>
+          <p:nvPr/>
+        </p:nvSpPr>
+        <p:spPr>
+          <a:xfrm xmlns:a="http://schemas.openxmlformats.org/drawingml/2006/main">
+            <a:off x="8763000" y="5543550"/>
+            <a:ext cx="2762250" cy="228600"/>
           </a:xfrm>
           <a:prstGeom xmlns:a="http://schemas.openxmlformats.org/drawingml/2006/main" prst="rect">
             <a:avLst/>
@@ -18122,12 +18244,73 @@
           </a:bodyPr>
           <a:lstStyle xmlns:a="http://schemas.openxmlformats.org/drawingml/2006/main"/>
           <a:p xmlns:a="http://schemas.openxmlformats.org/drawingml/2006/main">
+            <a:pPr algn="l">
+              <a:lnSpc>
+                <a:spcPct val="100000"/>
+              </a:lnSpc>
+              <a:buNone/>
+              <a:defRPr sz="1125" b="1">
+                <a:solidFill>
+                  <a:srgbClr val="EF7484"/>
+                </a:solidFill>
+                <a:latin typeface="Cascadia Mono"/>
+                <a:ea typeface="Cascadia Mono"/>
+                <a:cs typeface="Cascadia Mono"/>
+              </a:defRPr>
+            </a:pPr>
+            <a:r>
+              <a:rPr sz="1125" b="1">
+                <a:solidFill>
+                  <a:srgbClr val="EF7484"/>
+                </a:solidFill>
+                <a:latin typeface="Cascadia Mono"/>
+                <a:ea typeface="Cascadia Mono"/>
+                <a:cs typeface="Cascadia Mono"/>
+              </a:rPr>
+              <a:t>V2 FALLBACK</a:t>
+            </a:r>
+          </a:p>
+        </p:txBody>
+      </p:sp>
+      <p:sp>
+        <p:nvSpPr>
+          <p:cNvPr id="20" name="">
+            <a:extLst xmlns:a="http://schemas.openxmlformats.org/drawingml/2006/main">
+              <a:ext uri="{FF2B5EF4-FFF2-40B4-BE49-F238E27FC236}">
+                <a16:creationId xmlns:a16="http://schemas.microsoft.com/office/drawing/2014/main" id="{DFE4F297-C310-4516-8287-77BB6C718A05}"/>
+              </a:ext>
+            </a:extLst>
+          </p:cNvPr>
+          <p:cNvSpPr>
+            <a:spLocks xmlns:a="http://schemas.openxmlformats.org/drawingml/2006/main" noGrp="1"/>
+          </p:cNvSpPr>
+          <p:nvPr/>
+        </p:nvSpPr>
+        <p:spPr>
+          <a:xfrm xmlns:a="http://schemas.openxmlformats.org/drawingml/2006/main">
+            <a:off x="8763000" y="5810250"/>
+            <a:ext cx="2762250" cy="228600"/>
+          </a:xfrm>
+          <a:prstGeom xmlns:a="http://schemas.openxmlformats.org/drawingml/2006/main" prst="rect">
+            <a:avLst/>
+          </a:prstGeom>
+          <a:noFill xmlns:a="http://schemas.openxmlformats.org/drawingml/2006/main"/>
+          <a:ln xmlns:a="http://schemas.openxmlformats.org/drawingml/2006/main" w="0">
+            <a:noFill/>
+          </a:ln>
+        </p:spPr>
+        <p:txBody>
+          <a:bodyPr xmlns:a="http://schemas.openxmlformats.org/drawingml/2006/main" wrap="square" lIns="0" tIns="0" rIns="0" bIns="0" anchor="t">
+            <a:normAutofit fontScale="100000"/>
+          </a:bodyPr>
+          <a:lstStyle xmlns:a="http://schemas.openxmlformats.org/drawingml/2006/main"/>
+          <a:p xmlns:a="http://schemas.openxmlformats.org/drawingml/2006/main">
             <a:pPr algn="r" rtl="1">
               <a:lnSpc>
                 <a:spcPct val="100000"/>
               </a:lnSpc>
               <a:buNone/>
-              <a:defRPr sz="1350" b="0" lang="he-IL">
+              <a:defRPr sz="1275" b="0" lang="he-IL">
                 <a:solidFill>
                   <a:srgbClr val="EF7484"/>
                 </a:solidFill>
@@ -18137,7 +18320,7 @@
               </a:defRPr>
             </a:pPr>
             <a:r>
-              <a:rPr sz="1350" b="0" lang="he-IL">
+              <a:rPr sz="1275" b="0" lang="he-IL">
                 <a:solidFill>
                   <a:srgbClr val="EF7484"/>
                 </a:solidFill>
@@ -18145,7 +18328,7 @@
                 <a:ea typeface="Arial"/>
                 <a:cs typeface="Arial"/>
               </a:rPr>
-              <a:t>אין פקודה, אין הבטחת תשואה</a:t>
+              <a:t>אין הסתברות מומצאת</a:t>
             </a:r>
           </a:p>
         </p:txBody>
@@ -18153,7 +18336,7 @@
     </p:spTree>
     <p:extLst>
       <p:ext uri="{BB962C8B-B14F-4D97-AF65-F5344CB8AC3E}">
-        <p14:creationId xmlns:p14="http://schemas.microsoft.com/office/powerpoint/2010/main" val="1698293141"/>
+        <p14:creationId xmlns:p14="http://schemas.microsoft.com/office/powerpoint/2010/main" val="272530501"/>
       </p:ext>
     </p:extLst>
   </p:cSld>
@@ -18184,7 +18367,7 @@
           <p:cNvPr id="16" name="">
             <a:extLst xmlns:a="http://schemas.openxmlformats.org/drawingml/2006/main">
               <a:ext uri="{FF2B5EF4-FFF2-40B4-BE49-F238E27FC236}">
-                <a16:creationId xmlns:a16="http://schemas.microsoft.com/office/drawing/2014/main" id="{8BC8BCDB-1807-4A6F-9E65-FA181A54CEE8}"/>
+                <a16:creationId xmlns:a16="http://schemas.microsoft.com/office/drawing/2014/main" id="{E0C6383D-675F-4247-AE05-A0B61C98B5E5}"/>
               </a:ext>
             </a:extLst>
           </p:cNvPr>
@@ -18214,7 +18397,7 @@
           <p:cNvPr id="2" name="">
             <a:extLst xmlns:a="http://schemas.openxmlformats.org/drawingml/2006/main">
               <a:ext uri="{FF2B5EF4-FFF2-40B4-BE49-F238E27FC236}">
-                <a16:creationId xmlns:a16="http://schemas.microsoft.com/office/drawing/2014/main" id="{948E5E7D-5492-481A-9B1F-F0C58E43AA44}"/>
+                <a16:creationId xmlns:a16="http://schemas.microsoft.com/office/drawing/2014/main" id="{1A902CA8-F3E1-4A2E-9320-56FA184F0AB3}"/>
               </a:ext>
             </a:extLst>
           </p:cNvPr>
@@ -18275,7 +18458,7 @@
           <p:cNvPr id="3" name="">
             <a:extLst xmlns:a="http://schemas.openxmlformats.org/drawingml/2006/main">
               <a:ext uri="{FF2B5EF4-FFF2-40B4-BE49-F238E27FC236}">
-                <a16:creationId xmlns:a16="http://schemas.microsoft.com/office/drawing/2014/main" id="{C34469FE-43DB-4468-8A40-AC07A23062EF}"/>
+                <a16:creationId xmlns:a16="http://schemas.microsoft.com/office/drawing/2014/main" id="{EBDC10C3-50F0-4C78-A2B1-CD7DEF08778F}"/>
               </a:ext>
             </a:extLst>
           </p:cNvPr>
@@ -18336,7 +18519,7 @@
           <p:cNvPr id="4" name="">
             <a:extLst xmlns:a="http://schemas.openxmlformats.org/drawingml/2006/main">
               <a:ext uri="{FF2B5EF4-FFF2-40B4-BE49-F238E27FC236}">
-                <a16:creationId xmlns:a16="http://schemas.microsoft.com/office/drawing/2014/main" id="{B22B50B9-1C0D-4839-81B0-5DA268EC13F9}"/>
+                <a16:creationId xmlns:a16="http://schemas.microsoft.com/office/drawing/2014/main" id="{DD88123C-639D-4EF2-94C0-E90C6859F195}"/>
               </a:ext>
             </a:extLst>
           </p:cNvPr>
@@ -18397,7 +18580,7 @@
           <p:cNvPr id="5" name="">
             <a:extLst xmlns:a="http://schemas.openxmlformats.org/drawingml/2006/main">
               <a:ext uri="{FF2B5EF4-FFF2-40B4-BE49-F238E27FC236}">
-                <a16:creationId xmlns:a16="http://schemas.microsoft.com/office/drawing/2014/main" id="{C6D7FDEC-0304-4E65-BD89-864004B3B6B8}"/>
+                <a16:creationId xmlns:a16="http://schemas.microsoft.com/office/drawing/2014/main" id="{D7B3513E-0B5F-4471-AD5B-ED5FC69EC23B}"/>
               </a:ext>
             </a:extLst>
           </p:cNvPr>
@@ -18432,8 +18615,8 @@
           <p:nvPr/>
         </p:nvPicPr>
         <p:blipFill>
-          <a:blip xmlns:r="http://schemas.openxmlformats.org/officeDocument/2006/relationships" xmlns:a="http://schemas.openxmlformats.org/drawingml/2006/main" r:embed="R2d9509c7d31b4c51"/>
-          <a:srcRect xmlns:a="http://schemas.openxmlformats.org/drawingml/2006/main" l="1389" t="0" r="1389" b="0"/>
+          <a:blip xmlns:r="http://schemas.openxmlformats.org/officeDocument/2006/relationships" xmlns:a="http://schemas.openxmlformats.org/drawingml/2006/main" r:embed="R32f8972aab244bc2"/>
+          <a:srcRect xmlns:a="http://schemas.openxmlformats.org/drawingml/2006/main" l="0" t="3714" r="0" b="3714"/>
           <a:stretch xmlns:a="http://schemas.openxmlformats.org/drawingml/2006/main">
             <a:fillRect l="0" t="0" r="0" b="0"/>
           </a:stretch>
@@ -18455,7 +18638,7 @@
           <p:cNvPr id="7" name="">
             <a:extLst xmlns:a="http://schemas.openxmlformats.org/drawingml/2006/main">
               <a:ext uri="{FF2B5EF4-FFF2-40B4-BE49-F238E27FC236}">
-                <a16:creationId xmlns:a16="http://schemas.microsoft.com/office/drawing/2014/main" id="{F44C5343-C019-402C-B06A-D7B7A13F951C}"/>
+                <a16:creationId xmlns:a16="http://schemas.microsoft.com/office/drawing/2014/main" id="{8C4C001B-6341-45A4-BF8C-53BCF241AB1D}"/>
               </a:ext>
             </a:extLst>
           </p:cNvPr>
@@ -18516,7 +18699,7 @@
           <p:cNvPr id="8" name="">
             <a:extLst xmlns:a="http://schemas.openxmlformats.org/drawingml/2006/main">
               <a:ext uri="{FF2B5EF4-FFF2-40B4-BE49-F238E27FC236}">
-                <a16:creationId xmlns:a16="http://schemas.microsoft.com/office/drawing/2014/main" id="{617133A3-C8D8-4BBB-B5BD-AC1891D3F123}"/>
+                <a16:creationId xmlns:a16="http://schemas.microsoft.com/office/drawing/2014/main" id="{3BCA77FC-DDC7-4B16-8806-637B5CF1A78F}"/>
               </a:ext>
             </a:extLst>
           </p:cNvPr>
@@ -18567,7 +18750,7 @@
                 <a:ea typeface="Cascadia Mono"/>
                 <a:cs typeface="Cascadia Mono"/>
               </a:rPr>
-              <a:t>41</a:t>
+              <a:t>53</a:t>
             </a:r>
           </a:p>
         </p:txBody>
@@ -18577,7 +18760,7 @@
           <p:cNvPr id="9" name="">
             <a:extLst xmlns:a="http://schemas.openxmlformats.org/drawingml/2006/main">
               <a:ext uri="{FF2B5EF4-FFF2-40B4-BE49-F238E27FC236}">
-                <a16:creationId xmlns:a16="http://schemas.microsoft.com/office/drawing/2014/main" id="{28FD6778-8A61-455B-B978-B9C83B5F465A}"/>
+                <a16:creationId xmlns:a16="http://schemas.microsoft.com/office/drawing/2014/main" id="{462375A7-B04F-44B2-8949-F17F6F3F78B0}"/>
               </a:ext>
             </a:extLst>
           </p:cNvPr>
@@ -18638,7 +18821,7 @@
           <p:cNvPr id="10" name="">
             <a:extLst xmlns:a="http://schemas.openxmlformats.org/drawingml/2006/main">
               <a:ext uri="{FF2B5EF4-FFF2-40B4-BE49-F238E27FC236}">
-                <a16:creationId xmlns:a16="http://schemas.microsoft.com/office/drawing/2014/main" id="{E1675DED-8A3A-4F69-A0DF-923FAAFDC78A}"/>
+                <a16:creationId xmlns:a16="http://schemas.microsoft.com/office/drawing/2014/main" id="{C894581B-2156-4BD0-A3B8-2079AAEB3110}"/>
               </a:ext>
             </a:extLst>
           </p:cNvPr>
@@ -18689,7 +18872,7 @@
                 <a:ea typeface="Cascadia Mono"/>
                 <a:cs typeface="Cascadia Mono"/>
               </a:rPr>
-              <a:t>46,749</a:t>
+              <a:t>11</a:t>
             </a:r>
           </a:p>
         </p:txBody>
@@ -18699,7 +18882,7 @@
           <p:cNvPr id="11" name="">
             <a:extLst xmlns:a="http://schemas.openxmlformats.org/drawingml/2006/main">
               <a:ext uri="{FF2B5EF4-FFF2-40B4-BE49-F238E27FC236}">
-                <a16:creationId xmlns:a16="http://schemas.microsoft.com/office/drawing/2014/main" id="{79BA765E-6E98-48B5-A1D5-F3765466BF7C}"/>
+                <a16:creationId xmlns:a16="http://schemas.microsoft.com/office/drawing/2014/main" id="{A298CEC2-1DAE-4E1A-9569-A1C1BC372010}"/>
               </a:ext>
             </a:extLst>
           </p:cNvPr>
@@ -18750,7 +18933,7 @@
                 <a:ea typeface="Arial"/>
                 <a:cs typeface="Arial"/>
               </a:rPr>
-              <a:t>תצפיות</a:t>
+              <a:t>ריצות מפורסמות</a:t>
             </a:r>
           </a:p>
         </p:txBody>
@@ -18760,7 +18943,7 @@
           <p:cNvPr id="12" name="">
             <a:extLst xmlns:a="http://schemas.openxmlformats.org/drawingml/2006/main">
               <a:ext uri="{FF2B5EF4-FFF2-40B4-BE49-F238E27FC236}">
-                <a16:creationId xmlns:a16="http://schemas.microsoft.com/office/drawing/2014/main" id="{D8FA3616-36A9-47CE-A2FB-4AD130501935}"/>
+                <a16:creationId xmlns:a16="http://schemas.microsoft.com/office/drawing/2014/main" id="{F10A1566-AC06-4A56-B74C-515BBADA9E21}"/>
               </a:ext>
             </a:extLst>
           </p:cNvPr>
@@ -18811,7 +18994,7 @@
                 <a:ea typeface="Cascadia Mono"/>
                 <a:cs typeface="Cascadia Mono"/>
               </a:rPr>
-              <a:t>1,059</a:t>
+              <a:t>65,616</a:t>
             </a:r>
           </a:p>
         </p:txBody>
@@ -18821,7 +19004,7 @@
           <p:cNvPr id="13" name="">
             <a:extLst xmlns:a="http://schemas.openxmlformats.org/drawingml/2006/main">
               <a:ext uri="{FF2B5EF4-FFF2-40B4-BE49-F238E27FC236}">
-                <a16:creationId xmlns:a16="http://schemas.microsoft.com/office/drawing/2014/main" id="{D1A55C5F-07EC-4AD5-8F17-F82C8E8DE46D}"/>
+                <a16:creationId xmlns:a16="http://schemas.microsoft.com/office/drawing/2014/main" id="{9782E964-4AAC-42A2-8DAE-A84563F6B710}"/>
               </a:ext>
             </a:extLst>
           </p:cNvPr>
@@ -18872,7 +19055,7 @@
                 <a:ea typeface="Arial"/>
                 <a:cs typeface="Arial"/>
               </a:rPr>
-              <a:t>שינויי פוזיציה</a:t>
+              <a:t>נרות Certified</a:t>
             </a:r>
           </a:p>
         </p:txBody>
@@ -18882,7 +19065,7 @@
           <p:cNvPr id="14" name="">
             <a:extLst xmlns:a="http://schemas.openxmlformats.org/drawingml/2006/main">
               <a:ext uri="{FF2B5EF4-FFF2-40B4-BE49-F238E27FC236}">
-                <a16:creationId xmlns:a16="http://schemas.microsoft.com/office/drawing/2014/main" id="{EB2230F8-8DB9-4F8F-8D45-6024F93F5191}"/>
+                <a16:creationId xmlns:a16="http://schemas.microsoft.com/office/drawing/2014/main" id="{29452129-7D1D-4F7F-BC48-22F213AAEFD5}"/>
               </a:ext>
             </a:extLst>
           </p:cNvPr>
@@ -18913,7 +19096,7 @@
           <p:cNvPr id="15" name="">
             <a:extLst xmlns:a="http://schemas.openxmlformats.org/drawingml/2006/main">
               <a:ext uri="{FF2B5EF4-FFF2-40B4-BE49-F238E27FC236}">
-                <a16:creationId xmlns:a16="http://schemas.microsoft.com/office/drawing/2014/main" id="{B83C5686-630A-4686-A7B2-4DD03FBEC63F}"/>
+                <a16:creationId xmlns:a16="http://schemas.microsoft.com/office/drawing/2014/main" id="{C5905195-8407-495A-A3E6-5EB4EC4DEC0D}"/>
               </a:ext>
             </a:extLst>
           </p:cNvPr>
@@ -18972,7 +19155,7 @@
     </p:spTree>
     <p:extLst>
       <p:ext uri="{BB962C8B-B14F-4D97-AF65-F5344CB8AC3E}">
-        <p14:creationId xmlns:p14="http://schemas.microsoft.com/office/powerpoint/2010/main" val="1326146906"/>
+        <p14:creationId xmlns:p14="http://schemas.microsoft.com/office/powerpoint/2010/main" val="1133595536"/>
       </p:ext>
     </p:extLst>
   </p:cSld>

</xml_diff>